<commit_message>
Sort api response by system for consistent output
</commit_message>
<xml_diff>
--- a/tests/report_generator/integration/references/reference_npr-5333-overview.pptx
+++ b/tests/report_generator/integration/references/reference_npr-5333-overview.pptx
@@ -1034,7 +1034,7 @@
                   <a:lstStyle/>
                   <a:p>
                     <a:r>
-                      <a:t>integrationtest-zuul</a:t>
+                      <a:t>integrationtest-airflow</a:t>
                     </a:r>
                   </a:p>
                 </c:rich>
@@ -1064,7 +1064,7 @@
                   <a:lstStyle/>
                   <a:p>
                     <a:r>
-                      <a:t>integrationtest-kafka</a:t>
+                      <a:t>integrationtest-bazel</a:t>
                     </a:r>
                   </a:p>
                 </c:rich>
@@ -1094,7 +1094,7 @@
                   <a:lstStyle/>
                   <a:p>
                     <a:r>
-                      <a:t>integrationtest-facebookyoga</a:t>
+                      <a:t>integrationtest-druid</a:t>
                     </a:r>
                   </a:p>
                 </c:rich>
@@ -1130,6 +1130,126 @@
                   <a:lstStyle/>
                   <a:p>
                     <a:r>
+                      <a:t>integrationtest-elasticsearch</a:t>
+                    </a:r>
+                  </a:p>
+                </c:rich>
+              </c:tx>
+              <c:dLblPos val="r"/>
+              <c:showLegendKey val="0"/>
+              <c:showVal val="0"/>
+              <c:showCatName val="0"/>
+              <c:showSerName val="0"/>
+              <c:showPercent val="0"/>
+              <c:showBubbleSize val="0"/>
+              <c:separator>; </c:separator>
+              <c:extLst>
+                <c:ext xmlns:c15="http://schemas.microsoft.com/office/drawing/2012/chart" uri="{CE6537A1-D6FC-4f65-9D91-7224C49458BB}">
+                  <c15:showDataLabelsRange val="1"/>
+                </c:ext>
+                <c:ext xmlns:c16="http://schemas.microsoft.com/office/drawing/2014/chart" uri="{C3380CC4-5D6E-409C-BE32-E72D297353CC}">
+                  <c16:uniqueId val="{00000003-33E4-2C4E-BF34-F4F568F22E82}"/>
+                </c:ext>
+              </c:extLst>
+            </c:dLbl>
+            <c:dLbl>
+              <c:idx val="4"/>
+              <c:tx>
+                <c:rich>
+                  <a:bodyPr/>
+                  <a:lstStyle/>
+                  <a:p>
+                    <a:r>
+                      <a:t>integrationtest-electron</a:t>
+                    </a:r>
+                  </a:p>
+                </c:rich>
+              </c:tx>
+              <c:dLblPos val="r"/>
+              <c:showLegendKey val="0"/>
+              <c:showVal val="0"/>
+              <c:showCatName val="0"/>
+              <c:showSerName val="0"/>
+              <c:showPercent val="0"/>
+              <c:showBubbleSize val="0"/>
+              <c:separator>; </c:separator>
+              <c:extLst>
+                <c:ext xmlns:c15="http://schemas.microsoft.com/office/drawing/2012/chart" uri="{CE6537A1-D6FC-4f65-9D91-7224C49458BB}">
+                  <c15:showDataLabelsRange val="1"/>
+                </c:ext>
+                <c:ext xmlns:c16="http://schemas.microsoft.com/office/drawing/2014/chart" uri="{C3380CC4-5D6E-409C-BE32-E72D297353CC}">
+                  <c16:uniqueId val="{00000004-33E4-2C4E-BF34-F4F568F22E82}"/>
+                </c:ext>
+              </c:extLst>
+            </c:dLbl>
+            <c:dLbl>
+              <c:idx val="5"/>
+              <c:tx>
+                <c:rich>
+                  <a:bodyPr/>
+                  <a:lstStyle/>
+                  <a:p>
+                    <a:r>
+                      <a:t>integrationtest-facebookyoga</a:t>
+                    </a:r>
+                  </a:p>
+                </c:rich>
+              </c:tx>
+              <c:dLblPos val="r"/>
+              <c:showLegendKey val="0"/>
+              <c:showVal val="0"/>
+              <c:showCatName val="0"/>
+              <c:showSerName val="0"/>
+              <c:showPercent val="0"/>
+              <c:showBubbleSize val="0"/>
+              <c:separator>; </c:separator>
+              <c:extLst>
+                <c:ext xmlns:c15="http://schemas.microsoft.com/office/drawing/2012/chart" uri="{CE6537A1-D6FC-4f65-9D91-7224C49458BB}">
+                  <c15:showDataLabelsRange val="1"/>
+                </c:ext>
+                <c:ext xmlns:c16="http://schemas.microsoft.com/office/drawing/2014/chart" uri="{C3380CC4-5D6E-409C-BE32-E72D297353CC}">
+                  <c16:uniqueId val="{00000005-33E4-2C4E-BF34-F4F568F22E82}"/>
+                </c:ext>
+              </c:extLst>
+            </c:dLbl>
+            <c:dLbl>
+              <c:idx val="6"/>
+              <c:tx>
+                <c:rich>
+                  <a:bodyPr/>
+                  <a:lstStyle/>
+                  <a:p>
+                    <a:r>
+                      <a:t>integrationtest-git</a:t>
+                    </a:r>
+                  </a:p>
+                </c:rich>
+              </c:tx>
+              <c:dLblPos val="r"/>
+              <c:showLegendKey val="0"/>
+              <c:showVal val="0"/>
+              <c:showCatName val="0"/>
+              <c:showSerName val="0"/>
+              <c:showPercent val="0"/>
+              <c:showBubbleSize val="0"/>
+              <c:separator>; </c:separator>
+              <c:extLst>
+                <c:ext xmlns:c15="http://schemas.microsoft.com/office/drawing/2012/chart" uri="{CE6537A1-D6FC-4f65-9D91-7224C49458BB}">
+                  <c15:showDataLabelsRange val="1"/>
+                </c:ext>
+                <c:ext xmlns:c16="http://schemas.microsoft.com/office/drawing/2014/chart" uri="{C3380CC4-5D6E-409C-BE32-E72D297353CC}">
+                  <c16:uniqueId val="{00000006-33E4-2C4E-BF34-F4F568F22E82}"/>
+                </c:ext>
+              </c:extLst>
+            </c:dLbl>
+            <c:dLbl>
+              <c:idx val="7"/>
+              <c:tx>
+                <c:rich>
+                  <a:bodyPr/>
+                  <a:lstStyle/>
+                  <a:p>
+                    <a:r>
                       <a:t>integrationtest-jruby</a:t>
                     </a:r>
                   </a:p>
@@ -1148,19 +1268,19 @@
                   <c15:showDataLabelsRange val="1"/>
                 </c:ext>
                 <c:ext xmlns:c16="http://schemas.microsoft.com/office/drawing/2014/chart" uri="{C3380CC4-5D6E-409C-BE32-E72D297353CC}">
-                  <c16:uniqueId val="{00000003-33E4-2C4E-BF34-F4F568F22E82}"/>
-                </c:ext>
-              </c:extLst>
-            </c:dLbl>
-            <c:dLbl>
-              <c:idx val="4"/>
-              <c:tx>
-                <c:rich>
-                  <a:bodyPr/>
-                  <a:lstStyle/>
-                  <a:p>
-                    <a:r>
-                      <a:t>integrationtest-bazel</a:t>
+                  <c16:uniqueId val="{00000007-33E4-2C4E-BF34-F4F568F22E82}"/>
+                </c:ext>
+              </c:extLst>
+            </c:dLbl>
+            <c:dLbl>
+              <c:idx val="8"/>
+              <c:tx>
+                <c:rich>
+                  <a:bodyPr/>
+                  <a:lstStyle/>
+                  <a:p>
+                    <a:r>
+                      <a:t>integrationtest-kafka</a:t>
                     </a:r>
                   </a:p>
                 </c:rich>
@@ -1178,19 +1298,19 @@
                   <c15:showDataLabelsRange val="1"/>
                 </c:ext>
                 <c:ext xmlns:c16="http://schemas.microsoft.com/office/drawing/2014/chart" uri="{C3380CC4-5D6E-409C-BE32-E72D297353CC}">
-                  <c16:uniqueId val="{00000004-33E4-2C4E-BF34-F4F568F22E82}"/>
-                </c:ext>
-              </c:extLst>
-            </c:dLbl>
-            <c:dLbl>
-              <c:idx val="5"/>
-              <c:tx>
-                <c:rich>
-                  <a:bodyPr/>
-                  <a:lstStyle/>
-                  <a:p>
-                    <a:r>
-                      <a:t>integrationtest-electron</a:t>
+                  <c16:uniqueId val="{00000008-33E4-2C4E-BF34-F4F568F22E82}"/>
+                </c:ext>
+              </c:extLst>
+            </c:dLbl>
+            <c:dLbl>
+              <c:idx val="9"/>
+              <c:tx>
+                <c:rich>
+                  <a:bodyPr/>
+                  <a:lstStyle/>
+                  <a:p>
+                    <a:r>
+                      <a:t>integrationtest-vscode</a:t>
                     </a:r>
                   </a:p>
                 </c:rich>
@@ -1208,102 +1328,12 @@
                   <c15:showDataLabelsRange val="1"/>
                 </c:ext>
                 <c:ext xmlns:c16="http://schemas.microsoft.com/office/drawing/2014/chart" uri="{C3380CC4-5D6E-409C-BE32-E72D297353CC}">
-                  <c16:uniqueId val="{00000005-33E4-2C4E-BF34-F4F568F22E82}"/>
-                </c:ext>
-              </c:extLst>
-            </c:dLbl>
-            <c:dLbl>
-              <c:idx val="6"/>
-              <c:tx>
-                <c:rich>
-                  <a:bodyPr/>
-                  <a:lstStyle/>
-                  <a:p>
-                    <a:r>
-                      <a:t>integrationtest-airflow</a:t>
-                    </a:r>
-                  </a:p>
-                </c:rich>
-              </c:tx>
-              <c:dLblPos val="r"/>
-              <c:showLegendKey val="0"/>
-              <c:showVal val="0"/>
-              <c:showCatName val="0"/>
-              <c:showSerName val="0"/>
-              <c:showPercent val="0"/>
-              <c:showBubbleSize val="0"/>
-              <c:separator>; </c:separator>
-              <c:extLst>
-                <c:ext xmlns:c15="http://schemas.microsoft.com/office/drawing/2012/chart" uri="{CE6537A1-D6FC-4f65-9D91-7224C49458BB}">
-                  <c15:showDataLabelsRange val="1"/>
-                </c:ext>
-                <c:ext xmlns:c16="http://schemas.microsoft.com/office/drawing/2014/chart" uri="{C3380CC4-5D6E-409C-BE32-E72D297353CC}">
-                  <c16:uniqueId val="{00000006-33E4-2C4E-BF34-F4F568F22E82}"/>
-                </c:ext>
-              </c:extLst>
-            </c:dLbl>
-            <c:dLbl>
-              <c:idx val="7"/>
-              <c:tx>
-                <c:rich>
-                  <a:bodyPr/>
-                  <a:lstStyle/>
-                  <a:p>
-                    <a:r>
-                      <a:t>integrationtest-git</a:t>
-                    </a:r>
-                  </a:p>
-                </c:rich>
-              </c:tx>
-              <c:dLblPos val="r"/>
-              <c:showLegendKey val="0"/>
-              <c:showVal val="0"/>
-              <c:showCatName val="0"/>
-              <c:showSerName val="0"/>
-              <c:showPercent val="0"/>
-              <c:showBubbleSize val="0"/>
-              <c:separator>; </c:separator>
-              <c:extLst>
-                <c:ext xmlns:c15="http://schemas.microsoft.com/office/drawing/2012/chart" uri="{CE6537A1-D6FC-4f65-9D91-7224C49458BB}">
-                  <c15:showDataLabelsRange val="1"/>
-                </c:ext>
-                <c:ext xmlns:c16="http://schemas.microsoft.com/office/drawing/2014/chart" uri="{C3380CC4-5D6E-409C-BE32-E72D297353CC}">
-                  <c16:uniqueId val="{00000007-33E4-2C4E-BF34-F4F568F22E82}"/>
-                </c:ext>
-              </c:extLst>
-            </c:dLbl>
-            <c:dLbl>
-              <c:idx val="8"/>
-              <c:tx>
-                <c:rich>
-                  <a:bodyPr/>
-                  <a:lstStyle/>
-                  <a:p>
-                    <a:r>
-                      <a:t>integrationtest-vscode</a:t>
-                    </a:r>
-                  </a:p>
-                </c:rich>
-              </c:tx>
-              <c:dLblPos val="r"/>
-              <c:showLegendKey val="0"/>
-              <c:showVal val="0"/>
-              <c:showCatName val="0"/>
-              <c:showSerName val="0"/>
-              <c:showPercent val="0"/>
-              <c:showBubbleSize val="0"/>
-              <c:separator>; </c:separator>
-              <c:extLst>
-                <c:ext xmlns:c15="http://schemas.microsoft.com/office/drawing/2012/chart" uri="{CE6537A1-D6FC-4f65-9D91-7224C49458BB}">
-                  <c15:showDataLabelsRange val="1"/>
-                </c:ext>
-                <c:ext xmlns:c16="http://schemas.microsoft.com/office/drawing/2014/chart" uri="{C3380CC4-5D6E-409C-BE32-E72D297353CC}">
-                  <c16:uniqueId val="{00000008-33E4-2C4E-BF34-F4F568F22E82}"/>
-                </c:ext>
-              </c:extLst>
-            </c:dLbl>
-            <c:dLbl>
-              <c:idx val="9"/>
+                  <c16:uniqueId val="{00000009-33E4-2C4E-BF34-F4F568F22E82}"/>
+                </c:ext>
+              </c:extLst>
+            </c:dLbl>
+            <c:dLbl>
+              <c:idx val="10"/>
               <c:tx>
                 <c:rich>
                   <a:bodyPr/>
@@ -1315,36 +1345,6 @@
                   </a:p>
                 </c:rich>
               </c:tx>
-              <c:dLblPos val="r"/>
-              <c:showLegendKey val="0"/>
-              <c:showVal val="0"/>
-              <c:showCatName val="0"/>
-              <c:showSerName val="0"/>
-              <c:showPercent val="0"/>
-              <c:showBubbleSize val="0"/>
-              <c:separator>; </c:separator>
-              <c:extLst>
-                <c:ext xmlns:c15="http://schemas.microsoft.com/office/drawing/2012/chart" uri="{CE6537A1-D6FC-4f65-9D91-7224C49458BB}">
-                  <c15:showDataLabelsRange val="1"/>
-                </c:ext>
-                <c:ext xmlns:c16="http://schemas.microsoft.com/office/drawing/2014/chart" uri="{C3380CC4-5D6E-409C-BE32-E72D297353CC}">
-                  <c16:uniqueId val="{00000009-33E4-2C4E-BF34-F4F568F22E82}"/>
-                </c:ext>
-              </c:extLst>
-            </c:dLbl>
-            <c:dLbl>
-              <c:idx val="10"/>
-              <c:tx>
-                <c:rich>
-                  <a:bodyPr/>
-                  <a:lstStyle/>
-                  <a:p>
-                    <a:r>
-                      <a:t>integrationtest-elasticsearch</a:t>
-                    </a:r>
-                  </a:p>
-                </c:rich>
-              </c:tx>
               <c:showLegendKey val="0"/>
               <c:showVal val="1"/>
               <c:showCatName val="0"/>
@@ -1368,7 +1368,7 @@
                   <a:lstStyle/>
                   <a:p>
                     <a:r>
-                      <a:t>integrationtest-druid</a:t>
+                      <a:t>integrationtest-zuul</a:t>
                     </a:r>
                   </a:p>
                 </c:rich>
@@ -3785,40 +3785,40 @@
                 <c:formatCode>General</c:formatCode>
                 <c:ptCount val="12"/>
                 <c:pt idx="0">
-                  <c:v>6</c:v>
+                  <c:v>431</c:v>
                 </c:pt>
                 <c:pt idx="1">
+                  <c:v>16</c:v>
+                </c:pt>
+                <c:pt idx="2">
+                  <c:v>96</c:v>
+                </c:pt>
+                <c:pt idx="3">
+                  <c:v>19</c:v>
+                </c:pt>
+                <c:pt idx="4">
+                  <c:v>34</c:v>
+                </c:pt>
+                <c:pt idx="5">
+                  <c:v>0</c:v>
+                </c:pt>
+                <c:pt idx="6">
+                  <c:v>1550</c:v>
+                </c:pt>
+                <c:pt idx="7">
+                  <c:v>114</c:v>
+                </c:pt>
+                <c:pt idx="8">
                   <c:v>56</c:v>
                 </c:pt>
-                <c:pt idx="2">
-                  <c:v>0</c:v>
-                </c:pt>
-                <c:pt idx="3">
-                  <c:v>114</c:v>
-                </c:pt>
-                <c:pt idx="4">
-                  <c:v>16</c:v>
-                </c:pt>
-                <c:pt idx="5">
-                  <c:v>34</c:v>
-                </c:pt>
-                <c:pt idx="6">
-                  <c:v>431</c:v>
-                </c:pt>
-                <c:pt idx="7">
-                  <c:v>1550</c:v>
-                </c:pt>
-                <c:pt idx="8">
+                <c:pt idx="9">
                   <c:v>70</c:v>
                 </c:pt>
-                <c:pt idx="9">
+                <c:pt idx="10">
                   <c:v>5</c:v>
                 </c:pt>
-                <c:pt idx="10">
-                  <c:v>19</c:v>
-                </c:pt>
                 <c:pt idx="11">
-                  <c:v>96</c:v>
+                  <c:v>6</c:v>
                 </c:pt>
               </c:numCache>
             </c:numRef>
@@ -3830,40 +3830,40 @@
                 <c:formatCode>General</c:formatCode>
                 <c:ptCount val="12"/>
                 <c:pt idx="0">
-                  <c:v>3.3</c:v>
+                  <c:v>2.1</c:v>
                 </c:pt>
                 <c:pt idx="1">
-                  <c:v>2.0</c:v>
+                  <c:v>2.4</c:v>
                 </c:pt>
                 <c:pt idx="2">
-                  <c:v>5.5</c:v>
+                  <c:v>1.9</c:v>
                 </c:pt>
                 <c:pt idx="3">
-                  <c:v>1.7</c:v>
+                  <c:v>1.5</c:v>
                 </c:pt>
                 <c:pt idx="4">
                   <c:v>2.4</c:v>
                 </c:pt>
                 <c:pt idx="5">
-                  <c:v>2.4</c:v>
+                  <c:v>5.5</c:v>
                 </c:pt>
                 <c:pt idx="6">
+                  <c:v>2.6</c:v>
+                </c:pt>
+                <c:pt idx="7">
+                  <c:v>1.7</c:v>
+                </c:pt>
+                <c:pt idx="8">
+                  <c:v>2.0</c:v>
+                </c:pt>
+                <c:pt idx="9">
                   <c:v>2.1</c:v>
                 </c:pt>
-                <c:pt idx="7">
-                  <c:v>2.6</c:v>
-                </c:pt>
-                <c:pt idx="8">
-                  <c:v>2.1</c:v>
-                </c:pt>
-                <c:pt idx="9">
+                <c:pt idx="10">
                   <c:v>3.1</c:v>
                 </c:pt>
-                <c:pt idx="10">
-                  <c:v>1.5</c:v>
-                </c:pt>
                 <c:pt idx="11">
-                  <c:v>1.9</c:v>
+                  <c:v>3.3</c:v>
                 </c:pt>
               </c:numCache>
             </c:numRef>
@@ -4143,7 +4143,7 @@
                   <a:lstStyle/>
                   <a:p>
                     <a:r>
-                      <a:t>integrationtest-zuul</a:t>
+                      <a:t>integrationtest-airflow</a:t>
                     </a:r>
                   </a:p>
                 </c:rich>
@@ -4173,7 +4173,7 @@
                   <a:lstStyle/>
                   <a:p>
                     <a:r>
-                      <a:t>integrationtest-kafka</a:t>
+                      <a:t>integrationtest-bazel</a:t>
                     </a:r>
                   </a:p>
                 </c:rich>
@@ -4203,7 +4203,7 @@
                   <a:lstStyle/>
                   <a:p>
                     <a:r>
-                      <a:t>integrationtest-facebookyoga</a:t>
+                      <a:t>integrationtest-druid</a:t>
                     </a:r>
                   </a:p>
                 </c:rich>
@@ -4239,6 +4239,126 @@
                   <a:lstStyle/>
                   <a:p>
                     <a:r>
+                      <a:t>integrationtest-elasticsearch</a:t>
+                    </a:r>
+                  </a:p>
+                </c:rich>
+              </c:tx>
+              <c:dLblPos val="r"/>
+              <c:showLegendKey val="0"/>
+              <c:showVal val="0"/>
+              <c:showCatName val="0"/>
+              <c:showSerName val="0"/>
+              <c:showPercent val="0"/>
+              <c:showBubbleSize val="0"/>
+              <c:separator>; </c:separator>
+              <c:extLst>
+                <c:ext xmlns:c15="http://schemas.microsoft.com/office/drawing/2012/chart" uri="{CE6537A1-D6FC-4f65-9D91-7224C49458BB}">
+                  <c15:showDataLabelsRange val="1"/>
+                </c:ext>
+                <c:ext xmlns:c16="http://schemas.microsoft.com/office/drawing/2014/chart" uri="{C3380CC4-5D6E-409C-BE32-E72D297353CC}">
+                  <c16:uniqueId val="{00000003-33E4-2C4E-BF34-F4F568F22E82}"/>
+                </c:ext>
+              </c:extLst>
+            </c:dLbl>
+            <c:dLbl>
+              <c:idx val="4"/>
+              <c:tx>
+                <c:rich>
+                  <a:bodyPr/>
+                  <a:lstStyle/>
+                  <a:p>
+                    <a:r>
+                      <a:t>integrationtest-electron</a:t>
+                    </a:r>
+                  </a:p>
+                </c:rich>
+              </c:tx>
+              <c:dLblPos val="r"/>
+              <c:showLegendKey val="0"/>
+              <c:showVal val="0"/>
+              <c:showCatName val="0"/>
+              <c:showSerName val="0"/>
+              <c:showPercent val="0"/>
+              <c:showBubbleSize val="0"/>
+              <c:separator>; </c:separator>
+              <c:extLst>
+                <c:ext xmlns:c15="http://schemas.microsoft.com/office/drawing/2012/chart" uri="{CE6537A1-D6FC-4f65-9D91-7224C49458BB}">
+                  <c15:showDataLabelsRange val="1"/>
+                </c:ext>
+                <c:ext xmlns:c16="http://schemas.microsoft.com/office/drawing/2014/chart" uri="{C3380CC4-5D6E-409C-BE32-E72D297353CC}">
+                  <c16:uniqueId val="{00000004-33E4-2C4E-BF34-F4F568F22E82}"/>
+                </c:ext>
+              </c:extLst>
+            </c:dLbl>
+            <c:dLbl>
+              <c:idx val="5"/>
+              <c:tx>
+                <c:rich>
+                  <a:bodyPr/>
+                  <a:lstStyle/>
+                  <a:p>
+                    <a:r>
+                      <a:t>integrationtest-facebookyoga</a:t>
+                    </a:r>
+                  </a:p>
+                </c:rich>
+              </c:tx>
+              <c:dLblPos val="r"/>
+              <c:showLegendKey val="0"/>
+              <c:showVal val="0"/>
+              <c:showCatName val="0"/>
+              <c:showSerName val="0"/>
+              <c:showPercent val="0"/>
+              <c:showBubbleSize val="0"/>
+              <c:separator>; </c:separator>
+              <c:extLst>
+                <c:ext xmlns:c15="http://schemas.microsoft.com/office/drawing/2012/chart" uri="{CE6537A1-D6FC-4f65-9D91-7224C49458BB}">
+                  <c15:showDataLabelsRange val="1"/>
+                </c:ext>
+                <c:ext xmlns:c16="http://schemas.microsoft.com/office/drawing/2014/chart" uri="{C3380CC4-5D6E-409C-BE32-E72D297353CC}">
+                  <c16:uniqueId val="{00000005-33E4-2C4E-BF34-F4F568F22E82}"/>
+                </c:ext>
+              </c:extLst>
+            </c:dLbl>
+            <c:dLbl>
+              <c:idx val="6"/>
+              <c:tx>
+                <c:rich>
+                  <a:bodyPr/>
+                  <a:lstStyle/>
+                  <a:p>
+                    <a:r>
+                      <a:t>integrationtest-git</a:t>
+                    </a:r>
+                  </a:p>
+                </c:rich>
+              </c:tx>
+              <c:dLblPos val="r"/>
+              <c:showLegendKey val="0"/>
+              <c:showVal val="0"/>
+              <c:showCatName val="0"/>
+              <c:showSerName val="0"/>
+              <c:showPercent val="0"/>
+              <c:showBubbleSize val="0"/>
+              <c:separator>; </c:separator>
+              <c:extLst>
+                <c:ext xmlns:c15="http://schemas.microsoft.com/office/drawing/2012/chart" uri="{CE6537A1-D6FC-4f65-9D91-7224C49458BB}">
+                  <c15:showDataLabelsRange val="1"/>
+                </c:ext>
+                <c:ext xmlns:c16="http://schemas.microsoft.com/office/drawing/2014/chart" uri="{C3380CC4-5D6E-409C-BE32-E72D297353CC}">
+                  <c16:uniqueId val="{00000006-33E4-2C4E-BF34-F4F568F22E82}"/>
+                </c:ext>
+              </c:extLst>
+            </c:dLbl>
+            <c:dLbl>
+              <c:idx val="7"/>
+              <c:tx>
+                <c:rich>
+                  <a:bodyPr/>
+                  <a:lstStyle/>
+                  <a:p>
+                    <a:r>
                       <a:t>integrationtest-jruby</a:t>
                     </a:r>
                   </a:p>
@@ -4257,19 +4377,19 @@
                   <c15:showDataLabelsRange val="1"/>
                 </c:ext>
                 <c:ext xmlns:c16="http://schemas.microsoft.com/office/drawing/2014/chart" uri="{C3380CC4-5D6E-409C-BE32-E72D297353CC}">
-                  <c16:uniqueId val="{00000003-33E4-2C4E-BF34-F4F568F22E82}"/>
-                </c:ext>
-              </c:extLst>
-            </c:dLbl>
-            <c:dLbl>
-              <c:idx val="4"/>
-              <c:tx>
-                <c:rich>
-                  <a:bodyPr/>
-                  <a:lstStyle/>
-                  <a:p>
-                    <a:r>
-                      <a:t>integrationtest-bazel</a:t>
+                  <c16:uniqueId val="{00000007-33E4-2C4E-BF34-F4F568F22E82}"/>
+                </c:ext>
+              </c:extLst>
+            </c:dLbl>
+            <c:dLbl>
+              <c:idx val="8"/>
+              <c:tx>
+                <c:rich>
+                  <a:bodyPr/>
+                  <a:lstStyle/>
+                  <a:p>
+                    <a:r>
+                      <a:t>integrationtest-kafka</a:t>
                     </a:r>
                   </a:p>
                 </c:rich>
@@ -4287,19 +4407,19 @@
                   <c15:showDataLabelsRange val="1"/>
                 </c:ext>
                 <c:ext xmlns:c16="http://schemas.microsoft.com/office/drawing/2014/chart" uri="{C3380CC4-5D6E-409C-BE32-E72D297353CC}">
-                  <c16:uniqueId val="{00000004-33E4-2C4E-BF34-F4F568F22E82}"/>
-                </c:ext>
-              </c:extLst>
-            </c:dLbl>
-            <c:dLbl>
-              <c:idx val="5"/>
-              <c:tx>
-                <c:rich>
-                  <a:bodyPr/>
-                  <a:lstStyle/>
-                  <a:p>
-                    <a:r>
-                      <a:t>integrationtest-electron</a:t>
+                  <c16:uniqueId val="{00000008-33E4-2C4E-BF34-F4F568F22E82}"/>
+                </c:ext>
+              </c:extLst>
+            </c:dLbl>
+            <c:dLbl>
+              <c:idx val="9"/>
+              <c:tx>
+                <c:rich>
+                  <a:bodyPr/>
+                  <a:lstStyle/>
+                  <a:p>
+                    <a:r>
+                      <a:t>integrationtest-vscode</a:t>
                     </a:r>
                   </a:p>
                 </c:rich>
@@ -4317,102 +4437,12 @@
                   <c15:showDataLabelsRange val="1"/>
                 </c:ext>
                 <c:ext xmlns:c16="http://schemas.microsoft.com/office/drawing/2014/chart" uri="{C3380CC4-5D6E-409C-BE32-E72D297353CC}">
-                  <c16:uniqueId val="{00000005-33E4-2C4E-BF34-F4F568F22E82}"/>
-                </c:ext>
-              </c:extLst>
-            </c:dLbl>
-            <c:dLbl>
-              <c:idx val="6"/>
-              <c:tx>
-                <c:rich>
-                  <a:bodyPr/>
-                  <a:lstStyle/>
-                  <a:p>
-                    <a:r>
-                      <a:t>integrationtest-airflow</a:t>
-                    </a:r>
-                  </a:p>
-                </c:rich>
-              </c:tx>
-              <c:dLblPos val="r"/>
-              <c:showLegendKey val="0"/>
-              <c:showVal val="0"/>
-              <c:showCatName val="0"/>
-              <c:showSerName val="0"/>
-              <c:showPercent val="0"/>
-              <c:showBubbleSize val="0"/>
-              <c:separator>; </c:separator>
-              <c:extLst>
-                <c:ext xmlns:c15="http://schemas.microsoft.com/office/drawing/2012/chart" uri="{CE6537A1-D6FC-4f65-9D91-7224C49458BB}">
-                  <c15:showDataLabelsRange val="1"/>
-                </c:ext>
-                <c:ext xmlns:c16="http://schemas.microsoft.com/office/drawing/2014/chart" uri="{C3380CC4-5D6E-409C-BE32-E72D297353CC}">
-                  <c16:uniqueId val="{00000006-33E4-2C4E-BF34-F4F568F22E82}"/>
-                </c:ext>
-              </c:extLst>
-            </c:dLbl>
-            <c:dLbl>
-              <c:idx val="7"/>
-              <c:tx>
-                <c:rich>
-                  <a:bodyPr/>
-                  <a:lstStyle/>
-                  <a:p>
-                    <a:r>
-                      <a:t>integrationtest-git</a:t>
-                    </a:r>
-                  </a:p>
-                </c:rich>
-              </c:tx>
-              <c:dLblPos val="r"/>
-              <c:showLegendKey val="0"/>
-              <c:showVal val="0"/>
-              <c:showCatName val="0"/>
-              <c:showSerName val="0"/>
-              <c:showPercent val="0"/>
-              <c:showBubbleSize val="0"/>
-              <c:separator>; </c:separator>
-              <c:extLst>
-                <c:ext xmlns:c15="http://schemas.microsoft.com/office/drawing/2012/chart" uri="{CE6537A1-D6FC-4f65-9D91-7224C49458BB}">
-                  <c15:showDataLabelsRange val="1"/>
-                </c:ext>
-                <c:ext xmlns:c16="http://schemas.microsoft.com/office/drawing/2014/chart" uri="{C3380CC4-5D6E-409C-BE32-E72D297353CC}">
-                  <c16:uniqueId val="{00000007-33E4-2C4E-BF34-F4F568F22E82}"/>
-                </c:ext>
-              </c:extLst>
-            </c:dLbl>
-            <c:dLbl>
-              <c:idx val="8"/>
-              <c:tx>
-                <c:rich>
-                  <a:bodyPr/>
-                  <a:lstStyle/>
-                  <a:p>
-                    <a:r>
-                      <a:t>integrationtest-vscode</a:t>
-                    </a:r>
-                  </a:p>
-                </c:rich>
-              </c:tx>
-              <c:dLblPos val="r"/>
-              <c:showLegendKey val="0"/>
-              <c:showVal val="0"/>
-              <c:showCatName val="0"/>
-              <c:showSerName val="0"/>
-              <c:showPercent val="0"/>
-              <c:showBubbleSize val="0"/>
-              <c:separator>; </c:separator>
-              <c:extLst>
-                <c:ext xmlns:c15="http://schemas.microsoft.com/office/drawing/2012/chart" uri="{CE6537A1-D6FC-4f65-9D91-7224C49458BB}">
-                  <c15:showDataLabelsRange val="1"/>
-                </c:ext>
-                <c:ext xmlns:c16="http://schemas.microsoft.com/office/drawing/2014/chart" uri="{C3380CC4-5D6E-409C-BE32-E72D297353CC}">
-                  <c16:uniqueId val="{00000008-33E4-2C4E-BF34-F4F568F22E82}"/>
-                </c:ext>
-              </c:extLst>
-            </c:dLbl>
-            <c:dLbl>
-              <c:idx val="9"/>
+                  <c16:uniqueId val="{00000009-33E4-2C4E-BF34-F4F568F22E82}"/>
+                </c:ext>
+              </c:extLst>
+            </c:dLbl>
+            <c:dLbl>
+              <c:idx val="10"/>
               <c:tx>
                 <c:rich>
                   <a:bodyPr/>
@@ -4424,36 +4454,6 @@
                   </a:p>
                 </c:rich>
               </c:tx>
-              <c:dLblPos val="r"/>
-              <c:showLegendKey val="0"/>
-              <c:showVal val="0"/>
-              <c:showCatName val="0"/>
-              <c:showSerName val="0"/>
-              <c:showPercent val="0"/>
-              <c:showBubbleSize val="0"/>
-              <c:separator>; </c:separator>
-              <c:extLst>
-                <c:ext xmlns:c15="http://schemas.microsoft.com/office/drawing/2012/chart" uri="{CE6537A1-D6FC-4f65-9D91-7224C49458BB}">
-                  <c15:showDataLabelsRange val="1"/>
-                </c:ext>
-                <c:ext xmlns:c16="http://schemas.microsoft.com/office/drawing/2014/chart" uri="{C3380CC4-5D6E-409C-BE32-E72D297353CC}">
-                  <c16:uniqueId val="{00000009-33E4-2C4E-BF34-F4F568F22E82}"/>
-                </c:ext>
-              </c:extLst>
-            </c:dLbl>
-            <c:dLbl>
-              <c:idx val="10"/>
-              <c:tx>
-                <c:rich>
-                  <a:bodyPr/>
-                  <a:lstStyle/>
-                  <a:p>
-                    <a:r>
-                      <a:t>integrationtest-elasticsearch</a:t>
-                    </a:r>
-                  </a:p>
-                </c:rich>
-              </c:tx>
               <c:showLegendKey val="0"/>
               <c:showVal val="1"/>
               <c:showCatName val="0"/>
@@ -4477,7 +4477,7 @@
                   <a:lstStyle/>
                   <a:p>
                     <a:r>
-                      <a:t>integrationtest-druid</a:t>
+                      <a:t>integrationtest-zuul</a:t>
                     </a:r>
                   </a:p>
                 </c:rich>
@@ -6894,40 +6894,40 @@
                 <c:formatCode>General</c:formatCode>
                 <c:ptCount val="12"/>
                 <c:pt idx="0">
-                  <c:v>6</c:v>
+                  <c:v>431</c:v>
                 </c:pt>
                 <c:pt idx="1">
+                  <c:v>16</c:v>
+                </c:pt>
+                <c:pt idx="2">
+                  <c:v>96</c:v>
+                </c:pt>
+                <c:pt idx="3">
+                  <c:v>19</c:v>
+                </c:pt>
+                <c:pt idx="4">
+                  <c:v>34</c:v>
+                </c:pt>
+                <c:pt idx="5">
+                  <c:v>0</c:v>
+                </c:pt>
+                <c:pt idx="6">
+                  <c:v>1550</c:v>
+                </c:pt>
+                <c:pt idx="7">
+                  <c:v>114</c:v>
+                </c:pt>
+                <c:pt idx="8">
                   <c:v>56</c:v>
                 </c:pt>
-                <c:pt idx="2">
-                  <c:v>0</c:v>
-                </c:pt>
-                <c:pt idx="3">
-                  <c:v>114</c:v>
-                </c:pt>
-                <c:pt idx="4">
-                  <c:v>16</c:v>
-                </c:pt>
-                <c:pt idx="5">
-                  <c:v>34</c:v>
-                </c:pt>
-                <c:pt idx="6">
-                  <c:v>431</c:v>
-                </c:pt>
-                <c:pt idx="7">
-                  <c:v>1550</c:v>
-                </c:pt>
-                <c:pt idx="8">
+                <c:pt idx="9">
                   <c:v>70</c:v>
                 </c:pt>
-                <c:pt idx="9">
+                <c:pt idx="10">
                   <c:v>5</c:v>
                 </c:pt>
-                <c:pt idx="10">
-                  <c:v>19</c:v>
-                </c:pt>
                 <c:pt idx="11">
-                  <c:v>96</c:v>
+                  <c:v>6</c:v>
                 </c:pt>
               </c:numCache>
             </c:numRef>
@@ -6939,40 +6939,40 @@
                 <c:formatCode>General</c:formatCode>
                 <c:ptCount val="12"/>
                 <c:pt idx="0">
-                  <c:v>3.3</c:v>
+                  <c:v>2.1</c:v>
                 </c:pt>
                 <c:pt idx="1">
-                  <c:v>2.0</c:v>
+                  <c:v>2.4</c:v>
                 </c:pt>
                 <c:pt idx="2">
-                  <c:v>5.5</c:v>
+                  <c:v>1.9</c:v>
                 </c:pt>
                 <c:pt idx="3">
-                  <c:v>1.7</c:v>
+                  <c:v>1.5</c:v>
                 </c:pt>
                 <c:pt idx="4">
                   <c:v>2.4</c:v>
                 </c:pt>
                 <c:pt idx="5">
-                  <c:v>2.4</c:v>
+                  <c:v>5.5</c:v>
                 </c:pt>
                 <c:pt idx="6">
+                  <c:v>2.6</c:v>
+                </c:pt>
+                <c:pt idx="7">
+                  <c:v>1.7</c:v>
+                </c:pt>
+                <c:pt idx="8">
+                  <c:v>2.0</c:v>
+                </c:pt>
+                <c:pt idx="9">
                   <c:v>2.1</c:v>
                 </c:pt>
-                <c:pt idx="7">
-                  <c:v>2.6</c:v>
-                </c:pt>
-                <c:pt idx="8">
-                  <c:v>2.1</c:v>
-                </c:pt>
-                <c:pt idx="9">
+                <c:pt idx="10">
                   <c:v>3.1</c:v>
                 </c:pt>
-                <c:pt idx="10">
-                  <c:v>1.5</c:v>
-                </c:pt>
                 <c:pt idx="11">
-                  <c:v>1.9</c:v>
+                  <c:v>3.3</c:v>
                 </c:pt>
               </c:numCache>
             </c:numRef>
@@ -7246,7 +7246,7 @@
                   <a:lstStyle/>
                   <a:p>
                     <a:r>
-                      <a:t>integrationtest-vscode</a:t>
+                      <a:t>integrationtest-airflow</a:t>
                     </a:r>
                   </a:p>
                 </c:rich>
@@ -7276,7 +7276,7 @@
                   <a:lstStyle/>
                   <a:p>
                     <a:r>
-                      <a:t>integrationtest-git</a:t>
+                      <a:t>integrationtest-bazel</a:t>
                     </a:r>
                   </a:p>
                 </c:rich>
@@ -7306,7 +7306,7 @@
                   <a:lstStyle/>
                   <a:p>
                     <a:r>
-                      <a:t>integrationtest-facebookyoga</a:t>
+                      <a:t>integrationtest-druid</a:t>
                     </a:r>
                   </a:p>
                 </c:rich>
@@ -7342,7 +7342,7 @@
                   <a:lstStyle/>
                   <a:p>
                     <a:r>
-                      <a:t>integrationtest-druid</a:t>
+                      <a:t>integrationtest-elasticsearch</a:t>
                     </a:r>
                   </a:p>
                 </c:rich>
@@ -7372,6 +7372,96 @@
                   <a:lstStyle/>
                   <a:p>
                     <a:r>
+                      <a:t>integrationtest-electron</a:t>
+                    </a:r>
+                  </a:p>
+                </c:rich>
+              </c:tx>
+              <c:dLblPos val="r"/>
+              <c:showLegendKey val="0"/>
+              <c:showVal val="0"/>
+              <c:showCatName val="0"/>
+              <c:showSerName val="0"/>
+              <c:showPercent val="0"/>
+              <c:showBubbleSize val="0"/>
+              <c:separator>; </c:separator>
+              <c:extLst>
+                <c:ext xmlns:c15="http://schemas.microsoft.com/office/drawing/2012/chart" uri="{CE6537A1-D6FC-4f65-9D91-7224C49458BB}">
+                  <c15:showDataLabelsRange val="1"/>
+                </c:ext>
+                <c:ext xmlns:c16="http://schemas.microsoft.com/office/drawing/2014/chart" uri="{C3380CC4-5D6E-409C-BE32-E72D297353CC}">
+                  <c16:uniqueId val="{00000004-33E4-2C4E-BF34-F4F568F22E82}"/>
+                </c:ext>
+              </c:extLst>
+            </c:dLbl>
+            <c:dLbl>
+              <c:idx val="5"/>
+              <c:tx>
+                <c:rich>
+                  <a:bodyPr/>
+                  <a:lstStyle/>
+                  <a:p>
+                    <a:r>
+                      <a:t>integrationtest-facebookyoga</a:t>
+                    </a:r>
+                  </a:p>
+                </c:rich>
+              </c:tx>
+              <c:dLblPos val="r"/>
+              <c:showLegendKey val="0"/>
+              <c:showVal val="0"/>
+              <c:showCatName val="0"/>
+              <c:showSerName val="0"/>
+              <c:showPercent val="0"/>
+              <c:showBubbleSize val="0"/>
+              <c:separator>; </c:separator>
+              <c:extLst>
+                <c:ext xmlns:c15="http://schemas.microsoft.com/office/drawing/2012/chart" uri="{CE6537A1-D6FC-4f65-9D91-7224C49458BB}">
+                  <c15:showDataLabelsRange val="1"/>
+                </c:ext>
+                <c:ext xmlns:c16="http://schemas.microsoft.com/office/drawing/2014/chart" uri="{C3380CC4-5D6E-409C-BE32-E72D297353CC}">
+                  <c16:uniqueId val="{00000005-33E4-2C4E-BF34-F4F568F22E82}"/>
+                </c:ext>
+              </c:extLst>
+            </c:dLbl>
+            <c:dLbl>
+              <c:idx val="6"/>
+              <c:tx>
+                <c:rich>
+                  <a:bodyPr/>
+                  <a:lstStyle/>
+                  <a:p>
+                    <a:r>
+                      <a:t>integrationtest-git</a:t>
+                    </a:r>
+                  </a:p>
+                </c:rich>
+              </c:tx>
+              <c:dLblPos val="r"/>
+              <c:showLegendKey val="0"/>
+              <c:showVal val="0"/>
+              <c:showCatName val="0"/>
+              <c:showSerName val="0"/>
+              <c:showPercent val="0"/>
+              <c:showBubbleSize val="0"/>
+              <c:separator>; </c:separator>
+              <c:extLst>
+                <c:ext xmlns:c15="http://schemas.microsoft.com/office/drawing/2012/chart" uri="{CE6537A1-D6FC-4f65-9D91-7224C49458BB}">
+                  <c15:showDataLabelsRange val="1"/>
+                </c:ext>
+                <c:ext xmlns:c16="http://schemas.microsoft.com/office/drawing/2014/chart" uri="{C3380CC4-5D6E-409C-BE32-E72D297353CC}">
+                  <c16:uniqueId val="{00000006-33E4-2C4E-BF34-F4F568F22E82}"/>
+                </c:ext>
+              </c:extLst>
+            </c:dLbl>
+            <c:dLbl>
+              <c:idx val="7"/>
+              <c:tx>
+                <c:rich>
+                  <a:bodyPr/>
+                  <a:lstStyle/>
+                  <a:p>
+                    <a:r>
                       <a:t>integrationtest-jruby</a:t>
                     </a:r>
                   </a:p>
@@ -7390,12 +7480,72 @@
                   <c15:showDataLabelsRange val="1"/>
                 </c:ext>
                 <c:ext xmlns:c16="http://schemas.microsoft.com/office/drawing/2014/chart" uri="{C3380CC4-5D6E-409C-BE32-E72D297353CC}">
-                  <c16:uniqueId val="{00000004-33E4-2C4E-BF34-F4F568F22E82}"/>
-                </c:ext>
-              </c:extLst>
-            </c:dLbl>
-            <c:dLbl>
-              <c:idx val="5"/>
+                  <c16:uniqueId val="{00000007-33E4-2C4E-BF34-F4F568F22E82}"/>
+                </c:ext>
+              </c:extLst>
+            </c:dLbl>
+            <c:dLbl>
+              <c:idx val="8"/>
+              <c:tx>
+                <c:rich>
+                  <a:bodyPr/>
+                  <a:lstStyle/>
+                  <a:p>
+                    <a:r>
+                      <a:t>integrationtest-kafka</a:t>
+                    </a:r>
+                  </a:p>
+                </c:rich>
+              </c:tx>
+              <c:dLblPos val="r"/>
+              <c:showLegendKey val="0"/>
+              <c:showVal val="0"/>
+              <c:showCatName val="0"/>
+              <c:showSerName val="0"/>
+              <c:showPercent val="0"/>
+              <c:showBubbleSize val="0"/>
+              <c:separator>; </c:separator>
+              <c:extLst>
+                <c:ext xmlns:c15="http://schemas.microsoft.com/office/drawing/2012/chart" uri="{CE6537A1-D6FC-4f65-9D91-7224C49458BB}">
+                  <c15:showDataLabelsRange val="1"/>
+                </c:ext>
+                <c:ext xmlns:c16="http://schemas.microsoft.com/office/drawing/2014/chart" uri="{C3380CC4-5D6E-409C-BE32-E72D297353CC}">
+                  <c16:uniqueId val="{00000008-33E4-2C4E-BF34-F4F568F22E82}"/>
+                </c:ext>
+              </c:extLst>
+            </c:dLbl>
+            <c:dLbl>
+              <c:idx val="9"/>
+              <c:tx>
+                <c:rich>
+                  <a:bodyPr/>
+                  <a:lstStyle/>
+                  <a:p>
+                    <a:r>
+                      <a:t>integrationtest-vscode</a:t>
+                    </a:r>
+                  </a:p>
+                </c:rich>
+              </c:tx>
+              <c:dLblPos val="r"/>
+              <c:showLegendKey val="0"/>
+              <c:showVal val="0"/>
+              <c:showCatName val="0"/>
+              <c:showSerName val="0"/>
+              <c:showPercent val="0"/>
+              <c:showBubbleSize val="0"/>
+              <c:separator>; </c:separator>
+              <c:extLst>
+                <c:ext xmlns:c15="http://schemas.microsoft.com/office/drawing/2012/chart" uri="{CE6537A1-D6FC-4f65-9D91-7224C49458BB}">
+                  <c15:showDataLabelsRange val="1"/>
+                </c:ext>
+                <c:ext xmlns:c16="http://schemas.microsoft.com/office/drawing/2014/chart" uri="{C3380CC4-5D6E-409C-BE32-E72D297353CC}">
+                  <c16:uniqueId val="{00000009-33E4-2C4E-BF34-F4F568F22E82}"/>
+                </c:ext>
+              </c:extLst>
+            </c:dLbl>
+            <c:dLbl>
+              <c:idx val="10"/>
               <c:tx>
                 <c:rich>
                   <a:bodyPr/>
@@ -7407,55 +7557,23 @@
                   </a:p>
                 </c:rich>
               </c:tx>
-              <c:dLblPos val="r"/>
-              <c:showLegendKey val="0"/>
-              <c:showVal val="0"/>
-              <c:showCatName val="0"/>
-              <c:showSerName val="0"/>
-              <c:showPercent val="0"/>
-              <c:showBubbleSize val="0"/>
-              <c:separator>; </c:separator>
-              <c:extLst>
-                <c:ext xmlns:c15="http://schemas.microsoft.com/office/drawing/2012/chart" uri="{CE6537A1-D6FC-4f65-9D91-7224C49458BB}">
-                  <c15:showDataLabelsRange val="1"/>
-                </c:ext>
-                <c:ext xmlns:c16="http://schemas.microsoft.com/office/drawing/2014/chart" uri="{C3380CC4-5D6E-409C-BE32-E72D297353CC}">
-                  <c16:uniqueId val="{00000005-33E4-2C4E-BF34-F4F568F22E82}"/>
-                </c:ext>
-              </c:extLst>
-            </c:dLbl>
-            <c:dLbl>
-              <c:idx val="6"/>
-              <c:tx>
-                <c:rich>
-                  <a:bodyPr/>
-                  <a:lstStyle/>
-                  <a:p>
-                    <a:r>
-                      <a:t>integrationtest-elasticsearch</a:t>
-                    </a:r>
-                  </a:p>
-                </c:rich>
-              </c:tx>
-              <c:dLblPos val="r"/>
-              <c:showLegendKey val="0"/>
-              <c:showVal val="0"/>
-              <c:showCatName val="0"/>
-              <c:showSerName val="0"/>
-              <c:showPercent val="0"/>
-              <c:showBubbleSize val="0"/>
-              <c:separator>; </c:separator>
-              <c:extLst>
-                <c:ext xmlns:c15="http://schemas.microsoft.com/office/drawing/2012/chart" uri="{CE6537A1-D6FC-4f65-9D91-7224C49458BB}">
-                  <c15:showDataLabelsRange val="1"/>
-                </c:ext>
-                <c:ext xmlns:c16="http://schemas.microsoft.com/office/drawing/2014/chart" uri="{C3380CC4-5D6E-409C-BE32-E72D297353CC}">
-                  <c16:uniqueId val="{00000006-33E4-2C4E-BF34-F4F568F22E82}"/>
-                </c:ext>
-              </c:extLst>
-            </c:dLbl>
-            <c:dLbl>
-              <c:idx val="7"/>
+              <c:showLegendKey val="0"/>
+              <c:showVal val="1"/>
+              <c:showCatName val="0"/>
+              <c:showSerName val="0"/>
+              <c:showPercent val="0"/>
+              <c:showBubbleSize val="0"/>
+              <c:extLst>
+                <c:ext xmlns:c15="http://schemas.microsoft.com/office/drawing/2012/chart" uri="{CE6537A1-D6FC-4f65-9D91-7224C49458BB}">
+                  <c15:showDataLabelsRange val="0"/>
+                </c:ext>
+                <c:ext xmlns:c16="http://schemas.microsoft.com/office/drawing/2014/chart" uri="{C3380CC4-5D6E-409C-BE32-E72D297353CC}">
+                  <c16:uniqueId val="{0000000A-33E4-2C4E-BF34-F4F568F22E82}"/>
+                </c:ext>
+              </c:extLst>
+            </c:dLbl>
+            <c:dLbl>
+              <c:idx val="11"/>
               <c:tx>
                 <c:rich>
                   <a:bodyPr/>
@@ -7463,124 +7581,6 @@
                   <a:p>
                     <a:r>
                       <a:t>integrationtest-zuul</a:t>
-                    </a:r>
-                  </a:p>
-                </c:rich>
-              </c:tx>
-              <c:dLblPos val="r"/>
-              <c:showLegendKey val="0"/>
-              <c:showVal val="0"/>
-              <c:showCatName val="0"/>
-              <c:showSerName val="0"/>
-              <c:showPercent val="0"/>
-              <c:showBubbleSize val="0"/>
-              <c:separator>; </c:separator>
-              <c:extLst>
-                <c:ext xmlns:c15="http://schemas.microsoft.com/office/drawing/2012/chart" uri="{CE6537A1-D6FC-4f65-9D91-7224C49458BB}">
-                  <c15:showDataLabelsRange val="1"/>
-                </c:ext>
-                <c:ext xmlns:c16="http://schemas.microsoft.com/office/drawing/2014/chart" uri="{C3380CC4-5D6E-409C-BE32-E72D297353CC}">
-                  <c16:uniqueId val="{00000007-33E4-2C4E-BF34-F4F568F22E82}"/>
-                </c:ext>
-              </c:extLst>
-            </c:dLbl>
-            <c:dLbl>
-              <c:idx val="8"/>
-              <c:tx>
-                <c:rich>
-                  <a:bodyPr/>
-                  <a:lstStyle/>
-                  <a:p>
-                    <a:r>
-                      <a:t>integrationtest-kafka</a:t>
-                    </a:r>
-                  </a:p>
-                </c:rich>
-              </c:tx>
-              <c:dLblPos val="r"/>
-              <c:showLegendKey val="0"/>
-              <c:showVal val="0"/>
-              <c:showCatName val="0"/>
-              <c:showSerName val="0"/>
-              <c:showPercent val="0"/>
-              <c:showBubbleSize val="0"/>
-              <c:separator>; </c:separator>
-              <c:extLst>
-                <c:ext xmlns:c15="http://schemas.microsoft.com/office/drawing/2012/chart" uri="{CE6537A1-D6FC-4f65-9D91-7224C49458BB}">
-                  <c15:showDataLabelsRange val="1"/>
-                </c:ext>
-                <c:ext xmlns:c16="http://schemas.microsoft.com/office/drawing/2014/chart" uri="{C3380CC4-5D6E-409C-BE32-E72D297353CC}">
-                  <c16:uniqueId val="{00000008-33E4-2C4E-BF34-F4F568F22E82}"/>
-                </c:ext>
-              </c:extLst>
-            </c:dLbl>
-            <c:dLbl>
-              <c:idx val="9"/>
-              <c:tx>
-                <c:rich>
-                  <a:bodyPr/>
-                  <a:lstStyle/>
-                  <a:p>
-                    <a:r>
-                      <a:t>integrationtest-airflow</a:t>
-                    </a:r>
-                  </a:p>
-                </c:rich>
-              </c:tx>
-              <c:dLblPos val="r"/>
-              <c:showLegendKey val="0"/>
-              <c:showVal val="0"/>
-              <c:showCatName val="0"/>
-              <c:showSerName val="0"/>
-              <c:showPercent val="0"/>
-              <c:showBubbleSize val="0"/>
-              <c:separator>; </c:separator>
-              <c:extLst>
-                <c:ext xmlns:c15="http://schemas.microsoft.com/office/drawing/2012/chart" uri="{CE6537A1-D6FC-4f65-9D91-7224C49458BB}">
-                  <c15:showDataLabelsRange val="1"/>
-                </c:ext>
-                <c:ext xmlns:c16="http://schemas.microsoft.com/office/drawing/2014/chart" uri="{C3380CC4-5D6E-409C-BE32-E72D297353CC}">
-                  <c16:uniqueId val="{00000009-33E4-2C4E-BF34-F4F568F22E82}"/>
-                </c:ext>
-              </c:extLst>
-            </c:dLbl>
-            <c:dLbl>
-              <c:idx val="10"/>
-              <c:tx>
-                <c:rich>
-                  <a:bodyPr/>
-                  <a:lstStyle/>
-                  <a:p>
-                    <a:r>
-                      <a:t>integrationtest-bazel</a:t>
-                    </a:r>
-                  </a:p>
-                </c:rich>
-              </c:tx>
-              <c:showLegendKey val="0"/>
-              <c:showVal val="1"/>
-              <c:showCatName val="0"/>
-              <c:showSerName val="0"/>
-              <c:showPercent val="0"/>
-              <c:showBubbleSize val="0"/>
-              <c:extLst>
-                <c:ext xmlns:c15="http://schemas.microsoft.com/office/drawing/2012/chart" uri="{CE6537A1-D6FC-4f65-9D91-7224C49458BB}">
-                  <c15:showDataLabelsRange val="0"/>
-                </c:ext>
-                <c:ext xmlns:c16="http://schemas.microsoft.com/office/drawing/2014/chart" uri="{C3380CC4-5D6E-409C-BE32-E72D297353CC}">
-                  <c16:uniqueId val="{0000000A-33E4-2C4E-BF34-F4F568F22E82}"/>
-                </c:ext>
-              </c:extLst>
-            </c:dLbl>
-            <c:dLbl>
-              <c:idx val="11"/>
-              <c:tx>
-                <c:rich>
-                  <a:bodyPr/>
-                  <a:lstStyle/>
-                  <a:p>
-                    <a:r>
-                      <a:t>integrationtest-electron</a:t>
                     </a:r>
                   </a:p>
                 </c:rich>
@@ -10000,25 +10000,25 @@
                   <c:v>0</c:v>
                 </c:pt>
                 <c:pt idx="1">
-                  <c:v>1013</c:v>
+                  <c:v>4</c:v>
                 </c:pt>
                 <c:pt idx="2">
-                  <c:v>0</c:v>
+                  <c:v>15</c:v>
                 </c:pt>
                 <c:pt idx="3">
-                  <c:v>15</c:v>
+                  <c:v>16</c:v>
                 </c:pt>
                 <c:pt idx="4">
-                  <c:v>41</c:v>
+                  <c:v>0</c:v>
                 </c:pt>
                 <c:pt idx="5">
                   <c:v>0</c:v>
                 </c:pt>
                 <c:pt idx="6">
-                  <c:v>16</c:v>
+                  <c:v>1013</c:v>
                 </c:pt>
                 <c:pt idx="7">
-                  <c:v>1</c:v>
+                  <c:v>41</c:v>
                 </c:pt>
                 <c:pt idx="8">
                   <c:v>24</c:v>
@@ -10027,10 +10027,10 @@
                   <c:v>0</c:v>
                 </c:pt>
                 <c:pt idx="10">
-                  <c:v>4</c:v>
+                  <c:v>0</c:v>
                 </c:pt>
                 <c:pt idx="11">
-                  <c:v>0</c:v>
+                  <c:v>1</c:v>
                 </c:pt>
               </c:numCache>
             </c:numRef>
@@ -10045,25 +10045,25 @@
                   <c:v>3.1</c:v>
                 </c:pt>
                 <c:pt idx="1">
+                  <c:v>2.4</c:v>
+                </c:pt>
+                <c:pt idx="2">
+                  <c:v>1.4</c:v>
+                </c:pt>
+                <c:pt idx="3">
+                  <c:v>1.5</c:v>
+                </c:pt>
+                <c:pt idx="4">
+                  <c:v>3.4</c:v>
+                </c:pt>
+                <c:pt idx="5">
+                  <c:v>5.5</c:v>
+                </c:pt>
+                <c:pt idx="6">
                   <c:v>2.6</c:v>
                 </c:pt>
-                <c:pt idx="2">
-                  <c:v>5.5</c:v>
-                </c:pt>
-                <c:pt idx="3">
-                  <c:v>1.4</c:v>
-                </c:pt>
-                <c:pt idx="4">
+                <c:pt idx="7">
                   <c:v>1.1</c:v>
-                </c:pt>
-                <c:pt idx="5">
-                  <c:v>3.4</c:v>
-                </c:pt>
-                <c:pt idx="6">
-                  <c:v>1.5</c:v>
-                </c:pt>
-                <c:pt idx="7">
-                  <c:v>3.1</c:v>
                 </c:pt>
                 <c:pt idx="8">
                   <c:v>1.9</c:v>
@@ -10072,10 +10072,10 @@
                   <c:v>3.1</c:v>
                 </c:pt>
                 <c:pt idx="10">
-                  <c:v>2.4</c:v>
+                  <c:v>3.4</c:v>
                 </c:pt>
                 <c:pt idx="11">
-                  <c:v>3.4</c:v>
+                  <c:v>3.1</c:v>
                 </c:pt>
               </c:numCache>
             </c:numRef>
@@ -10355,7 +10355,7 @@
                   <a:lstStyle/>
                   <a:p>
                     <a:r>
-                      <a:t>integrationtest-vscode</a:t>
+                      <a:t>integrationtest-airflow</a:t>
                     </a:r>
                   </a:p>
                 </c:rich>
@@ -10385,7 +10385,7 @@
                   <a:lstStyle/>
                   <a:p>
                     <a:r>
-                      <a:t>integrationtest-git</a:t>
+                      <a:t>integrationtest-bazel</a:t>
                     </a:r>
                   </a:p>
                 </c:rich>
@@ -10415,7 +10415,7 @@
                   <a:lstStyle/>
                   <a:p>
                     <a:r>
-                      <a:t>integrationtest-facebookyoga</a:t>
+                      <a:t>integrationtest-druid</a:t>
                     </a:r>
                   </a:p>
                 </c:rich>
@@ -10451,7 +10451,7 @@
                   <a:lstStyle/>
                   <a:p>
                     <a:r>
-                      <a:t>integrationtest-druid</a:t>
+                      <a:t>integrationtest-elasticsearch</a:t>
                     </a:r>
                   </a:p>
                 </c:rich>
@@ -10481,6 +10481,96 @@
                   <a:lstStyle/>
                   <a:p>
                     <a:r>
+                      <a:t>integrationtest-electron</a:t>
+                    </a:r>
+                  </a:p>
+                </c:rich>
+              </c:tx>
+              <c:dLblPos val="r"/>
+              <c:showLegendKey val="0"/>
+              <c:showVal val="0"/>
+              <c:showCatName val="0"/>
+              <c:showSerName val="0"/>
+              <c:showPercent val="0"/>
+              <c:showBubbleSize val="0"/>
+              <c:separator>; </c:separator>
+              <c:extLst>
+                <c:ext xmlns:c15="http://schemas.microsoft.com/office/drawing/2012/chart" uri="{CE6537A1-D6FC-4f65-9D91-7224C49458BB}">
+                  <c15:showDataLabelsRange val="1"/>
+                </c:ext>
+                <c:ext xmlns:c16="http://schemas.microsoft.com/office/drawing/2014/chart" uri="{C3380CC4-5D6E-409C-BE32-E72D297353CC}">
+                  <c16:uniqueId val="{00000004-33E4-2C4E-BF34-F4F568F22E82}"/>
+                </c:ext>
+              </c:extLst>
+            </c:dLbl>
+            <c:dLbl>
+              <c:idx val="5"/>
+              <c:tx>
+                <c:rich>
+                  <a:bodyPr/>
+                  <a:lstStyle/>
+                  <a:p>
+                    <a:r>
+                      <a:t>integrationtest-facebookyoga</a:t>
+                    </a:r>
+                  </a:p>
+                </c:rich>
+              </c:tx>
+              <c:dLblPos val="r"/>
+              <c:showLegendKey val="0"/>
+              <c:showVal val="0"/>
+              <c:showCatName val="0"/>
+              <c:showSerName val="0"/>
+              <c:showPercent val="0"/>
+              <c:showBubbleSize val="0"/>
+              <c:separator>; </c:separator>
+              <c:extLst>
+                <c:ext xmlns:c15="http://schemas.microsoft.com/office/drawing/2012/chart" uri="{CE6537A1-D6FC-4f65-9D91-7224C49458BB}">
+                  <c15:showDataLabelsRange val="1"/>
+                </c:ext>
+                <c:ext xmlns:c16="http://schemas.microsoft.com/office/drawing/2014/chart" uri="{C3380CC4-5D6E-409C-BE32-E72D297353CC}">
+                  <c16:uniqueId val="{00000005-33E4-2C4E-BF34-F4F568F22E82}"/>
+                </c:ext>
+              </c:extLst>
+            </c:dLbl>
+            <c:dLbl>
+              <c:idx val="6"/>
+              <c:tx>
+                <c:rich>
+                  <a:bodyPr/>
+                  <a:lstStyle/>
+                  <a:p>
+                    <a:r>
+                      <a:t>integrationtest-git</a:t>
+                    </a:r>
+                  </a:p>
+                </c:rich>
+              </c:tx>
+              <c:dLblPos val="r"/>
+              <c:showLegendKey val="0"/>
+              <c:showVal val="0"/>
+              <c:showCatName val="0"/>
+              <c:showSerName val="0"/>
+              <c:showPercent val="0"/>
+              <c:showBubbleSize val="0"/>
+              <c:separator>; </c:separator>
+              <c:extLst>
+                <c:ext xmlns:c15="http://schemas.microsoft.com/office/drawing/2012/chart" uri="{CE6537A1-D6FC-4f65-9D91-7224C49458BB}">
+                  <c15:showDataLabelsRange val="1"/>
+                </c:ext>
+                <c:ext xmlns:c16="http://schemas.microsoft.com/office/drawing/2014/chart" uri="{C3380CC4-5D6E-409C-BE32-E72D297353CC}">
+                  <c16:uniqueId val="{00000006-33E4-2C4E-BF34-F4F568F22E82}"/>
+                </c:ext>
+              </c:extLst>
+            </c:dLbl>
+            <c:dLbl>
+              <c:idx val="7"/>
+              <c:tx>
+                <c:rich>
+                  <a:bodyPr/>
+                  <a:lstStyle/>
+                  <a:p>
+                    <a:r>
                       <a:t>integrationtest-jruby</a:t>
                     </a:r>
                   </a:p>
@@ -10499,12 +10589,72 @@
                   <c15:showDataLabelsRange val="1"/>
                 </c:ext>
                 <c:ext xmlns:c16="http://schemas.microsoft.com/office/drawing/2014/chart" uri="{C3380CC4-5D6E-409C-BE32-E72D297353CC}">
-                  <c16:uniqueId val="{00000004-33E4-2C4E-BF34-F4F568F22E82}"/>
-                </c:ext>
-              </c:extLst>
-            </c:dLbl>
-            <c:dLbl>
-              <c:idx val="5"/>
+                  <c16:uniqueId val="{00000007-33E4-2C4E-BF34-F4F568F22E82}"/>
+                </c:ext>
+              </c:extLst>
+            </c:dLbl>
+            <c:dLbl>
+              <c:idx val="8"/>
+              <c:tx>
+                <c:rich>
+                  <a:bodyPr/>
+                  <a:lstStyle/>
+                  <a:p>
+                    <a:r>
+                      <a:t>integrationtest-kafka</a:t>
+                    </a:r>
+                  </a:p>
+                </c:rich>
+              </c:tx>
+              <c:dLblPos val="r"/>
+              <c:showLegendKey val="0"/>
+              <c:showVal val="0"/>
+              <c:showCatName val="0"/>
+              <c:showSerName val="0"/>
+              <c:showPercent val="0"/>
+              <c:showBubbleSize val="0"/>
+              <c:separator>; </c:separator>
+              <c:extLst>
+                <c:ext xmlns:c15="http://schemas.microsoft.com/office/drawing/2012/chart" uri="{CE6537A1-D6FC-4f65-9D91-7224C49458BB}">
+                  <c15:showDataLabelsRange val="1"/>
+                </c:ext>
+                <c:ext xmlns:c16="http://schemas.microsoft.com/office/drawing/2014/chart" uri="{C3380CC4-5D6E-409C-BE32-E72D297353CC}">
+                  <c16:uniqueId val="{00000008-33E4-2C4E-BF34-F4F568F22E82}"/>
+                </c:ext>
+              </c:extLst>
+            </c:dLbl>
+            <c:dLbl>
+              <c:idx val="9"/>
+              <c:tx>
+                <c:rich>
+                  <a:bodyPr/>
+                  <a:lstStyle/>
+                  <a:p>
+                    <a:r>
+                      <a:t>integrationtest-vscode</a:t>
+                    </a:r>
+                  </a:p>
+                </c:rich>
+              </c:tx>
+              <c:dLblPos val="r"/>
+              <c:showLegendKey val="0"/>
+              <c:showVal val="0"/>
+              <c:showCatName val="0"/>
+              <c:showSerName val="0"/>
+              <c:showPercent val="0"/>
+              <c:showBubbleSize val="0"/>
+              <c:separator>; </c:separator>
+              <c:extLst>
+                <c:ext xmlns:c15="http://schemas.microsoft.com/office/drawing/2012/chart" uri="{CE6537A1-D6FC-4f65-9D91-7224C49458BB}">
+                  <c15:showDataLabelsRange val="1"/>
+                </c:ext>
+                <c:ext xmlns:c16="http://schemas.microsoft.com/office/drawing/2014/chart" uri="{C3380CC4-5D6E-409C-BE32-E72D297353CC}">
+                  <c16:uniqueId val="{00000009-33E4-2C4E-BF34-F4F568F22E82}"/>
+                </c:ext>
+              </c:extLst>
+            </c:dLbl>
+            <c:dLbl>
+              <c:idx val="10"/>
               <c:tx>
                 <c:rich>
                   <a:bodyPr/>
@@ -10516,55 +10666,23 @@
                   </a:p>
                 </c:rich>
               </c:tx>
-              <c:dLblPos val="r"/>
-              <c:showLegendKey val="0"/>
-              <c:showVal val="0"/>
-              <c:showCatName val="0"/>
-              <c:showSerName val="0"/>
-              <c:showPercent val="0"/>
-              <c:showBubbleSize val="0"/>
-              <c:separator>; </c:separator>
-              <c:extLst>
-                <c:ext xmlns:c15="http://schemas.microsoft.com/office/drawing/2012/chart" uri="{CE6537A1-D6FC-4f65-9D91-7224C49458BB}">
-                  <c15:showDataLabelsRange val="1"/>
-                </c:ext>
-                <c:ext xmlns:c16="http://schemas.microsoft.com/office/drawing/2014/chart" uri="{C3380CC4-5D6E-409C-BE32-E72D297353CC}">
-                  <c16:uniqueId val="{00000005-33E4-2C4E-BF34-F4F568F22E82}"/>
-                </c:ext>
-              </c:extLst>
-            </c:dLbl>
-            <c:dLbl>
-              <c:idx val="6"/>
-              <c:tx>
-                <c:rich>
-                  <a:bodyPr/>
-                  <a:lstStyle/>
-                  <a:p>
-                    <a:r>
-                      <a:t>integrationtest-elasticsearch</a:t>
-                    </a:r>
-                  </a:p>
-                </c:rich>
-              </c:tx>
-              <c:dLblPos val="r"/>
-              <c:showLegendKey val="0"/>
-              <c:showVal val="0"/>
-              <c:showCatName val="0"/>
-              <c:showSerName val="0"/>
-              <c:showPercent val="0"/>
-              <c:showBubbleSize val="0"/>
-              <c:separator>; </c:separator>
-              <c:extLst>
-                <c:ext xmlns:c15="http://schemas.microsoft.com/office/drawing/2012/chart" uri="{CE6537A1-D6FC-4f65-9D91-7224C49458BB}">
-                  <c15:showDataLabelsRange val="1"/>
-                </c:ext>
-                <c:ext xmlns:c16="http://schemas.microsoft.com/office/drawing/2014/chart" uri="{C3380CC4-5D6E-409C-BE32-E72D297353CC}">
-                  <c16:uniqueId val="{00000006-33E4-2C4E-BF34-F4F568F22E82}"/>
-                </c:ext>
-              </c:extLst>
-            </c:dLbl>
-            <c:dLbl>
-              <c:idx val="7"/>
+              <c:showLegendKey val="0"/>
+              <c:showVal val="1"/>
+              <c:showCatName val="0"/>
+              <c:showSerName val="0"/>
+              <c:showPercent val="0"/>
+              <c:showBubbleSize val="0"/>
+              <c:extLst>
+                <c:ext xmlns:c15="http://schemas.microsoft.com/office/drawing/2012/chart" uri="{CE6537A1-D6FC-4f65-9D91-7224C49458BB}">
+                  <c15:showDataLabelsRange val="0"/>
+                </c:ext>
+                <c:ext xmlns:c16="http://schemas.microsoft.com/office/drawing/2014/chart" uri="{C3380CC4-5D6E-409C-BE32-E72D297353CC}">
+                  <c16:uniqueId val="{0000000A-33E4-2C4E-BF34-F4F568F22E82}"/>
+                </c:ext>
+              </c:extLst>
+            </c:dLbl>
+            <c:dLbl>
+              <c:idx val="11"/>
               <c:tx>
                 <c:rich>
                   <a:bodyPr/>
@@ -10572,124 +10690,6 @@
                   <a:p>
                     <a:r>
                       <a:t>integrationtest-zuul</a:t>
-                    </a:r>
-                  </a:p>
-                </c:rich>
-              </c:tx>
-              <c:dLblPos val="r"/>
-              <c:showLegendKey val="0"/>
-              <c:showVal val="0"/>
-              <c:showCatName val="0"/>
-              <c:showSerName val="0"/>
-              <c:showPercent val="0"/>
-              <c:showBubbleSize val="0"/>
-              <c:separator>; </c:separator>
-              <c:extLst>
-                <c:ext xmlns:c15="http://schemas.microsoft.com/office/drawing/2012/chart" uri="{CE6537A1-D6FC-4f65-9D91-7224C49458BB}">
-                  <c15:showDataLabelsRange val="1"/>
-                </c:ext>
-                <c:ext xmlns:c16="http://schemas.microsoft.com/office/drawing/2014/chart" uri="{C3380CC4-5D6E-409C-BE32-E72D297353CC}">
-                  <c16:uniqueId val="{00000007-33E4-2C4E-BF34-F4F568F22E82}"/>
-                </c:ext>
-              </c:extLst>
-            </c:dLbl>
-            <c:dLbl>
-              <c:idx val="8"/>
-              <c:tx>
-                <c:rich>
-                  <a:bodyPr/>
-                  <a:lstStyle/>
-                  <a:p>
-                    <a:r>
-                      <a:t>integrationtest-kafka</a:t>
-                    </a:r>
-                  </a:p>
-                </c:rich>
-              </c:tx>
-              <c:dLblPos val="r"/>
-              <c:showLegendKey val="0"/>
-              <c:showVal val="0"/>
-              <c:showCatName val="0"/>
-              <c:showSerName val="0"/>
-              <c:showPercent val="0"/>
-              <c:showBubbleSize val="0"/>
-              <c:separator>; </c:separator>
-              <c:extLst>
-                <c:ext xmlns:c15="http://schemas.microsoft.com/office/drawing/2012/chart" uri="{CE6537A1-D6FC-4f65-9D91-7224C49458BB}">
-                  <c15:showDataLabelsRange val="1"/>
-                </c:ext>
-                <c:ext xmlns:c16="http://schemas.microsoft.com/office/drawing/2014/chart" uri="{C3380CC4-5D6E-409C-BE32-E72D297353CC}">
-                  <c16:uniqueId val="{00000008-33E4-2C4E-BF34-F4F568F22E82}"/>
-                </c:ext>
-              </c:extLst>
-            </c:dLbl>
-            <c:dLbl>
-              <c:idx val="9"/>
-              <c:tx>
-                <c:rich>
-                  <a:bodyPr/>
-                  <a:lstStyle/>
-                  <a:p>
-                    <a:r>
-                      <a:t>integrationtest-airflow</a:t>
-                    </a:r>
-                  </a:p>
-                </c:rich>
-              </c:tx>
-              <c:dLblPos val="r"/>
-              <c:showLegendKey val="0"/>
-              <c:showVal val="0"/>
-              <c:showCatName val="0"/>
-              <c:showSerName val="0"/>
-              <c:showPercent val="0"/>
-              <c:showBubbleSize val="0"/>
-              <c:separator>; </c:separator>
-              <c:extLst>
-                <c:ext xmlns:c15="http://schemas.microsoft.com/office/drawing/2012/chart" uri="{CE6537A1-D6FC-4f65-9D91-7224C49458BB}">
-                  <c15:showDataLabelsRange val="1"/>
-                </c:ext>
-                <c:ext xmlns:c16="http://schemas.microsoft.com/office/drawing/2014/chart" uri="{C3380CC4-5D6E-409C-BE32-E72D297353CC}">
-                  <c16:uniqueId val="{00000009-33E4-2C4E-BF34-F4F568F22E82}"/>
-                </c:ext>
-              </c:extLst>
-            </c:dLbl>
-            <c:dLbl>
-              <c:idx val="10"/>
-              <c:tx>
-                <c:rich>
-                  <a:bodyPr/>
-                  <a:lstStyle/>
-                  <a:p>
-                    <a:r>
-                      <a:t>integrationtest-bazel</a:t>
-                    </a:r>
-                  </a:p>
-                </c:rich>
-              </c:tx>
-              <c:showLegendKey val="0"/>
-              <c:showVal val="1"/>
-              <c:showCatName val="0"/>
-              <c:showSerName val="0"/>
-              <c:showPercent val="0"/>
-              <c:showBubbleSize val="0"/>
-              <c:extLst>
-                <c:ext xmlns:c15="http://schemas.microsoft.com/office/drawing/2012/chart" uri="{CE6537A1-D6FC-4f65-9D91-7224C49458BB}">
-                  <c15:showDataLabelsRange val="0"/>
-                </c:ext>
-                <c:ext xmlns:c16="http://schemas.microsoft.com/office/drawing/2014/chart" uri="{C3380CC4-5D6E-409C-BE32-E72D297353CC}">
-                  <c16:uniqueId val="{0000000A-33E4-2C4E-BF34-F4F568F22E82}"/>
-                </c:ext>
-              </c:extLst>
-            </c:dLbl>
-            <c:dLbl>
-              <c:idx val="11"/>
-              <c:tx>
-                <c:rich>
-                  <a:bodyPr/>
-                  <a:lstStyle/>
-                  <a:p>
-                    <a:r>
-                      <a:t>integrationtest-electron</a:t>
                     </a:r>
                   </a:p>
                 </c:rich>
@@ -13109,25 +13109,25 @@
                   <c:v>0</c:v>
                 </c:pt>
                 <c:pt idx="1">
-                  <c:v>1013</c:v>
+                  <c:v>4</c:v>
                 </c:pt>
                 <c:pt idx="2">
-                  <c:v>0</c:v>
+                  <c:v>15</c:v>
                 </c:pt>
                 <c:pt idx="3">
-                  <c:v>15</c:v>
+                  <c:v>16</c:v>
                 </c:pt>
                 <c:pt idx="4">
-                  <c:v>41</c:v>
+                  <c:v>0</c:v>
                 </c:pt>
                 <c:pt idx="5">
                   <c:v>0</c:v>
                 </c:pt>
                 <c:pt idx="6">
-                  <c:v>16</c:v>
+                  <c:v>1013</c:v>
                 </c:pt>
                 <c:pt idx="7">
-                  <c:v>1</c:v>
+                  <c:v>41</c:v>
                 </c:pt>
                 <c:pt idx="8">
                   <c:v>24</c:v>
@@ -13136,10 +13136,10 @@
                   <c:v>0</c:v>
                 </c:pt>
                 <c:pt idx="10">
-                  <c:v>4</c:v>
+                  <c:v>0</c:v>
                 </c:pt>
                 <c:pt idx="11">
-                  <c:v>0</c:v>
+                  <c:v>1</c:v>
                 </c:pt>
               </c:numCache>
             </c:numRef>
@@ -13154,25 +13154,25 @@
                   <c:v>3.1</c:v>
                 </c:pt>
                 <c:pt idx="1">
+                  <c:v>2.4</c:v>
+                </c:pt>
+                <c:pt idx="2">
+                  <c:v>1.4</c:v>
+                </c:pt>
+                <c:pt idx="3">
+                  <c:v>1.5</c:v>
+                </c:pt>
+                <c:pt idx="4">
+                  <c:v>3.4</c:v>
+                </c:pt>
+                <c:pt idx="5">
+                  <c:v>5.5</c:v>
+                </c:pt>
+                <c:pt idx="6">
                   <c:v>2.6</c:v>
                 </c:pt>
-                <c:pt idx="2">
-                  <c:v>5.5</c:v>
-                </c:pt>
-                <c:pt idx="3">
-                  <c:v>1.4</c:v>
-                </c:pt>
-                <c:pt idx="4">
+                <c:pt idx="7">
                   <c:v>1.1</c:v>
-                </c:pt>
-                <c:pt idx="5">
-                  <c:v>3.4</c:v>
-                </c:pt>
-                <c:pt idx="6">
-                  <c:v>1.5</c:v>
-                </c:pt>
-                <c:pt idx="7">
-                  <c:v>3.1</c:v>
                 </c:pt>
                 <c:pt idx="8">
                   <c:v>1.9</c:v>
@@ -13181,10 +13181,10 @@
                   <c:v>3.1</c:v>
                 </c:pt>
                 <c:pt idx="10">
-                  <c:v>2.4</c:v>
+                  <c:v>3.4</c:v>
                 </c:pt>
                 <c:pt idx="11">
-                  <c:v>3.4</c:v>
+                  <c:v>3.1</c:v>
                 </c:pt>
               </c:numCache>
             </c:numRef>
@@ -13458,7 +13458,7 @@
                   <a:lstStyle/>
                   <a:p>
                     <a:r>
-                      <a:t>integrationtest-vscode</a:t>
+                      <a:t>integrationtest-airflow</a:t>
                     </a:r>
                   </a:p>
                 </c:rich>
@@ -13488,7 +13488,7 @@
                   <a:lstStyle/>
                   <a:p>
                     <a:r>
-                      <a:t>integrationtest-git</a:t>
+                      <a:t>integrationtest-bazel</a:t>
                     </a:r>
                   </a:p>
                 </c:rich>
@@ -13518,7 +13518,7 @@
                   <a:lstStyle/>
                   <a:p>
                     <a:r>
-                      <a:t>integrationtest-facebookyoga</a:t>
+                      <a:t>integrationtest-druid</a:t>
                     </a:r>
                   </a:p>
                 </c:rich>
@@ -13554,7 +13554,7 @@
                   <a:lstStyle/>
                   <a:p>
                     <a:r>
-                      <a:t>integrationtest-druid</a:t>
+                      <a:t>integrationtest-elasticsearch</a:t>
                     </a:r>
                   </a:p>
                 </c:rich>
@@ -13584,6 +13584,96 @@
                   <a:lstStyle/>
                   <a:p>
                     <a:r>
+                      <a:t>integrationtest-electron</a:t>
+                    </a:r>
+                  </a:p>
+                </c:rich>
+              </c:tx>
+              <c:dLblPos val="r"/>
+              <c:showLegendKey val="0"/>
+              <c:showVal val="0"/>
+              <c:showCatName val="0"/>
+              <c:showSerName val="0"/>
+              <c:showPercent val="0"/>
+              <c:showBubbleSize val="0"/>
+              <c:separator>; </c:separator>
+              <c:extLst>
+                <c:ext xmlns:c15="http://schemas.microsoft.com/office/drawing/2012/chart" uri="{CE6537A1-D6FC-4f65-9D91-7224C49458BB}">
+                  <c15:showDataLabelsRange val="1"/>
+                </c:ext>
+                <c:ext xmlns:c16="http://schemas.microsoft.com/office/drawing/2014/chart" uri="{C3380CC4-5D6E-409C-BE32-E72D297353CC}">
+                  <c16:uniqueId val="{00000004-33E4-2C4E-BF34-F4F568F22E82}"/>
+                </c:ext>
+              </c:extLst>
+            </c:dLbl>
+            <c:dLbl>
+              <c:idx val="5"/>
+              <c:tx>
+                <c:rich>
+                  <a:bodyPr/>
+                  <a:lstStyle/>
+                  <a:p>
+                    <a:r>
+                      <a:t>integrationtest-facebookyoga</a:t>
+                    </a:r>
+                  </a:p>
+                </c:rich>
+              </c:tx>
+              <c:dLblPos val="r"/>
+              <c:showLegendKey val="0"/>
+              <c:showVal val="0"/>
+              <c:showCatName val="0"/>
+              <c:showSerName val="0"/>
+              <c:showPercent val="0"/>
+              <c:showBubbleSize val="0"/>
+              <c:separator>; </c:separator>
+              <c:extLst>
+                <c:ext xmlns:c15="http://schemas.microsoft.com/office/drawing/2012/chart" uri="{CE6537A1-D6FC-4f65-9D91-7224C49458BB}">
+                  <c15:showDataLabelsRange val="1"/>
+                </c:ext>
+                <c:ext xmlns:c16="http://schemas.microsoft.com/office/drawing/2014/chart" uri="{C3380CC4-5D6E-409C-BE32-E72D297353CC}">
+                  <c16:uniqueId val="{00000005-33E4-2C4E-BF34-F4F568F22E82}"/>
+                </c:ext>
+              </c:extLst>
+            </c:dLbl>
+            <c:dLbl>
+              <c:idx val="6"/>
+              <c:tx>
+                <c:rich>
+                  <a:bodyPr/>
+                  <a:lstStyle/>
+                  <a:p>
+                    <a:r>
+                      <a:t>integrationtest-git</a:t>
+                    </a:r>
+                  </a:p>
+                </c:rich>
+              </c:tx>
+              <c:dLblPos val="r"/>
+              <c:showLegendKey val="0"/>
+              <c:showVal val="0"/>
+              <c:showCatName val="0"/>
+              <c:showSerName val="0"/>
+              <c:showPercent val="0"/>
+              <c:showBubbleSize val="0"/>
+              <c:separator>; </c:separator>
+              <c:extLst>
+                <c:ext xmlns:c15="http://schemas.microsoft.com/office/drawing/2012/chart" uri="{CE6537A1-D6FC-4f65-9D91-7224C49458BB}">
+                  <c15:showDataLabelsRange val="1"/>
+                </c:ext>
+                <c:ext xmlns:c16="http://schemas.microsoft.com/office/drawing/2014/chart" uri="{C3380CC4-5D6E-409C-BE32-E72D297353CC}">
+                  <c16:uniqueId val="{00000006-33E4-2C4E-BF34-F4F568F22E82}"/>
+                </c:ext>
+              </c:extLst>
+            </c:dLbl>
+            <c:dLbl>
+              <c:idx val="7"/>
+              <c:tx>
+                <c:rich>
+                  <a:bodyPr/>
+                  <a:lstStyle/>
+                  <a:p>
+                    <a:r>
                       <a:t>integrationtest-jruby</a:t>
                     </a:r>
                   </a:p>
@@ -13602,12 +13692,72 @@
                   <c15:showDataLabelsRange val="1"/>
                 </c:ext>
                 <c:ext xmlns:c16="http://schemas.microsoft.com/office/drawing/2014/chart" uri="{C3380CC4-5D6E-409C-BE32-E72D297353CC}">
-                  <c16:uniqueId val="{00000004-33E4-2C4E-BF34-F4F568F22E82}"/>
-                </c:ext>
-              </c:extLst>
-            </c:dLbl>
-            <c:dLbl>
-              <c:idx val="5"/>
+                  <c16:uniqueId val="{00000007-33E4-2C4E-BF34-F4F568F22E82}"/>
+                </c:ext>
+              </c:extLst>
+            </c:dLbl>
+            <c:dLbl>
+              <c:idx val="8"/>
+              <c:tx>
+                <c:rich>
+                  <a:bodyPr/>
+                  <a:lstStyle/>
+                  <a:p>
+                    <a:r>
+                      <a:t>integrationtest-kafka</a:t>
+                    </a:r>
+                  </a:p>
+                </c:rich>
+              </c:tx>
+              <c:dLblPos val="r"/>
+              <c:showLegendKey val="0"/>
+              <c:showVal val="0"/>
+              <c:showCatName val="0"/>
+              <c:showSerName val="0"/>
+              <c:showPercent val="0"/>
+              <c:showBubbleSize val="0"/>
+              <c:separator>; </c:separator>
+              <c:extLst>
+                <c:ext xmlns:c15="http://schemas.microsoft.com/office/drawing/2012/chart" uri="{CE6537A1-D6FC-4f65-9D91-7224C49458BB}">
+                  <c15:showDataLabelsRange val="1"/>
+                </c:ext>
+                <c:ext xmlns:c16="http://schemas.microsoft.com/office/drawing/2014/chart" uri="{C3380CC4-5D6E-409C-BE32-E72D297353CC}">
+                  <c16:uniqueId val="{00000008-33E4-2C4E-BF34-F4F568F22E82}"/>
+                </c:ext>
+              </c:extLst>
+            </c:dLbl>
+            <c:dLbl>
+              <c:idx val="9"/>
+              <c:tx>
+                <c:rich>
+                  <a:bodyPr/>
+                  <a:lstStyle/>
+                  <a:p>
+                    <a:r>
+                      <a:t>integrationtest-vscode</a:t>
+                    </a:r>
+                  </a:p>
+                </c:rich>
+              </c:tx>
+              <c:dLblPos val="r"/>
+              <c:showLegendKey val="0"/>
+              <c:showVal val="0"/>
+              <c:showCatName val="0"/>
+              <c:showSerName val="0"/>
+              <c:showPercent val="0"/>
+              <c:showBubbleSize val="0"/>
+              <c:separator>; </c:separator>
+              <c:extLst>
+                <c:ext xmlns:c15="http://schemas.microsoft.com/office/drawing/2012/chart" uri="{CE6537A1-D6FC-4f65-9D91-7224C49458BB}">
+                  <c15:showDataLabelsRange val="1"/>
+                </c:ext>
+                <c:ext xmlns:c16="http://schemas.microsoft.com/office/drawing/2014/chart" uri="{C3380CC4-5D6E-409C-BE32-E72D297353CC}">
+                  <c16:uniqueId val="{00000009-33E4-2C4E-BF34-F4F568F22E82}"/>
+                </c:ext>
+              </c:extLst>
+            </c:dLbl>
+            <c:dLbl>
+              <c:idx val="10"/>
               <c:tx>
                 <c:rich>
                   <a:bodyPr/>
@@ -13619,55 +13769,23 @@
                   </a:p>
                 </c:rich>
               </c:tx>
-              <c:dLblPos val="r"/>
-              <c:showLegendKey val="0"/>
-              <c:showVal val="0"/>
-              <c:showCatName val="0"/>
-              <c:showSerName val="0"/>
-              <c:showPercent val="0"/>
-              <c:showBubbleSize val="0"/>
-              <c:separator>; </c:separator>
-              <c:extLst>
-                <c:ext xmlns:c15="http://schemas.microsoft.com/office/drawing/2012/chart" uri="{CE6537A1-D6FC-4f65-9D91-7224C49458BB}">
-                  <c15:showDataLabelsRange val="1"/>
-                </c:ext>
-                <c:ext xmlns:c16="http://schemas.microsoft.com/office/drawing/2014/chart" uri="{C3380CC4-5D6E-409C-BE32-E72D297353CC}">
-                  <c16:uniqueId val="{00000005-33E4-2C4E-BF34-F4F568F22E82}"/>
-                </c:ext>
-              </c:extLst>
-            </c:dLbl>
-            <c:dLbl>
-              <c:idx val="6"/>
-              <c:tx>
-                <c:rich>
-                  <a:bodyPr/>
-                  <a:lstStyle/>
-                  <a:p>
-                    <a:r>
-                      <a:t>integrationtest-elasticsearch</a:t>
-                    </a:r>
-                  </a:p>
-                </c:rich>
-              </c:tx>
-              <c:dLblPos val="r"/>
-              <c:showLegendKey val="0"/>
-              <c:showVal val="0"/>
-              <c:showCatName val="0"/>
-              <c:showSerName val="0"/>
-              <c:showPercent val="0"/>
-              <c:showBubbleSize val="0"/>
-              <c:separator>; </c:separator>
-              <c:extLst>
-                <c:ext xmlns:c15="http://schemas.microsoft.com/office/drawing/2012/chart" uri="{CE6537A1-D6FC-4f65-9D91-7224C49458BB}">
-                  <c15:showDataLabelsRange val="1"/>
-                </c:ext>
-                <c:ext xmlns:c16="http://schemas.microsoft.com/office/drawing/2014/chart" uri="{C3380CC4-5D6E-409C-BE32-E72D297353CC}">
-                  <c16:uniqueId val="{00000006-33E4-2C4E-BF34-F4F568F22E82}"/>
-                </c:ext>
-              </c:extLst>
-            </c:dLbl>
-            <c:dLbl>
-              <c:idx val="7"/>
+              <c:showLegendKey val="0"/>
+              <c:showVal val="1"/>
+              <c:showCatName val="0"/>
+              <c:showSerName val="0"/>
+              <c:showPercent val="0"/>
+              <c:showBubbleSize val="0"/>
+              <c:extLst>
+                <c:ext xmlns:c15="http://schemas.microsoft.com/office/drawing/2012/chart" uri="{CE6537A1-D6FC-4f65-9D91-7224C49458BB}">
+                  <c15:showDataLabelsRange val="0"/>
+                </c:ext>
+                <c:ext xmlns:c16="http://schemas.microsoft.com/office/drawing/2014/chart" uri="{C3380CC4-5D6E-409C-BE32-E72D297353CC}">
+                  <c16:uniqueId val="{0000000A-33E4-2C4E-BF34-F4F568F22E82}"/>
+                </c:ext>
+              </c:extLst>
+            </c:dLbl>
+            <c:dLbl>
+              <c:idx val="11"/>
               <c:tx>
                 <c:rich>
                   <a:bodyPr/>
@@ -13675,124 +13793,6 @@
                   <a:p>
                     <a:r>
                       <a:t>integrationtest-zuul</a:t>
-                    </a:r>
-                  </a:p>
-                </c:rich>
-              </c:tx>
-              <c:dLblPos val="r"/>
-              <c:showLegendKey val="0"/>
-              <c:showVal val="0"/>
-              <c:showCatName val="0"/>
-              <c:showSerName val="0"/>
-              <c:showPercent val="0"/>
-              <c:showBubbleSize val="0"/>
-              <c:separator>; </c:separator>
-              <c:extLst>
-                <c:ext xmlns:c15="http://schemas.microsoft.com/office/drawing/2012/chart" uri="{CE6537A1-D6FC-4f65-9D91-7224C49458BB}">
-                  <c15:showDataLabelsRange val="1"/>
-                </c:ext>
-                <c:ext xmlns:c16="http://schemas.microsoft.com/office/drawing/2014/chart" uri="{C3380CC4-5D6E-409C-BE32-E72D297353CC}">
-                  <c16:uniqueId val="{00000007-33E4-2C4E-BF34-F4F568F22E82}"/>
-                </c:ext>
-              </c:extLst>
-            </c:dLbl>
-            <c:dLbl>
-              <c:idx val="8"/>
-              <c:tx>
-                <c:rich>
-                  <a:bodyPr/>
-                  <a:lstStyle/>
-                  <a:p>
-                    <a:r>
-                      <a:t>integrationtest-kafka</a:t>
-                    </a:r>
-                  </a:p>
-                </c:rich>
-              </c:tx>
-              <c:dLblPos val="r"/>
-              <c:showLegendKey val="0"/>
-              <c:showVal val="0"/>
-              <c:showCatName val="0"/>
-              <c:showSerName val="0"/>
-              <c:showPercent val="0"/>
-              <c:showBubbleSize val="0"/>
-              <c:separator>; </c:separator>
-              <c:extLst>
-                <c:ext xmlns:c15="http://schemas.microsoft.com/office/drawing/2012/chart" uri="{CE6537A1-D6FC-4f65-9D91-7224C49458BB}">
-                  <c15:showDataLabelsRange val="1"/>
-                </c:ext>
-                <c:ext xmlns:c16="http://schemas.microsoft.com/office/drawing/2014/chart" uri="{C3380CC4-5D6E-409C-BE32-E72D297353CC}">
-                  <c16:uniqueId val="{00000008-33E4-2C4E-BF34-F4F568F22E82}"/>
-                </c:ext>
-              </c:extLst>
-            </c:dLbl>
-            <c:dLbl>
-              <c:idx val="9"/>
-              <c:tx>
-                <c:rich>
-                  <a:bodyPr/>
-                  <a:lstStyle/>
-                  <a:p>
-                    <a:r>
-                      <a:t>integrationtest-airflow</a:t>
-                    </a:r>
-                  </a:p>
-                </c:rich>
-              </c:tx>
-              <c:dLblPos val="r"/>
-              <c:showLegendKey val="0"/>
-              <c:showVal val="0"/>
-              <c:showCatName val="0"/>
-              <c:showSerName val="0"/>
-              <c:showPercent val="0"/>
-              <c:showBubbleSize val="0"/>
-              <c:separator>; </c:separator>
-              <c:extLst>
-                <c:ext xmlns:c15="http://schemas.microsoft.com/office/drawing/2012/chart" uri="{CE6537A1-D6FC-4f65-9D91-7224C49458BB}">
-                  <c15:showDataLabelsRange val="1"/>
-                </c:ext>
-                <c:ext xmlns:c16="http://schemas.microsoft.com/office/drawing/2014/chart" uri="{C3380CC4-5D6E-409C-BE32-E72D297353CC}">
-                  <c16:uniqueId val="{00000009-33E4-2C4E-BF34-F4F568F22E82}"/>
-                </c:ext>
-              </c:extLst>
-            </c:dLbl>
-            <c:dLbl>
-              <c:idx val="10"/>
-              <c:tx>
-                <c:rich>
-                  <a:bodyPr/>
-                  <a:lstStyle/>
-                  <a:p>
-                    <a:r>
-                      <a:t>integrationtest-bazel</a:t>
-                    </a:r>
-                  </a:p>
-                </c:rich>
-              </c:tx>
-              <c:showLegendKey val="0"/>
-              <c:showVal val="1"/>
-              <c:showCatName val="0"/>
-              <c:showSerName val="0"/>
-              <c:showPercent val="0"/>
-              <c:showBubbleSize val="0"/>
-              <c:extLst>
-                <c:ext xmlns:c15="http://schemas.microsoft.com/office/drawing/2012/chart" uri="{CE6537A1-D6FC-4f65-9D91-7224C49458BB}">
-                  <c15:showDataLabelsRange val="0"/>
-                </c:ext>
-                <c:ext xmlns:c16="http://schemas.microsoft.com/office/drawing/2014/chart" uri="{C3380CC4-5D6E-409C-BE32-E72D297353CC}">
-                  <c16:uniqueId val="{0000000A-33E4-2C4E-BF34-F4F568F22E82}"/>
-                </c:ext>
-              </c:extLst>
-            </c:dLbl>
-            <c:dLbl>
-              <c:idx val="11"/>
-              <c:tx>
-                <c:rich>
-                  <a:bodyPr/>
-                  <a:lstStyle/>
-                  <a:p>
-                    <a:r>
-                      <a:t>integrationtest-electron</a:t>
                     </a:r>
                   </a:p>
                 </c:rich>
@@ -16212,25 +16212,25 @@
                   <c:v>0</c:v>
                 </c:pt>
                 <c:pt idx="1">
-                  <c:v>0</c:v>
+                  <c:v>8</c:v>
                 </c:pt>
                 <c:pt idx="2">
-                  <c:v>0</c:v>
+                  <c:v>110</c:v>
                 </c:pt>
                 <c:pt idx="3">
-                  <c:v>110</c:v>
+                  <c:v>1</c:v>
                 </c:pt>
                 <c:pt idx="4">
-                  <c:v>92</c:v>
+                  <c:v>0</c:v>
                 </c:pt>
                 <c:pt idx="5">
                   <c:v>0</c:v>
                 </c:pt>
                 <c:pt idx="6">
-                  <c:v>1</c:v>
+                  <c:v>0</c:v>
                 </c:pt>
                 <c:pt idx="7">
-                  <c:v>2</c:v>
+                  <c:v>92</c:v>
                 </c:pt>
                 <c:pt idx="8">
                   <c:v>191</c:v>
@@ -16239,10 +16239,10 @@
                   <c:v>0</c:v>
                 </c:pt>
                 <c:pt idx="10">
-                  <c:v>8</c:v>
+                  <c:v>0</c:v>
                 </c:pt>
                 <c:pt idx="11">
-                  <c:v>0</c:v>
+                  <c:v>2</c:v>
                 </c:pt>
               </c:numCache>
             </c:numRef>
@@ -16254,40 +16254,40 @@
                 <c:formatCode>General</c:formatCode>
                 <c:ptCount val="12"/>
                 <c:pt idx="0">
-                  <c:v>0.37003177753814737</c:v>
+                  <c:v>1.3833017183820222</c:v>
                 </c:pt>
                 <c:pt idx="1">
+                  <c:v>0.9735727184331157</c:v>
+                </c:pt>
+                <c:pt idx="2">
+                  <c:v>0.7158149801669627</c:v>
+                </c:pt>
+                <c:pt idx="3">
+                  <c:v>0.7272545364860646</c:v>
+                </c:pt>
+                <c:pt idx="4">
+                  <c:v>0.4023615750105847</c:v>
+                </c:pt>
+                <c:pt idx="5">
+                  <c:v>3.6938153752411904</c:v>
+                </c:pt>
+                <c:pt idx="6">
                   <c:v>0.0017429295159303757</c:v>
                 </c:pt>
-                <c:pt idx="2">
-                  <c:v>3.6938153752411904</c:v>
-                </c:pt>
-                <c:pt idx="3">
-                  <c:v>0.7158149801669627</c:v>
-                </c:pt>
-                <c:pt idx="4">
+                <c:pt idx="7">
                   <c:v>1.6848604048738367</c:v>
-                </c:pt>
-                <c:pt idx="5">
-                  <c:v>0.6528559266471607</c:v>
-                </c:pt>
-                <c:pt idx="6">
-                  <c:v>0.7272545364860646</c:v>
-                </c:pt>
-                <c:pt idx="7">
-                  <c:v>0.5290492957746479</c:v>
                 </c:pt>
                 <c:pt idx="8">
                   <c:v>1.5559151628411991</c:v>
                 </c:pt>
                 <c:pt idx="9">
-                  <c:v>1.3833017183820222</c:v>
+                  <c:v>0.37003177753814737</c:v>
                 </c:pt>
                 <c:pt idx="10">
-                  <c:v>0.9735727184331157</c:v>
+                  <c:v>0.6528559266471607</c:v>
                 </c:pt>
                 <c:pt idx="11">
-                  <c:v>0.4023615750105847</c:v>
+                  <c:v>0.5290492957746479</c:v>
                 </c:pt>
               </c:numCache>
             </c:numRef>

</xml_diff>

<commit_message>
Recreate integration tests for volatile api endpoints
</commit_message>
<xml_diff>
--- a/tests/report_generator/integration/references/reference_npr-5333-overview.pptx
+++ b/tests/report_generator/integration/references/reference_npr-5333-overview.pptx
@@ -3795,40 +3795,40 @@
                 <c:formatCode>General</c:formatCode>
                 <c:ptCount val="12"/>
                 <c:pt idx="0">
-                  <c:v>453</c:v>
+                  <c:v>2</c:v>
                 </c:pt>
                 <c:pt idx="1">
-                  <c:v>17</c:v>
+                  <c:v>2</c:v>
                 </c:pt>
                 <c:pt idx="2">
-                  <c:v>96</c:v>
+                  <c:v>2</c:v>
                 </c:pt>
                 <c:pt idx="3">
-                  <c:v>14</c:v>
+                  <c:v>2</c:v>
                 </c:pt>
                 <c:pt idx="4">
-                  <c:v>34</c:v>
+                  <c:v>2</c:v>
                 </c:pt>
                 <c:pt idx="5">
-                  <c:v>0</c:v>
+                  <c:v>2</c:v>
                 </c:pt>
                 <c:pt idx="6">
-                  <c:v>1550</c:v>
+                  <c:v>2</c:v>
                 </c:pt>
                 <c:pt idx="7">
-                  <c:v>115</c:v>
+                  <c:v>2</c:v>
                 </c:pt>
                 <c:pt idx="8">
-                  <c:v>55</c:v>
+                  <c:v>2</c:v>
                 </c:pt>
                 <c:pt idx="9">
-                  <c:v>74</c:v>
+                  <c:v>2</c:v>
                 </c:pt>
                 <c:pt idx="10">
-                  <c:v>5</c:v>
+                  <c:v>2</c:v>
                 </c:pt>
                 <c:pt idx="11">
-                  <c:v>6</c:v>
+                  <c:v>2</c:v>
                 </c:pt>
               </c:numCache>
             </c:numRef>
@@ -3840,40 +3840,40 @@
                 <c:formatCode>General</c:formatCode>
                 <c:ptCount val="12"/>
                 <c:pt idx="0">
+                  <c:v>3.3</c:v>
+                </c:pt>
+                <c:pt idx="1">
+                  <c:v>4.5</c:v>
+                </c:pt>
+                <c:pt idx="2">
+                  <c:v>2.1</c:v>
+                </c:pt>
+                <c:pt idx="3">
+                  <c:v>4.5</c:v>
+                </c:pt>
+                <c:pt idx="4">
                   <c:v>1.5</c:v>
                 </c:pt>
-                <c:pt idx="1">
-                  <c:v>2.3</c:v>
-                </c:pt>
-                <c:pt idx="2">
-                  <c:v>1.9</c:v>
-                </c:pt>
-                <c:pt idx="3">
-                  <c:v>1.6</c:v>
-                </c:pt>
-                <c:pt idx="4">
-                  <c:v>2.4</c:v>
-                </c:pt>
                 <c:pt idx="5">
-                  <c:v>5.5</c:v>
+                  <c:v>2.1</c:v>
                 </c:pt>
                 <c:pt idx="6">
-                  <c:v>2.6</c:v>
+                  <c:v>3.9</c:v>
                 </c:pt>
                 <c:pt idx="7">
-                  <c:v>1.7</c:v>
+                  <c:v>2.7</c:v>
                 </c:pt>
                 <c:pt idx="8">
-                  <c:v>2.3</c:v>
+                  <c:v>2.7</c:v>
                 </c:pt>
                 <c:pt idx="9">
-                  <c:v>2.0</c:v>
+                  <c:v>3.9</c:v>
                 </c:pt>
                 <c:pt idx="10">
-                  <c:v>3.1</c:v>
+                  <c:v>3.3</c:v>
                 </c:pt>
                 <c:pt idx="11">
-                  <c:v>2.1</c:v>
+                  <c:v>1.5</c:v>
                 </c:pt>
               </c:numCache>
             </c:numRef>
@@ -3908,7 +3908,7 @@
         <c:axId val="1649584720"/>
         <c:scaling>
           <c:orientation val="minMax"/>
-          <c:max val="2000.0"/>
+          <c:max val="20.0"/>
           <c:min val="0.0"/>
         </c:scaling>
         <c:delete val="0"/>
@@ -6907,7 +6907,7 @@
                   <c:v>15</c:v>
                 </c:pt>
                 <c:pt idx="3">
-                  <c:v>8</c:v>
+                  <c:v>45</c:v>
                 </c:pt>
                 <c:pt idx="4">
                   <c:v>0</c:v>
@@ -6952,7 +6952,7 @@
                   <c:v>1.4</c:v>
                 </c:pt>
                 <c:pt idx="3">
-                  <c:v>1.8</c:v>
+                  <c:v>1.1</c:v>
                 </c:pt>
                 <c:pt idx="4">
                   <c:v>3.4</c:v>
@@ -7280,6 +7280,36 @@
                   <a:lstStyle/>
                   <a:p>
                     <a:r>
+                      <a:t>integrationtest-elasticsearch</a:t>
+                    </a:r>
+                  </a:p>
+                </c:rich>
+              </c:tx>
+              <c:dLblPos val="r"/>
+              <c:showLegendKey val="0"/>
+              <c:showVal val="0"/>
+              <c:showCatName val="0"/>
+              <c:showSerName val="0"/>
+              <c:showPercent val="0"/>
+              <c:showBubbleSize val="0"/>
+              <c:separator>; </c:separator>
+              <c:extLst>
+                <c:ext xmlns:c15="http://schemas.microsoft.com/office/drawing/2012/chart" uri="{CE6537A1-D6FC-4f65-9D91-7224C49458BB}">
+                  <c15:showDataLabelsRange val="1"/>
+                </c:ext>
+                <c:ext xmlns:c16="http://schemas.microsoft.com/office/drawing/2014/chart" uri="{C3380CC4-5D6E-409C-BE32-E72D297353CC}">
+                  <c16:uniqueId val="{00000001-33E4-2C4E-BF34-F4F568F22E82}"/>
+                </c:ext>
+              </c:extLst>
+            </c:dLbl>
+            <c:dLbl>
+              <c:idx val="2"/>
+              <c:tx>
+                <c:rich>
+                  <a:bodyPr/>
+                  <a:lstStyle/>
+                  <a:p>
+                    <a:r>
                       <a:t>integrationtest-druid</a:t>
                     </a:r>
                   </a:p>
@@ -7298,12 +7328,18 @@
                   <c15:showDataLabelsRange val="1"/>
                 </c:ext>
                 <c:ext xmlns:c16="http://schemas.microsoft.com/office/drawing/2014/chart" uri="{C3380CC4-5D6E-409C-BE32-E72D297353CC}">
-                  <c16:uniqueId val="{00000001-33E4-2C4E-BF34-F4F568F22E82}"/>
+                  <c16:uniqueId val="{00000002-33E4-2C4E-BF34-F4F568F22E82}"/>
                 </c:ext>
               </c:extLst>
             </c:dLbl>
             <c:dLbl>
-              <c:idx val="2"/>
+              <c:idx val="3"/>
+              <c:layout>
+                <c:manualLayout>
+                  <c:x val="-2.3413399101154898E-2"/>
+                  <c:y val="-4.5616973413873718E-2"/>
+                </c:manualLayout>
+              </c:layout>
               <c:tx>
                 <c:rich>
                   <a:bodyPr/>
@@ -7328,18 +7364,12 @@
                   <c15:showDataLabelsRange val="1"/>
                 </c:ext>
                 <c:ext xmlns:c16="http://schemas.microsoft.com/office/drawing/2014/chart" uri="{C3380CC4-5D6E-409C-BE32-E72D297353CC}">
-                  <c16:uniqueId val="{00000002-33E4-2C4E-BF34-F4F568F22E82}"/>
+                  <c16:uniqueId val="{00000003-33E4-2C4E-BF34-F4F568F22E82}"/>
                 </c:ext>
               </c:extLst>
             </c:dLbl>
             <c:dLbl>
-              <c:idx val="3"/>
-              <c:layout>
-                <c:manualLayout>
-                  <c:x val="-2.3413399101154898E-2"/>
-                  <c:y val="-4.5616973413873718E-2"/>
-                </c:manualLayout>
-              </c:layout>
+              <c:idx val="4"/>
               <c:tx>
                 <c:rich>
                   <a:bodyPr/>
@@ -7364,36 +7394,6 @@
                   <c15:showDataLabelsRange val="1"/>
                 </c:ext>
                 <c:ext xmlns:c16="http://schemas.microsoft.com/office/drawing/2014/chart" uri="{C3380CC4-5D6E-409C-BE32-E72D297353CC}">
-                  <c16:uniqueId val="{00000003-33E4-2C4E-BF34-F4F568F22E82}"/>
-                </c:ext>
-              </c:extLst>
-            </c:dLbl>
-            <c:dLbl>
-              <c:idx val="4"/>
-              <c:tx>
-                <c:rich>
-                  <a:bodyPr/>
-                  <a:lstStyle/>
-                  <a:p>
-                    <a:r>
-                      <a:t>integrationtest-zuul</a:t>
-                    </a:r>
-                  </a:p>
-                </c:rich>
-              </c:tx>
-              <c:dLblPos val="r"/>
-              <c:showLegendKey val="0"/>
-              <c:showVal val="0"/>
-              <c:showCatName val="0"/>
-              <c:showSerName val="0"/>
-              <c:showPercent val="0"/>
-              <c:showBubbleSize val="0"/>
-              <c:separator>; </c:separator>
-              <c:extLst>
-                <c:ext xmlns:c15="http://schemas.microsoft.com/office/drawing/2012/chart" uri="{CE6537A1-D6FC-4f65-9D91-7224C49458BB}">
-                  <c15:showDataLabelsRange val="1"/>
-                </c:ext>
-                <c:ext xmlns:c16="http://schemas.microsoft.com/office/drawing/2014/chart" uri="{C3380CC4-5D6E-409C-BE32-E72D297353CC}">
                   <c16:uniqueId val="{00000004-33E4-2C4E-BF34-F4F568F22E82}"/>
                 </c:ext>
               </c:extLst>
@@ -7406,7 +7406,7 @@
                   <a:lstStyle/>
                   <a:p>
                     <a:r>
-                      <a:t>integrationtest-elasticsearch</a:t>
+                      <a:t>integrationtest-zuul</a:t>
                     </a:r>
                   </a:p>
                 </c:rich>
@@ -10001,40 +10001,40 @@
                 <c:formatCode>General</c:formatCode>
                 <c:ptCount val="12"/>
                 <c:pt idx="0">
-                  <c:v>191</c:v>
+                  <c:v>193</c:v>
                 </c:pt>
                 <c:pt idx="1">
-                  <c:v>110</c:v>
+                  <c:v>141</c:v>
                 </c:pt>
                 <c:pt idx="2">
-                  <c:v>92</c:v>
+                  <c:v>112</c:v>
                 </c:pt>
                 <c:pt idx="3">
-                  <c:v>8</c:v>
+                  <c:v>94</c:v>
                 </c:pt>
                 <c:pt idx="4">
+                  <c:v>10</c:v>
+                </c:pt>
+                <c:pt idx="5">
+                  <c:v>4</c:v>
+                </c:pt>
+                <c:pt idx="6">
+                  <c:v>3</c:v>
+                </c:pt>
+                <c:pt idx="7">
                   <c:v>2</c:v>
                 </c:pt>
-                <c:pt idx="5">
-                  <c:v>1</c:v>
-                </c:pt>
-                <c:pt idx="6">
-                  <c:v>1</c:v>
-                </c:pt>
-                <c:pt idx="7">
-                  <c:v>0</c:v>
-                </c:pt>
                 <c:pt idx="8">
-                  <c:v>0</c:v>
+                  <c:v>2</c:v>
                 </c:pt>
                 <c:pt idx="9">
-                  <c:v>0</c:v>
+                  <c:v>2</c:v>
                 </c:pt>
                 <c:pt idx="10">
-                  <c:v>0</c:v>
+                  <c:v>2</c:v>
                 </c:pt>
                 <c:pt idx="11">
-                  <c:v>0</c:v>
+                  <c:v>2</c:v>
                 </c:pt>
               </c:numCache>
             </c:numRef>
@@ -10049,19 +10049,19 @@
                   <c:v>1.5559151628411991</c:v>
                 </c:pt>
                 <c:pt idx="1">
+                  <c:v>0.7272545364860646</c:v>
+                </c:pt>
+                <c:pt idx="2">
                   <c:v>0.7158149801669627</c:v>
                 </c:pt>
-                <c:pt idx="2">
+                <c:pt idx="3">
                   <c:v>1.6848604048738367</c:v>
                 </c:pt>
-                <c:pt idx="3">
+                <c:pt idx="4">
                   <c:v>0.9735727184331157</c:v>
                 </c:pt>
-                <c:pt idx="4">
+                <c:pt idx="5">
                   <c:v>0.5290492957746479</c:v>
-                </c:pt>
-                <c:pt idx="5">
-                  <c:v>0.7272545364860646</c:v>
                 </c:pt>
                 <c:pt idx="6">
                   <c:v>0.37003177753814737</c:v>
@@ -32270,7 +32270,7 @@
                             <a:schemeClr val="tx1"/>
                           </a:solidFill>
                         </a:rPr>
-                        <a:t>integrationtest-git</a:t>
+                        <a:t>integrationtest-airflow</a:t>
                       </a:r>
                       <a:endParaRPr lang="en-US" sz="1200" b="0" i="0" u="none" strike="noStrike" noProof="0" dirty="0">
                         <a:solidFill>
@@ -32346,7 +32346,7 @@
                             <a:schemeClr val="tx1"/>
                           </a:solidFill>
                         </a:rPr>
-                        <a:t>1550</a:t>
+                        <a:t>2</a:t>
                       </a:r>
                       <a:endParaRPr lang="en-US" sz="1200" b="0" i="0" u="none" strike="noStrike" kern="1200" noProof="0" dirty="0">
                         <a:solidFill>
@@ -32373,7 +32373,7 @@
                             <a:schemeClr val="tx1"/>
                           </a:solidFill>
                         </a:rPr>
-                        <a:t>2.6★</a:t>
+                        <a:t>3.3★</a:t>
                       </a:r>
                       <a:endParaRPr lang="en-US" sz="1200" b="0" i="0" u="none" strike="noStrike" noProof="0" dirty="0">
                         <a:solidFill>
@@ -32433,7 +32433,7 @@
                             <a:schemeClr val="tx1"/>
                           </a:solidFill>
                         </a:rPr>
-                        <a:t>integrationtest-airflow</a:t>
+                        <a:t>integrationtest-bazel</a:t>
                       </a:r>
                       <a:endParaRPr lang="en-US" sz="1200" b="0" i="0" u="none" strike="noStrike" noProof="0" dirty="0">
                         <a:solidFill>
@@ -32518,7 +32518,7 @@
                             <a:schemeClr val="tx1"/>
                           </a:solidFill>
                         </a:rPr>
-                        <a:t>453</a:t>
+                        <a:t>2</a:t>
                       </a:r>
                       <a:endParaRPr lang="en-US" sz="1200" b="0" i="0" u="none" strike="noStrike" kern="1200" noProof="0" dirty="0">
                         <a:solidFill>
@@ -32561,7 +32561,7 @@
                             <a:schemeClr val="tx1"/>
                           </a:solidFill>
                         </a:rPr>
-                        <a:t>1.5★</a:t>
+                        <a:t>4.5★</a:t>
                       </a:r>
                       <a:endParaRPr lang="en-US" sz="1200" b="0" i="0" u="none" strike="noStrike" noProof="0" dirty="0">
                         <a:solidFill>
@@ -32605,6 +32605,884 @@
                 <a:extLst>
                   <a:ext uri="{0D108BD9-81ED-4DB2-BD59-A6C34878D82A}">
                     <a16:rowId xmlns:a16="http://schemas.microsoft.com/office/drawing/2014/main" val="10002"/>
+                  </a:ext>
+                </a:extLst>
+              </a:tr>
+              <a:tr h="279736">
+                <a:tc>
+                  <a:txBody>
+                    <a:bodyPr/>
+                    <a:lstStyle/>
+                    <a:p>
+                      <a:pPr algn="l" fontAlgn="b"/>
+                      <a:r>
+                        <a:rPr b="0" sz="1200" u="none">
+                          <a:solidFill>
+                            <a:schemeClr val="tx1"/>
+                          </a:solidFill>
+                        </a:rPr>
+                        <a:t>integrationtest-druid</a:t>
+                      </a:r>
+                      <a:endParaRPr lang="en-US" sz="1200" b="0" i="0" u="none" strike="noStrike" noProof="0" dirty="0">
+                        <a:solidFill>
+                          <a:schemeClr val="tx1"/>
+                        </a:solidFill>
+                        <a:effectLst/>
+                        <a:latin typeface="Calibri Regular"/>
+                      </a:endParaRPr>
+                    </a:p>
+                  </a:txBody>
+                  <a:tcPr marL="108000" marR="108000" marT="72000" marB="72000" anchor="ctr"/>
+                </a:tc>
+                <a:tc>
+                  <a:txBody>
+                    <a:bodyPr/>
+                    <a:lstStyle/>
+                    <a:p>
+                      <a:pPr marL="0" marR="0" lvl="0" indent="0" algn="ctr" defTabSz="914400" rtl="0" eaLnBrk="1" fontAlgn="b" latinLnBrk="0" hangingPunct="1">
+                        <a:lnSpc>
+                          <a:spcPct val="100000"/>
+                        </a:lnSpc>
+                        <a:spcBef>
+                          <a:spcPts val="0"/>
+                        </a:spcBef>
+                        <a:spcAft>
+                          <a:spcPts val="0"/>
+                        </a:spcAft>
+                        <a:buClrTx/>
+                        <a:buSzTx/>
+                        <a:buFontTx/>
+                        <a:buNone/>
+                        <a:tabLst/>
+                        <a:defRPr/>
+                      </a:pPr>
+                      <a:r>
+                        <a:rPr b="0" i="0" sz="1200" u="none">
+                          <a:solidFill>
+                            <a:schemeClr val="tx1"/>
+                          </a:solidFill>
+                          <a:latin typeface="Calibri Bold"/>
+                        </a:rPr>
+                        <a:t>N/A</a:t>
+                      </a:r>
+                      <a:endParaRPr lang="en-US" sz="1200" b="0" i="0" u="none" strike="noStrike" kern="1200" noProof="0" dirty="0">
+                        <a:solidFill>
+                          <a:schemeClr val="tx1"/>
+                        </a:solidFill>
+                        <a:effectLst/>
+                        <a:latin typeface="Calibri Bold"/>
+                        <a:ea typeface="+mn-ea"/>
+                        <a:cs typeface="+mn-cs"/>
+                      </a:endParaRPr>
+                    </a:p>
+                  </a:txBody>
+                  <a:tcPr marL="108000" marR="108000" marT="72000" marB="72000" anchor="ctr"/>
+                </a:tc>
+                <a:tc>
+                  <a:txBody>
+                    <a:bodyPr/>
+                    <a:lstStyle/>
+                    <a:p>
+                      <a:pPr marL="0" marR="0" lvl="0" indent="0" algn="ctr" defTabSz="914400" rtl="0" eaLnBrk="1" fontAlgn="b" latinLnBrk="0" hangingPunct="1">
+                        <a:lnSpc>
+                          <a:spcPct val="100000"/>
+                        </a:lnSpc>
+                        <a:spcBef>
+                          <a:spcPts val="0"/>
+                        </a:spcBef>
+                        <a:spcAft>
+                          <a:spcPts val="0"/>
+                        </a:spcAft>
+                        <a:buClrTx/>
+                        <a:buSzTx/>
+                        <a:buFontTx/>
+                        <a:buNone/>
+                        <a:tabLst/>
+                        <a:defRPr/>
+                      </a:pPr>
+                      <a:r>
+                        <a:rPr b="0" sz="1200" u="none">
+                          <a:solidFill>
+                            <a:schemeClr val="tx1"/>
+                          </a:solidFill>
+                        </a:rPr>
+                        <a:t>2</a:t>
+                      </a:r>
+                      <a:endParaRPr lang="en-US" sz="1200" b="0" i="0" u="none" strike="noStrike" kern="1200" noProof="0" dirty="0">
+                        <a:solidFill>
+                          <a:schemeClr val="tx1"/>
+                        </a:solidFill>
+                        <a:effectLst/>
+                        <a:latin typeface="Calibri Bold"/>
+                        <a:ea typeface="+mn-ea"/>
+                        <a:cs typeface="+mn-cs"/>
+                      </a:endParaRPr>
+                    </a:p>
+                  </a:txBody>
+                  <a:tcPr marL="108000" marR="108000" marT="72000" marB="72000" anchor="ctr"/>
+                </a:tc>
+                <a:tc>
+                  <a:txBody>
+                    <a:bodyPr/>
+                    <a:lstStyle/>
+                    <a:p>
+                      <a:pPr algn="ctr" fontAlgn="b"/>
+                      <a:r>
+                        <a:rPr b="0" sz="1200" u="none">
+                          <a:solidFill>
+                            <a:schemeClr val="tx1"/>
+                          </a:solidFill>
+                        </a:rPr>
+                        <a:t>2.1★</a:t>
+                      </a:r>
+                      <a:endParaRPr lang="en-US" sz="1200" b="0" i="0" u="none" strike="noStrike" noProof="0" dirty="0">
+                        <a:solidFill>
+                          <a:schemeClr val="tx1"/>
+                        </a:solidFill>
+                        <a:effectLst/>
+                        <a:latin typeface="Calibri Regular"/>
+                      </a:endParaRPr>
+                    </a:p>
+                  </a:txBody>
+                  <a:tcPr marL="108000" marR="108000" marT="72000" marB="72000" anchor="ctr"/>
+                </a:tc>
+                <a:tc>
+                  <a:txBody>
+                    <a:bodyPr/>
+                    <a:lstStyle/>
+                    <a:p>
+                      <a:pPr marL="0" algn="ctr" defTabSz="914400" rtl="0" eaLnBrk="1" fontAlgn="b" latinLnBrk="0" hangingPunct="1"/>
+                      <a:r>
+                        <a:rPr b="0" sz="1200" u="none">
+                          <a:solidFill>
+                            <a:schemeClr val="tx1"/>
+                          </a:solidFill>
+                          <a:hlinkClick r:id="rId4"/>
+                        </a:rPr>
+                        <a:t>link</a:t>
+                      </a:r>
+                      <a:endParaRPr lang="en-US" sz="1200" b="0" i="0" u="none" strike="noStrike" kern="1200" noProof="0" dirty="0">
+                        <a:solidFill>
+                          <a:schemeClr val="tx1"/>
+                        </a:solidFill>
+                        <a:effectLst/>
+                        <a:latin typeface="Calibri Regular"/>
+                        <a:ea typeface="+mn-ea"/>
+                        <a:cs typeface="+mn-cs"/>
+                      </a:endParaRPr>
+                    </a:p>
+                  </a:txBody>
+                  <a:tcPr marL="108000" marR="108000" marT="72000" marB="72000" anchor="ctr"/>
+                </a:tc>
+                <a:extLst>
+                  <a:ext uri="{0D108BD9-81ED-4DB2-BD59-A6C34878D82A}">
+                    <a16:rowId xmlns:a16="http://schemas.microsoft.com/office/drawing/2014/main" val="10003"/>
+                  </a:ext>
+                </a:extLst>
+              </a:tr>
+              <a:tr h="279736">
+                <a:tc>
+                  <a:txBody>
+                    <a:bodyPr/>
+                    <a:lstStyle/>
+                    <a:p>
+                      <a:pPr algn="l" fontAlgn="b"/>
+                      <a:r>
+                        <a:rPr b="0" sz="1200" u="none">
+                          <a:solidFill>
+                            <a:schemeClr val="tx1"/>
+                          </a:solidFill>
+                        </a:rPr>
+                        <a:t>integrationtest-elasticsearch</a:t>
+                      </a:r>
+                      <a:endParaRPr lang="en-US" sz="1200" b="0" i="0" u="none" strike="noStrike" noProof="0" dirty="0">
+                        <a:solidFill>
+                          <a:schemeClr val="tx1"/>
+                        </a:solidFill>
+                        <a:effectLst/>
+                        <a:latin typeface="Calibri Regular"/>
+                      </a:endParaRPr>
+                    </a:p>
+                  </a:txBody>
+                  <a:tcPr marL="108000" marR="108000" marT="72000" marB="72000" anchor="ctr"/>
+                </a:tc>
+                <a:tc>
+                  <a:txBody>
+                    <a:bodyPr/>
+                    <a:lstStyle/>
+                    <a:p>
+                      <a:pPr marL="0" marR="0" lvl="0" indent="0" algn="ctr" defTabSz="914400" rtl="0" eaLnBrk="1" fontAlgn="b" latinLnBrk="0" hangingPunct="1">
+                        <a:lnSpc>
+                          <a:spcPct val="100000"/>
+                        </a:lnSpc>
+                        <a:spcBef>
+                          <a:spcPts val="0"/>
+                        </a:spcBef>
+                        <a:spcAft>
+                          <a:spcPts val="0"/>
+                        </a:spcAft>
+                        <a:buClrTx/>
+                        <a:buSzTx/>
+                        <a:buFontTx/>
+                        <a:buNone/>
+                        <a:tabLst/>
+                        <a:defRPr/>
+                      </a:pPr>
+                      <a:r>
+                        <a:rPr b="0" i="0" sz="1200" u="none">
+                          <a:solidFill>
+                            <a:schemeClr val="tx1"/>
+                          </a:solidFill>
+                          <a:latin typeface="Calibri Bold"/>
+                        </a:rPr>
+                        <a:t>N/A</a:t>
+                      </a:r>
+                      <a:endParaRPr lang="en-US" sz="1200" b="0" i="0" u="none" strike="noStrike" kern="1200" noProof="0" dirty="0">
+                        <a:solidFill>
+                          <a:schemeClr val="tx1"/>
+                        </a:solidFill>
+                        <a:effectLst/>
+                        <a:latin typeface="Calibri Bold"/>
+                        <a:ea typeface="+mn-ea"/>
+                        <a:cs typeface="+mn-cs"/>
+                      </a:endParaRPr>
+                    </a:p>
+                  </a:txBody>
+                  <a:tcPr marL="108000" marR="108000" marT="72000" marB="72000" anchor="ctr"/>
+                </a:tc>
+                <a:tc>
+                  <a:txBody>
+                    <a:bodyPr/>
+                    <a:lstStyle/>
+                    <a:p>
+                      <a:pPr marL="0" marR="0" lvl="0" indent="0" algn="ctr" defTabSz="914400" rtl="0" eaLnBrk="1" fontAlgn="b" latinLnBrk="0" hangingPunct="1">
+                        <a:lnSpc>
+                          <a:spcPct val="100000"/>
+                        </a:lnSpc>
+                        <a:spcBef>
+                          <a:spcPts val="0"/>
+                        </a:spcBef>
+                        <a:spcAft>
+                          <a:spcPts val="0"/>
+                        </a:spcAft>
+                        <a:buClrTx/>
+                        <a:buSzTx/>
+                        <a:buFontTx/>
+                        <a:buNone/>
+                        <a:tabLst/>
+                        <a:defRPr/>
+                      </a:pPr>
+                      <a:r>
+                        <a:rPr b="0" sz="1200" u="none">
+                          <a:solidFill>
+                            <a:schemeClr val="tx1"/>
+                          </a:solidFill>
+                        </a:rPr>
+                        <a:t>2</a:t>
+                      </a:r>
+                      <a:endParaRPr lang="en-US" sz="1200" b="0" i="0" u="none" strike="noStrike" kern="1200" noProof="0" dirty="0">
+                        <a:solidFill>
+                          <a:schemeClr val="tx1"/>
+                        </a:solidFill>
+                        <a:effectLst/>
+                        <a:latin typeface="Calibri Bold"/>
+                        <a:ea typeface="+mn-ea"/>
+                        <a:cs typeface="+mn-cs"/>
+                      </a:endParaRPr>
+                    </a:p>
+                  </a:txBody>
+                  <a:tcPr marL="108000" marR="108000" marT="72000" marB="72000" anchor="ctr"/>
+                </a:tc>
+                <a:tc>
+                  <a:txBody>
+                    <a:bodyPr/>
+                    <a:lstStyle/>
+                    <a:p>
+                      <a:pPr marL="0" marR="0" lvl="0" indent="0" algn="ctr" defTabSz="914400" rtl="0" eaLnBrk="1" fontAlgn="b" latinLnBrk="0" hangingPunct="1">
+                        <a:lnSpc>
+                          <a:spcPct val="100000"/>
+                        </a:lnSpc>
+                        <a:spcBef>
+                          <a:spcPts val="0"/>
+                        </a:spcBef>
+                        <a:spcAft>
+                          <a:spcPts val="0"/>
+                        </a:spcAft>
+                        <a:buClrTx/>
+                        <a:buSzTx/>
+                        <a:buFontTx/>
+                        <a:buNone/>
+                        <a:tabLst/>
+                        <a:defRPr/>
+                      </a:pPr>
+                      <a:r>
+                        <a:rPr b="0" sz="1200" u="none">
+                          <a:solidFill>
+                            <a:schemeClr val="tx1"/>
+                          </a:solidFill>
+                        </a:rPr>
+                        <a:t>4.5★</a:t>
+                      </a:r>
+                      <a:endParaRPr lang="en-US" sz="1200" b="0" i="0" u="none" strike="noStrike" kern="1200" noProof="0" dirty="0">
+                        <a:solidFill>
+                          <a:schemeClr val="tx1"/>
+                        </a:solidFill>
+                        <a:effectLst/>
+                        <a:latin typeface="Calibri Bold"/>
+                        <a:ea typeface="+mn-ea"/>
+                        <a:cs typeface="+mn-cs"/>
+                      </a:endParaRPr>
+                    </a:p>
+                  </a:txBody>
+                  <a:tcPr marL="108000" marR="108000" marT="72000" marB="72000" anchor="ctr"/>
+                </a:tc>
+                <a:tc>
+                  <a:txBody>
+                    <a:bodyPr/>
+                    <a:lstStyle/>
+                    <a:p>
+                      <a:pPr marL="0" algn="ctr" defTabSz="914400" rtl="0" eaLnBrk="1" fontAlgn="b" latinLnBrk="0" hangingPunct="1"/>
+                      <a:r>
+                        <a:rPr b="0" sz="1200" u="none">
+                          <a:solidFill>
+                            <a:schemeClr val="tx1"/>
+                          </a:solidFill>
+                          <a:hlinkClick r:id="rId5"/>
+                        </a:rPr>
+                        <a:t>link</a:t>
+                      </a:r>
+                      <a:endParaRPr lang="en-US" sz="1200" b="0" i="0" u="none" strike="noStrike" kern="1200" noProof="0" dirty="0">
+                        <a:solidFill>
+                          <a:schemeClr val="tx1"/>
+                        </a:solidFill>
+                        <a:effectLst/>
+                        <a:latin typeface="Calibri Regular"/>
+                        <a:ea typeface="+mn-ea"/>
+                        <a:cs typeface="+mn-cs"/>
+                      </a:endParaRPr>
+                    </a:p>
+                  </a:txBody>
+                  <a:tcPr marL="108000" marR="108000" marT="72000" marB="72000" anchor="ctr"/>
+                </a:tc>
+                <a:extLst>
+                  <a:ext uri="{0D108BD9-81ED-4DB2-BD59-A6C34878D82A}">
+                    <a16:rowId xmlns:a16="http://schemas.microsoft.com/office/drawing/2014/main" val="10004"/>
+                  </a:ext>
+                </a:extLst>
+              </a:tr>
+              <a:tr h="279736">
+                <a:tc>
+                  <a:txBody>
+                    <a:bodyPr/>
+                    <a:lstStyle/>
+                    <a:p>
+                      <a:pPr algn="l" fontAlgn="b"/>
+                      <a:r>
+                        <a:rPr b="0" sz="1200" u="none">
+                          <a:solidFill>
+                            <a:schemeClr val="tx1"/>
+                          </a:solidFill>
+                        </a:rPr>
+                        <a:t>integrationtest-electron</a:t>
+                      </a:r>
+                      <a:endParaRPr lang="en-US" sz="1200" b="0" i="0" u="none" strike="noStrike" noProof="0" dirty="0">
+                        <a:solidFill>
+                          <a:schemeClr val="tx1"/>
+                        </a:solidFill>
+                        <a:effectLst/>
+                        <a:latin typeface="Calibri Regular"/>
+                      </a:endParaRPr>
+                    </a:p>
+                  </a:txBody>
+                  <a:tcPr marL="108000" marR="108000" marT="72000" marB="72000" anchor="ctr"/>
+                </a:tc>
+                <a:tc>
+                  <a:txBody>
+                    <a:bodyPr/>
+                    <a:lstStyle/>
+                    <a:p>
+                      <a:pPr marL="0" marR="0" lvl="0" indent="0" algn="ctr" defTabSz="914400" rtl="0" eaLnBrk="1" fontAlgn="b" latinLnBrk="0" hangingPunct="1">
+                        <a:lnSpc>
+                          <a:spcPct val="100000"/>
+                        </a:lnSpc>
+                        <a:spcBef>
+                          <a:spcPts val="0"/>
+                        </a:spcBef>
+                        <a:spcAft>
+                          <a:spcPts val="0"/>
+                        </a:spcAft>
+                        <a:buClrTx/>
+                        <a:buSzTx/>
+                        <a:buFontTx/>
+                        <a:buNone/>
+                        <a:tabLst/>
+                        <a:defRPr/>
+                      </a:pPr>
+                      <a:r>
+                        <a:rPr b="0" i="0" sz="1200" u="none">
+                          <a:solidFill>
+                            <a:schemeClr val="tx1"/>
+                          </a:solidFill>
+                          <a:latin typeface="Calibri Bold"/>
+                        </a:rPr>
+                        <a:t>N/A</a:t>
+                      </a:r>
+                      <a:endParaRPr lang="en-US" sz="1200" b="0" i="0" u="none" strike="noStrike" kern="1200" noProof="0" dirty="0">
+                        <a:solidFill>
+                          <a:schemeClr val="tx1"/>
+                        </a:solidFill>
+                        <a:effectLst/>
+                        <a:latin typeface="Calibri Bold"/>
+                        <a:ea typeface="+mn-ea"/>
+                        <a:cs typeface="+mn-cs"/>
+                      </a:endParaRPr>
+                    </a:p>
+                  </a:txBody>
+                  <a:tcPr marL="108000" marR="108000" marT="72000" marB="72000" anchor="ctr"/>
+                </a:tc>
+                <a:tc>
+                  <a:txBody>
+                    <a:bodyPr/>
+                    <a:lstStyle/>
+                    <a:p>
+                      <a:pPr marL="0" marR="0" lvl="0" indent="0" algn="ctr" defTabSz="914400" rtl="0" eaLnBrk="1" fontAlgn="b" latinLnBrk="0" hangingPunct="1">
+                        <a:lnSpc>
+                          <a:spcPct val="100000"/>
+                        </a:lnSpc>
+                        <a:spcBef>
+                          <a:spcPts val="0"/>
+                        </a:spcBef>
+                        <a:spcAft>
+                          <a:spcPts val="0"/>
+                        </a:spcAft>
+                        <a:buClrTx/>
+                        <a:buSzTx/>
+                        <a:buFontTx/>
+                        <a:buNone/>
+                        <a:tabLst/>
+                        <a:defRPr/>
+                      </a:pPr>
+                      <a:r>
+                        <a:rPr b="0" sz="1200" u="none">
+                          <a:solidFill>
+                            <a:schemeClr val="tx1"/>
+                          </a:solidFill>
+                        </a:rPr>
+                        <a:t>2</a:t>
+                      </a:r>
+                      <a:endParaRPr lang="en-US" sz="1200" b="0" i="0" u="none" strike="noStrike" kern="1200" noProof="0" dirty="0">
+                        <a:solidFill>
+                          <a:schemeClr val="tx1"/>
+                        </a:solidFill>
+                        <a:effectLst/>
+                        <a:latin typeface="Calibri Bold"/>
+                        <a:ea typeface="+mn-ea"/>
+                        <a:cs typeface="+mn-cs"/>
+                      </a:endParaRPr>
+                    </a:p>
+                  </a:txBody>
+                  <a:tcPr marL="108000" marR="108000" marT="72000" marB="72000" anchor="ctr"/>
+                </a:tc>
+                <a:tc>
+                  <a:txBody>
+                    <a:bodyPr/>
+                    <a:lstStyle/>
+                    <a:p>
+                      <a:pPr algn="ctr" fontAlgn="b"/>
+                      <a:r>
+                        <a:rPr b="0" sz="1200" u="none">
+                          <a:solidFill>
+                            <a:schemeClr val="tx1"/>
+                          </a:solidFill>
+                        </a:rPr>
+                        <a:t>1.5★</a:t>
+                      </a:r>
+                      <a:endParaRPr lang="en-US" sz="1200" b="0" i="0" u="none" strike="noStrike" noProof="0" dirty="0">
+                        <a:solidFill>
+                          <a:schemeClr val="tx1"/>
+                        </a:solidFill>
+                        <a:effectLst/>
+                        <a:latin typeface="Calibri Regular"/>
+                      </a:endParaRPr>
+                    </a:p>
+                  </a:txBody>
+                  <a:tcPr marL="108000" marR="108000" marT="72000" marB="72000" anchor="ctr"/>
+                </a:tc>
+                <a:tc>
+                  <a:txBody>
+                    <a:bodyPr/>
+                    <a:lstStyle/>
+                    <a:p>
+                      <a:pPr marL="0" algn="ctr" defTabSz="914400" rtl="0" eaLnBrk="1" fontAlgn="b" latinLnBrk="0" hangingPunct="1"/>
+                      <a:r>
+                        <a:rPr b="0" sz="1200" u="none">
+                          <a:solidFill>
+                            <a:schemeClr val="tx1"/>
+                          </a:solidFill>
+                          <a:hlinkClick r:id="rId6"/>
+                        </a:rPr>
+                        <a:t>link</a:t>
+                      </a:r>
+                      <a:endParaRPr lang="en-US" sz="1200" b="0" i="0" u="none" strike="noStrike" kern="1200" noProof="0" dirty="0">
+                        <a:solidFill>
+                          <a:schemeClr val="tx1"/>
+                        </a:solidFill>
+                        <a:effectLst/>
+                        <a:latin typeface="Calibri Regular"/>
+                        <a:ea typeface="+mn-ea"/>
+                        <a:cs typeface="+mn-cs"/>
+                      </a:endParaRPr>
+                    </a:p>
+                  </a:txBody>
+                  <a:tcPr marL="108000" marR="108000" marT="72000" marB="72000" anchor="ctr"/>
+                </a:tc>
+                <a:extLst>
+                  <a:ext uri="{0D108BD9-81ED-4DB2-BD59-A6C34878D82A}">
+                    <a16:rowId xmlns:a16="http://schemas.microsoft.com/office/drawing/2014/main" val="2001900654"/>
+                  </a:ext>
+                </a:extLst>
+              </a:tr>
+              <a:tr h="279736">
+                <a:tc>
+                  <a:txBody>
+                    <a:bodyPr/>
+                    <a:lstStyle/>
+                    <a:p>
+                      <a:pPr algn="l" fontAlgn="b"/>
+                      <a:r>
+                        <a:rPr b="0" sz="1200" u="none">
+                          <a:solidFill>
+                            <a:schemeClr val="tx1"/>
+                          </a:solidFill>
+                        </a:rPr>
+                        <a:t>integrationtest-facebookyoga</a:t>
+                      </a:r>
+                      <a:endParaRPr lang="en-US" sz="1200" b="0" i="0" u="none" strike="noStrike" noProof="0" dirty="0">
+                        <a:solidFill>
+                          <a:schemeClr val="tx1"/>
+                        </a:solidFill>
+                        <a:effectLst/>
+                        <a:latin typeface="Calibri Regular"/>
+                      </a:endParaRPr>
+                    </a:p>
+                  </a:txBody>
+                  <a:tcPr marL="108000" marR="108000" marT="72000" marB="72000" anchor="ctr"/>
+                </a:tc>
+                <a:tc>
+                  <a:txBody>
+                    <a:bodyPr/>
+                    <a:lstStyle/>
+                    <a:p>
+                      <a:pPr marL="0" marR="0" lvl="0" indent="0" algn="ctr" defTabSz="914400" rtl="0" eaLnBrk="1" fontAlgn="b" latinLnBrk="0" hangingPunct="1">
+                        <a:lnSpc>
+                          <a:spcPct val="100000"/>
+                        </a:lnSpc>
+                        <a:spcBef>
+                          <a:spcPts val="0"/>
+                        </a:spcBef>
+                        <a:spcAft>
+                          <a:spcPts val="0"/>
+                        </a:spcAft>
+                        <a:buClrTx/>
+                        <a:buSzTx/>
+                        <a:buFontTx/>
+                        <a:buNone/>
+                        <a:tabLst/>
+                        <a:defRPr/>
+                      </a:pPr>
+                      <a:r>
+                        <a:rPr b="0" i="0" sz="1200" u="none">
+                          <a:solidFill>
+                            <a:schemeClr val="tx1"/>
+                          </a:solidFill>
+                          <a:latin typeface="Calibri Bold"/>
+                        </a:rPr>
+                        <a:t>N/A</a:t>
+                      </a:r>
+                      <a:endParaRPr lang="en-US" sz="1200" b="0" i="0" u="none" strike="noStrike" kern="1200" noProof="0" dirty="0">
+                        <a:solidFill>
+                          <a:schemeClr val="tx1"/>
+                        </a:solidFill>
+                        <a:effectLst/>
+                        <a:latin typeface="Calibri Bold"/>
+                        <a:ea typeface="+mn-ea"/>
+                        <a:cs typeface="+mn-cs"/>
+                      </a:endParaRPr>
+                    </a:p>
+                  </a:txBody>
+                  <a:tcPr marL="108000" marR="108000" marT="72000" marB="72000" anchor="ctr"/>
+                </a:tc>
+                <a:tc>
+                  <a:txBody>
+                    <a:bodyPr/>
+                    <a:lstStyle/>
+                    <a:p>
+                      <a:pPr marL="0" marR="0" lvl="0" indent="0" algn="ctr" defTabSz="914400" rtl="0" eaLnBrk="1" fontAlgn="b" latinLnBrk="0" hangingPunct="1">
+                        <a:lnSpc>
+                          <a:spcPct val="100000"/>
+                        </a:lnSpc>
+                        <a:spcBef>
+                          <a:spcPts val="0"/>
+                        </a:spcBef>
+                        <a:spcAft>
+                          <a:spcPts val="0"/>
+                        </a:spcAft>
+                        <a:buClrTx/>
+                        <a:buSzTx/>
+                        <a:buFontTx/>
+                        <a:buNone/>
+                        <a:tabLst/>
+                        <a:defRPr/>
+                      </a:pPr>
+                      <a:r>
+                        <a:rPr b="0" sz="1200" u="none">
+                          <a:solidFill>
+                            <a:schemeClr val="tx1"/>
+                          </a:solidFill>
+                        </a:rPr>
+                        <a:t>2</a:t>
+                      </a:r>
+                      <a:endParaRPr lang="en-US" sz="1200" b="0" i="0" u="none" strike="noStrike" kern="1200" noProof="0" dirty="0">
+                        <a:solidFill>
+                          <a:schemeClr val="tx1"/>
+                        </a:solidFill>
+                        <a:effectLst/>
+                        <a:latin typeface="Calibri Bold"/>
+                        <a:ea typeface="+mn-ea"/>
+                        <a:cs typeface="+mn-cs"/>
+                      </a:endParaRPr>
+                    </a:p>
+                  </a:txBody>
+                  <a:tcPr marL="108000" marR="108000" marT="72000" marB="72000" anchor="ctr"/>
+                </a:tc>
+                <a:tc>
+                  <a:txBody>
+                    <a:bodyPr/>
+                    <a:lstStyle/>
+                    <a:p>
+                      <a:pPr algn="ctr" fontAlgn="b"/>
+                      <a:r>
+                        <a:rPr b="0" sz="1200" u="none">
+                          <a:solidFill>
+                            <a:schemeClr val="tx1"/>
+                          </a:solidFill>
+                        </a:rPr>
+                        <a:t>2.1★</a:t>
+                      </a:r>
+                      <a:endParaRPr lang="en-US" sz="1200" b="0" i="0" u="none" strike="noStrike" noProof="0" dirty="0">
+                        <a:solidFill>
+                          <a:schemeClr val="tx1"/>
+                        </a:solidFill>
+                        <a:effectLst/>
+                        <a:latin typeface="Calibri Regular"/>
+                      </a:endParaRPr>
+                    </a:p>
+                  </a:txBody>
+                  <a:tcPr marL="108000" marR="108000" marT="72000" marB="72000" anchor="ctr"/>
+                </a:tc>
+                <a:tc>
+                  <a:txBody>
+                    <a:bodyPr/>
+                    <a:lstStyle/>
+                    <a:p>
+                      <a:pPr marL="0" algn="ctr" defTabSz="914400" rtl="0" eaLnBrk="1" fontAlgn="b" latinLnBrk="0" hangingPunct="1"/>
+                      <a:r>
+                        <a:rPr b="0" sz="1200" u="none">
+                          <a:solidFill>
+                            <a:schemeClr val="tx1"/>
+                          </a:solidFill>
+                          <a:hlinkClick r:id="rId7"/>
+                        </a:rPr>
+                        <a:t>link</a:t>
+                      </a:r>
+                      <a:endParaRPr lang="en-US" sz="1200" b="0" i="0" u="none" strike="noStrike" kern="1200" noProof="0" dirty="0">
+                        <a:solidFill>
+                          <a:schemeClr val="tx1"/>
+                        </a:solidFill>
+                        <a:effectLst/>
+                        <a:latin typeface="Calibri Regular"/>
+                        <a:ea typeface="+mn-ea"/>
+                        <a:cs typeface="+mn-cs"/>
+                      </a:endParaRPr>
+                    </a:p>
+                  </a:txBody>
+                  <a:tcPr marL="108000" marR="108000" marT="72000" marB="72000" anchor="ctr"/>
+                </a:tc>
+                <a:extLst>
+                  <a:ext uri="{0D108BD9-81ED-4DB2-BD59-A6C34878D82A}">
+                    <a16:rowId xmlns:a16="http://schemas.microsoft.com/office/drawing/2014/main" val="928811833"/>
+                  </a:ext>
+                </a:extLst>
+              </a:tr>
+              <a:tr h="279736">
+                <a:tc>
+                  <a:txBody>
+                    <a:bodyPr/>
+                    <a:lstStyle/>
+                    <a:p>
+                      <a:pPr algn="l" fontAlgn="b"/>
+                      <a:r>
+                        <a:rPr b="0" sz="1200" u="none">
+                          <a:solidFill>
+                            <a:schemeClr val="tx1"/>
+                          </a:solidFill>
+                        </a:rPr>
+                        <a:t>integrationtest-git</a:t>
+                      </a:r>
+                      <a:endParaRPr lang="en-US" sz="1200" b="0" i="0" u="none" strike="noStrike" noProof="0" dirty="0">
+                        <a:solidFill>
+                          <a:schemeClr val="tx1"/>
+                        </a:solidFill>
+                        <a:effectLst/>
+                        <a:latin typeface="Calibri Regular"/>
+                      </a:endParaRPr>
+                    </a:p>
+                  </a:txBody>
+                  <a:tcPr marL="108000" marR="108000" marT="72000" marB="72000" anchor="ctr"/>
+                </a:tc>
+                <a:tc>
+                  <a:txBody>
+                    <a:bodyPr/>
+                    <a:lstStyle/>
+                    <a:p>
+                      <a:pPr marL="0" marR="0" lvl="0" indent="0" algn="ctr" defTabSz="914400" rtl="0" eaLnBrk="1" fontAlgn="b" latinLnBrk="0" hangingPunct="1">
+                        <a:lnSpc>
+                          <a:spcPct val="100000"/>
+                        </a:lnSpc>
+                        <a:spcBef>
+                          <a:spcPts val="0"/>
+                        </a:spcBef>
+                        <a:spcAft>
+                          <a:spcPts val="0"/>
+                        </a:spcAft>
+                        <a:buClrTx/>
+                        <a:buSzTx/>
+                        <a:buFontTx/>
+                        <a:buNone/>
+                        <a:tabLst/>
+                        <a:defRPr/>
+                      </a:pPr>
+                      <a:r>
+                        <a:rPr b="0" i="0" sz="1200" u="none">
+                          <a:solidFill>
+                            <a:schemeClr val="tx1"/>
+                          </a:solidFill>
+                          <a:latin typeface="Calibri Bold"/>
+                        </a:rPr>
+                        <a:t>N/A</a:t>
+                      </a:r>
+                      <a:endParaRPr lang="en-US" sz="1200" b="0" i="0" u="none" strike="noStrike" kern="1200" noProof="0" dirty="0">
+                        <a:solidFill>
+                          <a:schemeClr val="tx1"/>
+                        </a:solidFill>
+                        <a:effectLst/>
+                        <a:latin typeface="Calibri Bold"/>
+                        <a:ea typeface="+mn-ea"/>
+                        <a:cs typeface="+mn-cs"/>
+                      </a:endParaRPr>
+                    </a:p>
+                  </a:txBody>
+                  <a:tcPr marL="108000" marR="108000" marT="72000" marB="72000" anchor="ctr"/>
+                </a:tc>
+                <a:tc>
+                  <a:txBody>
+                    <a:bodyPr/>
+                    <a:lstStyle/>
+                    <a:p>
+                      <a:pPr marL="0" marR="0" lvl="0" indent="0" algn="ctr" defTabSz="914400" rtl="0" eaLnBrk="1" fontAlgn="b" latinLnBrk="0" hangingPunct="1">
+                        <a:lnSpc>
+                          <a:spcPct val="100000"/>
+                        </a:lnSpc>
+                        <a:spcBef>
+                          <a:spcPts val="0"/>
+                        </a:spcBef>
+                        <a:spcAft>
+                          <a:spcPts val="0"/>
+                        </a:spcAft>
+                        <a:buClrTx/>
+                        <a:buSzTx/>
+                        <a:buFontTx/>
+                        <a:buNone/>
+                        <a:tabLst/>
+                        <a:defRPr/>
+                      </a:pPr>
+                      <a:r>
+                        <a:rPr b="0" sz="1200" u="none">
+                          <a:solidFill>
+                            <a:schemeClr val="tx1"/>
+                          </a:solidFill>
+                        </a:rPr>
+                        <a:t>2</a:t>
+                      </a:r>
+                      <a:endParaRPr lang="en-US" sz="1200" b="0" i="0" u="none" strike="noStrike" kern="1200" noProof="0" dirty="0">
+                        <a:solidFill>
+                          <a:schemeClr val="tx1"/>
+                        </a:solidFill>
+                        <a:effectLst/>
+                        <a:latin typeface="Calibri Bold"/>
+                        <a:ea typeface="+mn-ea"/>
+                        <a:cs typeface="+mn-cs"/>
+                      </a:endParaRPr>
+                    </a:p>
+                  </a:txBody>
+                  <a:tcPr marL="108000" marR="108000" marT="72000" marB="72000" anchor="ctr"/>
+                </a:tc>
+                <a:tc>
+                  <a:txBody>
+                    <a:bodyPr/>
+                    <a:lstStyle/>
+                    <a:p>
+                      <a:pPr algn="ctr" fontAlgn="b"/>
+                      <a:r>
+                        <a:rPr b="0" sz="1200" u="none">
+                          <a:solidFill>
+                            <a:schemeClr val="tx1"/>
+                          </a:solidFill>
+                        </a:rPr>
+                        <a:t>3.9★</a:t>
+                      </a:r>
+                      <a:endParaRPr lang="en-US" sz="1200" b="0" i="0" u="none" strike="noStrike" noProof="0" dirty="0">
+                        <a:solidFill>
+                          <a:schemeClr val="tx1"/>
+                        </a:solidFill>
+                        <a:effectLst/>
+                        <a:latin typeface="Calibri Regular"/>
+                      </a:endParaRPr>
+                    </a:p>
+                  </a:txBody>
+                  <a:tcPr marL="108000" marR="108000" marT="72000" marB="72000" anchor="ctr"/>
+                </a:tc>
+                <a:tc>
+                  <a:txBody>
+                    <a:bodyPr/>
+                    <a:lstStyle/>
+                    <a:p>
+                      <a:pPr marL="0" algn="ctr" defTabSz="914400" rtl="0" eaLnBrk="1" fontAlgn="b" latinLnBrk="0" hangingPunct="1"/>
+                      <a:r>
+                        <a:rPr b="0" sz="1200" u="none">
+                          <a:solidFill>
+                            <a:schemeClr val="tx1"/>
+                          </a:solidFill>
+                          <a:hlinkClick r:id="rId8"/>
+                        </a:rPr>
+                        <a:t>link</a:t>
+                      </a:r>
+                      <a:endParaRPr lang="en-US" sz="1200" b="0" i="0" u="none" strike="noStrike" kern="1200" noProof="0" dirty="0">
+                        <a:solidFill>
+                          <a:schemeClr val="tx1"/>
+                        </a:solidFill>
+                        <a:effectLst/>
+                        <a:latin typeface="Calibri Regular"/>
+                        <a:ea typeface="+mn-ea"/>
+                        <a:cs typeface="+mn-cs"/>
+                      </a:endParaRPr>
+                    </a:p>
+                  </a:txBody>
+                  <a:tcPr marL="108000" marR="108000" marT="72000" marB="72000" anchor="ctr"/>
+                </a:tc>
+                <a:extLst>
+                  <a:ext uri="{0D108BD9-81ED-4DB2-BD59-A6C34878D82A}">
+                    <a16:rowId xmlns:a16="http://schemas.microsoft.com/office/drawing/2014/main" val="4060795780"/>
                   </a:ext>
                 </a:extLst>
               </a:tr>
@@ -32706,7 +33584,7 @@
                             <a:schemeClr val="tx1"/>
                           </a:solidFill>
                         </a:rPr>
-                        <a:t>115</a:t>
+                        <a:t>2</a:t>
                       </a:r>
                       <a:endParaRPr lang="en-US" sz="1200" b="0" i="0" u="none" strike="noStrike" kern="1200" noProof="0" dirty="0">
                         <a:solidFill>
@@ -32733,7 +33611,7 @@
                             <a:schemeClr val="tx1"/>
                           </a:solidFill>
                         </a:rPr>
-                        <a:t>1.7★</a:t>
+                        <a:t>2.7★</a:t>
                       </a:r>
                       <a:endParaRPr lang="en-US" sz="1200" b="0" i="0" u="none" strike="noStrike" noProof="0" dirty="0">
                         <a:solidFill>
@@ -32757,7 +33635,7 @@
                           <a:solidFill>
                             <a:schemeClr val="tx1"/>
                           </a:solidFill>
-                          <a:hlinkClick r:id="rId4"/>
+                          <a:hlinkClick r:id="rId9"/>
                         </a:rPr>
                         <a:t>link</a:t>
                       </a:r>
@@ -32776,7 +33654,7 @@
                 </a:tc>
                 <a:extLst>
                   <a:ext uri="{0D108BD9-81ED-4DB2-BD59-A6C34878D82A}">
-                    <a16:rowId xmlns:a16="http://schemas.microsoft.com/office/drawing/2014/main" val="10003"/>
+                    <a16:rowId xmlns:a16="http://schemas.microsoft.com/office/drawing/2014/main" val="933267410"/>
                   </a:ext>
                 </a:extLst>
               </a:tr>
@@ -32793,7 +33671,7 @@
                             <a:schemeClr val="tx1"/>
                           </a:solidFill>
                         </a:rPr>
-                        <a:t>integrationtest-druid</a:t>
+                        <a:t>integrationtest-kafka</a:t>
                       </a:r>
                       <a:endParaRPr lang="en-US" sz="1200" b="0" i="0" u="none" strike="noStrike" noProof="0" dirty="0">
                         <a:solidFill>
@@ -32878,7 +33756,7 @@
                             <a:schemeClr val="tx1"/>
                           </a:solidFill>
                         </a:rPr>
-                        <a:t>96</a:t>
+                        <a:t>2</a:t>
                       </a:r>
                       <a:endParaRPr lang="en-US" sz="1200" b="0" i="0" u="none" strike="noStrike" kern="1200" noProof="0" dirty="0">
                         <a:solidFill>
@@ -32898,39 +33776,21 @@
                     <a:bodyPr/>
                     <a:lstStyle/>
                     <a:p>
-                      <a:pPr marL="0" marR="0" lvl="0" indent="0" algn="ctr" defTabSz="914400" rtl="0" eaLnBrk="1" fontAlgn="b" latinLnBrk="0" hangingPunct="1">
-                        <a:lnSpc>
-                          <a:spcPct val="100000"/>
-                        </a:lnSpc>
-                        <a:spcBef>
-                          <a:spcPts val="0"/>
-                        </a:spcBef>
-                        <a:spcAft>
-                          <a:spcPts val="0"/>
-                        </a:spcAft>
-                        <a:buClrTx/>
-                        <a:buSzTx/>
-                        <a:buFontTx/>
-                        <a:buNone/>
-                        <a:tabLst/>
-                        <a:defRPr/>
-                      </a:pPr>
+                      <a:pPr algn="ctr" fontAlgn="b"/>
                       <a:r>
                         <a:rPr b="0" sz="1200" u="none">
                           <a:solidFill>
                             <a:schemeClr val="tx1"/>
                           </a:solidFill>
                         </a:rPr>
-                        <a:t>1.9★</a:t>
+                        <a:t>2.7★</a:t>
                       </a:r>
-                      <a:endParaRPr lang="en-US" sz="1200" b="0" i="0" u="none" strike="noStrike" kern="1200" noProof="0" dirty="0">
+                      <a:endParaRPr lang="en-US" sz="1200" b="0" i="0" u="none" strike="noStrike" noProof="0" dirty="0">
                         <a:solidFill>
                           <a:schemeClr val="tx1"/>
                         </a:solidFill>
                         <a:effectLst/>
-                        <a:latin typeface="Calibri Bold"/>
-                        <a:ea typeface="+mn-ea"/>
-                        <a:cs typeface="+mn-cs"/>
+                        <a:latin typeface="Calibri Regular"/>
                       </a:endParaRPr>
                     </a:p>
                   </a:txBody>
@@ -32947,7 +33807,7 @@
                           <a:solidFill>
                             <a:schemeClr val="tx1"/>
                           </a:solidFill>
-                          <a:hlinkClick r:id="rId5"/>
+                          <a:hlinkClick r:id="rId10"/>
                         </a:rPr>
                         <a:t>link</a:t>
                       </a:r>
@@ -32966,7 +33826,7 @@
                 </a:tc>
                 <a:extLst>
                   <a:ext uri="{0D108BD9-81ED-4DB2-BD59-A6C34878D82A}">
-                    <a16:rowId xmlns:a16="http://schemas.microsoft.com/office/drawing/2014/main" val="10004"/>
+                    <a16:rowId xmlns:a16="http://schemas.microsoft.com/office/drawing/2014/main" val="2009910387"/>
                   </a:ext>
                 </a:extLst>
               </a:tr>
@@ -33068,7 +33928,7 @@
                             <a:schemeClr val="tx1"/>
                           </a:solidFill>
                         </a:rPr>
-                        <a:t>74</a:t>
+                        <a:t>2</a:t>
                       </a:r>
                       <a:endParaRPr lang="en-US" sz="1200" b="0" i="0" u="none" strike="noStrike" kern="1200" noProof="0" dirty="0">
                         <a:solidFill>
@@ -33095,867 +33955,7 @@
                             <a:schemeClr val="tx1"/>
                           </a:solidFill>
                         </a:rPr>
-                        <a:t>2.0★</a:t>
-                      </a:r>
-                      <a:endParaRPr lang="en-US" sz="1200" b="0" i="0" u="none" strike="noStrike" noProof="0" dirty="0">
-                        <a:solidFill>
-                          <a:schemeClr val="tx1"/>
-                        </a:solidFill>
-                        <a:effectLst/>
-                        <a:latin typeface="Calibri Regular"/>
-                      </a:endParaRPr>
-                    </a:p>
-                  </a:txBody>
-                  <a:tcPr marL="108000" marR="108000" marT="72000" marB="72000" anchor="ctr"/>
-                </a:tc>
-                <a:tc>
-                  <a:txBody>
-                    <a:bodyPr/>
-                    <a:lstStyle/>
-                    <a:p>
-                      <a:pPr marL="0" algn="ctr" defTabSz="914400" rtl="0" eaLnBrk="1" fontAlgn="b" latinLnBrk="0" hangingPunct="1"/>
-                      <a:r>
-                        <a:rPr b="0" sz="1200" u="none">
-                          <a:solidFill>
-                            <a:schemeClr val="tx1"/>
-                          </a:solidFill>
-                          <a:hlinkClick r:id="rId6"/>
-                        </a:rPr>
-                        <a:t>link</a:t>
-                      </a:r>
-                      <a:endParaRPr lang="en-US" sz="1200" b="0" i="0" u="none" strike="noStrike" kern="1200" noProof="0" dirty="0">
-                        <a:solidFill>
-                          <a:schemeClr val="tx1"/>
-                        </a:solidFill>
-                        <a:effectLst/>
-                        <a:latin typeface="Calibri Regular"/>
-                        <a:ea typeface="+mn-ea"/>
-                        <a:cs typeface="+mn-cs"/>
-                      </a:endParaRPr>
-                    </a:p>
-                  </a:txBody>
-                  <a:tcPr marL="108000" marR="108000" marT="72000" marB="72000" anchor="ctr"/>
-                </a:tc>
-                <a:extLst>
-                  <a:ext uri="{0D108BD9-81ED-4DB2-BD59-A6C34878D82A}">
-                    <a16:rowId xmlns:a16="http://schemas.microsoft.com/office/drawing/2014/main" val="2001900654"/>
-                  </a:ext>
-                </a:extLst>
-              </a:tr>
-              <a:tr h="279736">
-                <a:tc>
-                  <a:txBody>
-                    <a:bodyPr/>
-                    <a:lstStyle/>
-                    <a:p>
-                      <a:pPr algn="l" fontAlgn="b"/>
-                      <a:r>
-                        <a:rPr b="0" sz="1200" u="none">
-                          <a:solidFill>
-                            <a:schemeClr val="tx1"/>
-                          </a:solidFill>
-                        </a:rPr>
-                        <a:t>integrationtest-kafka</a:t>
-                      </a:r>
-                      <a:endParaRPr lang="en-US" sz="1200" b="0" i="0" u="none" strike="noStrike" noProof="0" dirty="0">
-                        <a:solidFill>
-                          <a:schemeClr val="tx1"/>
-                        </a:solidFill>
-                        <a:effectLst/>
-                        <a:latin typeface="Calibri Regular"/>
-                      </a:endParaRPr>
-                    </a:p>
-                  </a:txBody>
-                  <a:tcPr marL="108000" marR="108000" marT="72000" marB="72000" anchor="ctr"/>
-                </a:tc>
-                <a:tc>
-                  <a:txBody>
-                    <a:bodyPr/>
-                    <a:lstStyle/>
-                    <a:p>
-                      <a:pPr marL="0" marR="0" lvl="0" indent="0" algn="ctr" defTabSz="914400" rtl="0" eaLnBrk="1" fontAlgn="b" latinLnBrk="0" hangingPunct="1">
-                        <a:lnSpc>
-                          <a:spcPct val="100000"/>
-                        </a:lnSpc>
-                        <a:spcBef>
-                          <a:spcPts val="0"/>
-                        </a:spcBef>
-                        <a:spcAft>
-                          <a:spcPts val="0"/>
-                        </a:spcAft>
-                        <a:buClrTx/>
-                        <a:buSzTx/>
-                        <a:buFontTx/>
-                        <a:buNone/>
-                        <a:tabLst/>
-                        <a:defRPr/>
-                      </a:pPr>
-                      <a:r>
-                        <a:rPr b="0" i="0" sz="1200" u="none">
-                          <a:solidFill>
-                            <a:schemeClr val="tx1"/>
-                          </a:solidFill>
-                          <a:latin typeface="Calibri Bold"/>
-                        </a:rPr>
-                        <a:t>N/A</a:t>
-                      </a:r>
-                      <a:endParaRPr lang="en-US" sz="1200" b="0" i="0" u="none" strike="noStrike" kern="1200" noProof="0" dirty="0">
-                        <a:solidFill>
-                          <a:schemeClr val="tx1"/>
-                        </a:solidFill>
-                        <a:effectLst/>
-                        <a:latin typeface="Calibri Bold"/>
-                        <a:ea typeface="+mn-ea"/>
-                        <a:cs typeface="+mn-cs"/>
-                      </a:endParaRPr>
-                    </a:p>
-                  </a:txBody>
-                  <a:tcPr marL="108000" marR="108000" marT="72000" marB="72000" anchor="ctr"/>
-                </a:tc>
-                <a:tc>
-                  <a:txBody>
-                    <a:bodyPr/>
-                    <a:lstStyle/>
-                    <a:p>
-                      <a:pPr marL="0" marR="0" lvl="0" indent="0" algn="ctr" defTabSz="914400" rtl="0" eaLnBrk="1" fontAlgn="b" latinLnBrk="0" hangingPunct="1">
-                        <a:lnSpc>
-                          <a:spcPct val="100000"/>
-                        </a:lnSpc>
-                        <a:spcBef>
-                          <a:spcPts val="0"/>
-                        </a:spcBef>
-                        <a:spcAft>
-                          <a:spcPts val="0"/>
-                        </a:spcAft>
-                        <a:buClrTx/>
-                        <a:buSzTx/>
-                        <a:buFontTx/>
-                        <a:buNone/>
-                        <a:tabLst/>
-                        <a:defRPr/>
-                      </a:pPr>
-                      <a:r>
-                        <a:rPr b="0" sz="1200" u="none">
-                          <a:solidFill>
-                            <a:schemeClr val="tx1"/>
-                          </a:solidFill>
-                        </a:rPr>
-                        <a:t>55</a:t>
-                      </a:r>
-                      <a:endParaRPr lang="en-US" sz="1200" b="0" i="0" u="none" strike="noStrike" kern="1200" noProof="0" dirty="0">
-                        <a:solidFill>
-                          <a:schemeClr val="tx1"/>
-                        </a:solidFill>
-                        <a:effectLst/>
-                        <a:latin typeface="Calibri Bold"/>
-                        <a:ea typeface="+mn-ea"/>
-                        <a:cs typeface="+mn-cs"/>
-                      </a:endParaRPr>
-                    </a:p>
-                  </a:txBody>
-                  <a:tcPr marL="108000" marR="108000" marT="72000" marB="72000" anchor="ctr"/>
-                </a:tc>
-                <a:tc>
-                  <a:txBody>
-                    <a:bodyPr/>
-                    <a:lstStyle/>
-                    <a:p>
-                      <a:pPr algn="ctr" fontAlgn="b"/>
-                      <a:r>
-                        <a:rPr b="0" sz="1200" u="none">
-                          <a:solidFill>
-                            <a:schemeClr val="tx1"/>
-                          </a:solidFill>
-                        </a:rPr>
-                        <a:t>2.3★</a:t>
-                      </a:r>
-                      <a:endParaRPr lang="en-US" sz="1200" b="0" i="0" u="none" strike="noStrike" noProof="0" dirty="0">
-                        <a:solidFill>
-                          <a:schemeClr val="tx1"/>
-                        </a:solidFill>
-                        <a:effectLst/>
-                        <a:latin typeface="Calibri Regular"/>
-                      </a:endParaRPr>
-                    </a:p>
-                  </a:txBody>
-                  <a:tcPr marL="108000" marR="108000" marT="72000" marB="72000" anchor="ctr"/>
-                </a:tc>
-                <a:tc>
-                  <a:txBody>
-                    <a:bodyPr/>
-                    <a:lstStyle/>
-                    <a:p>
-                      <a:pPr marL="0" algn="ctr" defTabSz="914400" rtl="0" eaLnBrk="1" fontAlgn="b" latinLnBrk="0" hangingPunct="1"/>
-                      <a:r>
-                        <a:rPr b="0" sz="1200" u="none">
-                          <a:solidFill>
-                            <a:schemeClr val="tx1"/>
-                          </a:solidFill>
-                          <a:hlinkClick r:id="rId7"/>
-                        </a:rPr>
-                        <a:t>link</a:t>
-                      </a:r>
-                      <a:endParaRPr lang="en-US" sz="1200" b="0" i="0" u="none" strike="noStrike" kern="1200" noProof="0" dirty="0">
-                        <a:solidFill>
-                          <a:schemeClr val="tx1"/>
-                        </a:solidFill>
-                        <a:effectLst/>
-                        <a:latin typeface="Calibri Regular"/>
-                        <a:ea typeface="+mn-ea"/>
-                        <a:cs typeface="+mn-cs"/>
-                      </a:endParaRPr>
-                    </a:p>
-                  </a:txBody>
-                  <a:tcPr marL="108000" marR="108000" marT="72000" marB="72000" anchor="ctr"/>
-                </a:tc>
-                <a:extLst>
-                  <a:ext uri="{0D108BD9-81ED-4DB2-BD59-A6C34878D82A}">
-                    <a16:rowId xmlns:a16="http://schemas.microsoft.com/office/drawing/2014/main" val="928811833"/>
-                  </a:ext>
-                </a:extLst>
-              </a:tr>
-              <a:tr h="279736">
-                <a:tc>
-                  <a:txBody>
-                    <a:bodyPr/>
-                    <a:lstStyle/>
-                    <a:p>
-                      <a:pPr algn="l" fontAlgn="b"/>
-                      <a:r>
-                        <a:rPr b="0" sz="1200" u="none">
-                          <a:solidFill>
-                            <a:schemeClr val="tx1"/>
-                          </a:solidFill>
-                        </a:rPr>
-                        <a:t>integrationtest-electron</a:t>
-                      </a:r>
-                      <a:endParaRPr lang="en-US" sz="1200" b="0" i="0" u="none" strike="noStrike" noProof="0" dirty="0">
-                        <a:solidFill>
-                          <a:schemeClr val="tx1"/>
-                        </a:solidFill>
-                        <a:effectLst/>
-                        <a:latin typeface="Calibri Regular"/>
-                      </a:endParaRPr>
-                    </a:p>
-                  </a:txBody>
-                  <a:tcPr marL="108000" marR="108000" marT="72000" marB="72000" anchor="ctr"/>
-                </a:tc>
-                <a:tc>
-                  <a:txBody>
-                    <a:bodyPr/>
-                    <a:lstStyle/>
-                    <a:p>
-                      <a:pPr marL="0" marR="0" lvl="0" indent="0" algn="ctr" defTabSz="914400" rtl="0" eaLnBrk="1" fontAlgn="b" latinLnBrk="0" hangingPunct="1">
-                        <a:lnSpc>
-                          <a:spcPct val="100000"/>
-                        </a:lnSpc>
-                        <a:spcBef>
-                          <a:spcPts val="0"/>
-                        </a:spcBef>
-                        <a:spcAft>
-                          <a:spcPts val="0"/>
-                        </a:spcAft>
-                        <a:buClrTx/>
-                        <a:buSzTx/>
-                        <a:buFontTx/>
-                        <a:buNone/>
-                        <a:tabLst/>
-                        <a:defRPr/>
-                      </a:pPr>
-                      <a:r>
-                        <a:rPr b="0" i="0" sz="1200" u="none">
-                          <a:solidFill>
-                            <a:schemeClr val="tx1"/>
-                          </a:solidFill>
-                          <a:latin typeface="Calibri Bold"/>
-                        </a:rPr>
-                        <a:t>N/A</a:t>
-                      </a:r>
-                      <a:endParaRPr lang="en-US" sz="1200" b="0" i="0" u="none" strike="noStrike" kern="1200" noProof="0" dirty="0">
-                        <a:solidFill>
-                          <a:schemeClr val="tx1"/>
-                        </a:solidFill>
-                        <a:effectLst/>
-                        <a:latin typeface="Calibri Bold"/>
-                        <a:ea typeface="+mn-ea"/>
-                        <a:cs typeface="+mn-cs"/>
-                      </a:endParaRPr>
-                    </a:p>
-                  </a:txBody>
-                  <a:tcPr marL="108000" marR="108000" marT="72000" marB="72000" anchor="ctr"/>
-                </a:tc>
-                <a:tc>
-                  <a:txBody>
-                    <a:bodyPr/>
-                    <a:lstStyle/>
-                    <a:p>
-                      <a:pPr marL="0" marR="0" lvl="0" indent="0" algn="ctr" defTabSz="914400" rtl="0" eaLnBrk="1" fontAlgn="b" latinLnBrk="0" hangingPunct="1">
-                        <a:lnSpc>
-                          <a:spcPct val="100000"/>
-                        </a:lnSpc>
-                        <a:spcBef>
-                          <a:spcPts val="0"/>
-                        </a:spcBef>
-                        <a:spcAft>
-                          <a:spcPts val="0"/>
-                        </a:spcAft>
-                        <a:buClrTx/>
-                        <a:buSzTx/>
-                        <a:buFontTx/>
-                        <a:buNone/>
-                        <a:tabLst/>
-                        <a:defRPr/>
-                      </a:pPr>
-                      <a:r>
-                        <a:rPr b="0" sz="1200" u="none">
-                          <a:solidFill>
-                            <a:schemeClr val="tx1"/>
-                          </a:solidFill>
-                        </a:rPr>
-                        <a:t>34</a:t>
-                      </a:r>
-                      <a:endParaRPr lang="en-US" sz="1200" b="0" i="0" u="none" strike="noStrike" kern="1200" noProof="0" dirty="0">
-                        <a:solidFill>
-                          <a:schemeClr val="tx1"/>
-                        </a:solidFill>
-                        <a:effectLst/>
-                        <a:latin typeface="Calibri Bold"/>
-                        <a:ea typeface="+mn-ea"/>
-                        <a:cs typeface="+mn-cs"/>
-                      </a:endParaRPr>
-                    </a:p>
-                  </a:txBody>
-                  <a:tcPr marL="108000" marR="108000" marT="72000" marB="72000" anchor="ctr"/>
-                </a:tc>
-                <a:tc>
-                  <a:txBody>
-                    <a:bodyPr/>
-                    <a:lstStyle/>
-                    <a:p>
-                      <a:pPr algn="ctr" fontAlgn="b"/>
-                      <a:r>
-                        <a:rPr b="0" sz="1200" u="none">
-                          <a:solidFill>
-                            <a:schemeClr val="tx1"/>
-                          </a:solidFill>
-                        </a:rPr>
-                        <a:t>2.4★</a:t>
-                      </a:r>
-                      <a:endParaRPr lang="en-US" sz="1200" b="0" i="0" u="none" strike="noStrike" noProof="0" dirty="0">
-                        <a:solidFill>
-                          <a:schemeClr val="tx1"/>
-                        </a:solidFill>
-                        <a:effectLst/>
-                        <a:latin typeface="Calibri Regular"/>
-                      </a:endParaRPr>
-                    </a:p>
-                  </a:txBody>
-                  <a:tcPr marL="108000" marR="108000" marT="72000" marB="72000" anchor="ctr"/>
-                </a:tc>
-                <a:tc>
-                  <a:txBody>
-                    <a:bodyPr/>
-                    <a:lstStyle/>
-                    <a:p>
-                      <a:pPr marL="0" algn="ctr" defTabSz="914400" rtl="0" eaLnBrk="1" fontAlgn="b" latinLnBrk="0" hangingPunct="1"/>
-                      <a:r>
-                        <a:rPr b="0" sz="1200" u="none">
-                          <a:solidFill>
-                            <a:schemeClr val="tx1"/>
-                          </a:solidFill>
-                          <a:hlinkClick r:id="rId8"/>
-                        </a:rPr>
-                        <a:t>link</a:t>
-                      </a:r>
-                      <a:endParaRPr lang="en-US" sz="1200" b="0" i="0" u="none" strike="noStrike" kern="1200" noProof="0" dirty="0">
-                        <a:solidFill>
-                          <a:schemeClr val="tx1"/>
-                        </a:solidFill>
-                        <a:effectLst/>
-                        <a:latin typeface="Calibri Regular"/>
-                        <a:ea typeface="+mn-ea"/>
-                        <a:cs typeface="+mn-cs"/>
-                      </a:endParaRPr>
-                    </a:p>
-                  </a:txBody>
-                  <a:tcPr marL="108000" marR="108000" marT="72000" marB="72000" anchor="ctr"/>
-                </a:tc>
-                <a:extLst>
-                  <a:ext uri="{0D108BD9-81ED-4DB2-BD59-A6C34878D82A}">
-                    <a16:rowId xmlns:a16="http://schemas.microsoft.com/office/drawing/2014/main" val="4060795780"/>
-                  </a:ext>
-                </a:extLst>
-              </a:tr>
-              <a:tr h="279736">
-                <a:tc>
-                  <a:txBody>
-                    <a:bodyPr/>
-                    <a:lstStyle/>
-                    <a:p>
-                      <a:pPr algn="l" fontAlgn="b"/>
-                      <a:r>
-                        <a:rPr b="0" sz="1200" u="none">
-                          <a:solidFill>
-                            <a:schemeClr val="tx1"/>
-                          </a:solidFill>
-                        </a:rPr>
-                        <a:t>integrationtest-bazel</a:t>
-                      </a:r>
-                      <a:endParaRPr lang="en-US" sz="1200" b="0" i="0" u="none" strike="noStrike" noProof="0" dirty="0">
-                        <a:solidFill>
-                          <a:schemeClr val="tx1"/>
-                        </a:solidFill>
-                        <a:effectLst/>
-                        <a:latin typeface="Calibri Regular"/>
-                      </a:endParaRPr>
-                    </a:p>
-                  </a:txBody>
-                  <a:tcPr marL="108000" marR="108000" marT="72000" marB="72000" anchor="ctr"/>
-                </a:tc>
-                <a:tc>
-                  <a:txBody>
-                    <a:bodyPr/>
-                    <a:lstStyle/>
-                    <a:p>
-                      <a:pPr marL="0" marR="0" lvl="0" indent="0" algn="ctr" defTabSz="914400" rtl="0" eaLnBrk="1" fontAlgn="b" latinLnBrk="0" hangingPunct="1">
-                        <a:lnSpc>
-                          <a:spcPct val="100000"/>
-                        </a:lnSpc>
-                        <a:spcBef>
-                          <a:spcPts val="0"/>
-                        </a:spcBef>
-                        <a:spcAft>
-                          <a:spcPts val="0"/>
-                        </a:spcAft>
-                        <a:buClrTx/>
-                        <a:buSzTx/>
-                        <a:buFontTx/>
-                        <a:buNone/>
-                        <a:tabLst/>
-                        <a:defRPr/>
-                      </a:pPr>
-                      <a:r>
-                        <a:rPr b="0" i="0" sz="1200" u="none">
-                          <a:solidFill>
-                            <a:schemeClr val="tx1"/>
-                          </a:solidFill>
-                          <a:latin typeface="Calibri Bold"/>
-                        </a:rPr>
-                        <a:t>N/A</a:t>
-                      </a:r>
-                      <a:endParaRPr lang="en-US" sz="1200" b="0" i="0" u="none" strike="noStrike" kern="1200" noProof="0" dirty="0">
-                        <a:solidFill>
-                          <a:schemeClr val="tx1"/>
-                        </a:solidFill>
-                        <a:effectLst/>
-                        <a:latin typeface="Calibri Bold"/>
-                        <a:ea typeface="+mn-ea"/>
-                        <a:cs typeface="+mn-cs"/>
-                      </a:endParaRPr>
-                    </a:p>
-                  </a:txBody>
-                  <a:tcPr marL="108000" marR="108000" marT="72000" marB="72000" anchor="ctr"/>
-                </a:tc>
-                <a:tc>
-                  <a:txBody>
-                    <a:bodyPr/>
-                    <a:lstStyle/>
-                    <a:p>
-                      <a:pPr marL="0" marR="0" lvl="0" indent="0" algn="ctr" defTabSz="914400" rtl="0" eaLnBrk="1" fontAlgn="b" latinLnBrk="0" hangingPunct="1">
-                        <a:lnSpc>
-                          <a:spcPct val="100000"/>
-                        </a:lnSpc>
-                        <a:spcBef>
-                          <a:spcPts val="0"/>
-                        </a:spcBef>
-                        <a:spcAft>
-                          <a:spcPts val="0"/>
-                        </a:spcAft>
-                        <a:buClrTx/>
-                        <a:buSzTx/>
-                        <a:buFontTx/>
-                        <a:buNone/>
-                        <a:tabLst/>
-                        <a:defRPr/>
-                      </a:pPr>
-                      <a:r>
-                        <a:rPr b="0" sz="1200" u="none">
-                          <a:solidFill>
-                            <a:schemeClr val="tx1"/>
-                          </a:solidFill>
-                        </a:rPr>
-                        <a:t>17</a:t>
-                      </a:r>
-                      <a:endParaRPr lang="en-US" sz="1200" b="0" i="0" u="none" strike="noStrike" kern="1200" noProof="0" dirty="0">
-                        <a:solidFill>
-                          <a:schemeClr val="tx1"/>
-                        </a:solidFill>
-                        <a:effectLst/>
-                        <a:latin typeface="Calibri Bold"/>
-                        <a:ea typeface="+mn-ea"/>
-                        <a:cs typeface="+mn-cs"/>
-                      </a:endParaRPr>
-                    </a:p>
-                  </a:txBody>
-                  <a:tcPr marL="108000" marR="108000" marT="72000" marB="72000" anchor="ctr"/>
-                </a:tc>
-                <a:tc>
-                  <a:txBody>
-                    <a:bodyPr/>
-                    <a:lstStyle/>
-                    <a:p>
-                      <a:pPr algn="ctr" fontAlgn="b"/>
-                      <a:r>
-                        <a:rPr b="0" sz="1200" u="none">
-                          <a:solidFill>
-                            <a:schemeClr val="tx1"/>
-                          </a:solidFill>
-                        </a:rPr>
-                        <a:t>2.3★</a:t>
-                      </a:r>
-                      <a:endParaRPr lang="en-US" sz="1200" b="0" i="0" u="none" strike="noStrike" noProof="0" dirty="0">
-                        <a:solidFill>
-                          <a:schemeClr val="tx1"/>
-                        </a:solidFill>
-                        <a:effectLst/>
-                        <a:latin typeface="Calibri Regular"/>
-                      </a:endParaRPr>
-                    </a:p>
-                  </a:txBody>
-                  <a:tcPr marL="108000" marR="108000" marT="72000" marB="72000" anchor="ctr"/>
-                </a:tc>
-                <a:tc>
-                  <a:txBody>
-                    <a:bodyPr/>
-                    <a:lstStyle/>
-                    <a:p>
-                      <a:pPr marL="0" algn="ctr" defTabSz="914400" rtl="0" eaLnBrk="1" fontAlgn="b" latinLnBrk="0" hangingPunct="1"/>
-                      <a:r>
-                        <a:rPr b="0" sz="1200" u="none">
-                          <a:solidFill>
-                            <a:schemeClr val="tx1"/>
-                          </a:solidFill>
-                          <a:hlinkClick r:id="rId9"/>
-                        </a:rPr>
-                        <a:t>link</a:t>
-                      </a:r>
-                      <a:endParaRPr lang="en-US" sz="1200" b="0" i="0" u="none" strike="noStrike" kern="1200" noProof="0" dirty="0">
-                        <a:solidFill>
-                          <a:schemeClr val="tx1"/>
-                        </a:solidFill>
-                        <a:effectLst/>
-                        <a:latin typeface="Calibri Regular"/>
-                        <a:ea typeface="+mn-ea"/>
-                        <a:cs typeface="+mn-cs"/>
-                      </a:endParaRPr>
-                    </a:p>
-                  </a:txBody>
-                  <a:tcPr marL="108000" marR="108000" marT="72000" marB="72000" anchor="ctr"/>
-                </a:tc>
-                <a:extLst>
-                  <a:ext uri="{0D108BD9-81ED-4DB2-BD59-A6C34878D82A}">
-                    <a16:rowId xmlns:a16="http://schemas.microsoft.com/office/drawing/2014/main" val="933267410"/>
-                  </a:ext>
-                </a:extLst>
-              </a:tr>
-              <a:tr h="279736">
-                <a:tc>
-                  <a:txBody>
-                    <a:bodyPr/>
-                    <a:lstStyle/>
-                    <a:p>
-                      <a:pPr algn="l" fontAlgn="b"/>
-                      <a:r>
-                        <a:rPr b="0" sz="1200" u="none">
-                          <a:solidFill>
-                            <a:schemeClr val="tx1"/>
-                          </a:solidFill>
-                        </a:rPr>
-                        <a:t>integrationtest-elasticsearch</a:t>
-                      </a:r>
-                      <a:endParaRPr lang="en-US" sz="1200" b="0" i="0" u="none" strike="noStrike" noProof="0" dirty="0">
-                        <a:solidFill>
-                          <a:schemeClr val="tx1"/>
-                        </a:solidFill>
-                        <a:effectLst/>
-                        <a:latin typeface="Calibri Regular"/>
-                      </a:endParaRPr>
-                    </a:p>
-                  </a:txBody>
-                  <a:tcPr marL="108000" marR="108000" marT="72000" marB="72000" anchor="ctr"/>
-                </a:tc>
-                <a:tc>
-                  <a:txBody>
-                    <a:bodyPr/>
-                    <a:lstStyle/>
-                    <a:p>
-                      <a:pPr marL="0" marR="0" lvl="0" indent="0" algn="ctr" defTabSz="914400" rtl="0" eaLnBrk="1" fontAlgn="b" latinLnBrk="0" hangingPunct="1">
-                        <a:lnSpc>
-                          <a:spcPct val="100000"/>
-                        </a:lnSpc>
-                        <a:spcBef>
-                          <a:spcPts val="0"/>
-                        </a:spcBef>
-                        <a:spcAft>
-                          <a:spcPts val="0"/>
-                        </a:spcAft>
-                        <a:buClrTx/>
-                        <a:buSzTx/>
-                        <a:buFontTx/>
-                        <a:buNone/>
-                        <a:tabLst/>
-                        <a:defRPr/>
-                      </a:pPr>
-                      <a:r>
-                        <a:rPr b="0" i="0" sz="1200" u="none">
-                          <a:solidFill>
-                            <a:schemeClr val="tx1"/>
-                          </a:solidFill>
-                          <a:latin typeface="Calibri Bold"/>
-                        </a:rPr>
-                        <a:t>N/A</a:t>
-                      </a:r>
-                      <a:endParaRPr lang="en-US" sz="1200" b="0" i="0" u="none" strike="noStrike" kern="1200" noProof="0" dirty="0">
-                        <a:solidFill>
-                          <a:schemeClr val="tx1"/>
-                        </a:solidFill>
-                        <a:effectLst/>
-                        <a:latin typeface="Calibri Bold"/>
-                        <a:ea typeface="+mn-ea"/>
-                        <a:cs typeface="+mn-cs"/>
-                      </a:endParaRPr>
-                    </a:p>
-                  </a:txBody>
-                  <a:tcPr marL="108000" marR="108000" marT="72000" marB="72000" anchor="ctr"/>
-                </a:tc>
-                <a:tc>
-                  <a:txBody>
-                    <a:bodyPr/>
-                    <a:lstStyle/>
-                    <a:p>
-                      <a:pPr marL="0" marR="0" lvl="0" indent="0" algn="ctr" defTabSz="914400" rtl="0" eaLnBrk="1" fontAlgn="b" latinLnBrk="0" hangingPunct="1">
-                        <a:lnSpc>
-                          <a:spcPct val="100000"/>
-                        </a:lnSpc>
-                        <a:spcBef>
-                          <a:spcPts val="0"/>
-                        </a:spcBef>
-                        <a:spcAft>
-                          <a:spcPts val="0"/>
-                        </a:spcAft>
-                        <a:buClrTx/>
-                        <a:buSzTx/>
-                        <a:buFontTx/>
-                        <a:buNone/>
-                        <a:tabLst/>
-                        <a:defRPr/>
-                      </a:pPr>
-                      <a:r>
-                        <a:rPr b="0" sz="1200" u="none">
-                          <a:solidFill>
-                            <a:schemeClr val="tx1"/>
-                          </a:solidFill>
-                        </a:rPr>
-                        <a:t>14</a:t>
-                      </a:r>
-                      <a:endParaRPr lang="en-US" sz="1200" b="0" i="0" u="none" strike="noStrike" kern="1200" noProof="0" dirty="0">
-                        <a:solidFill>
-                          <a:schemeClr val="tx1"/>
-                        </a:solidFill>
-                        <a:effectLst/>
-                        <a:latin typeface="Calibri Bold"/>
-                        <a:ea typeface="+mn-ea"/>
-                        <a:cs typeface="+mn-cs"/>
-                      </a:endParaRPr>
-                    </a:p>
-                  </a:txBody>
-                  <a:tcPr marL="108000" marR="108000" marT="72000" marB="72000" anchor="ctr"/>
-                </a:tc>
-                <a:tc>
-                  <a:txBody>
-                    <a:bodyPr/>
-                    <a:lstStyle/>
-                    <a:p>
-                      <a:pPr algn="ctr" fontAlgn="b"/>
-                      <a:r>
-                        <a:rPr b="0" sz="1200" u="none">
-                          <a:solidFill>
-                            <a:schemeClr val="tx1"/>
-                          </a:solidFill>
-                        </a:rPr>
-                        <a:t>1.6★</a:t>
-                      </a:r>
-                      <a:endParaRPr lang="en-US" sz="1200" b="0" i="0" u="none" strike="noStrike" noProof="0" dirty="0">
-                        <a:solidFill>
-                          <a:schemeClr val="tx1"/>
-                        </a:solidFill>
-                        <a:effectLst/>
-                        <a:latin typeface="Calibri Regular"/>
-                      </a:endParaRPr>
-                    </a:p>
-                  </a:txBody>
-                  <a:tcPr marL="108000" marR="108000" marT="72000" marB="72000" anchor="ctr"/>
-                </a:tc>
-                <a:tc>
-                  <a:txBody>
-                    <a:bodyPr/>
-                    <a:lstStyle/>
-                    <a:p>
-                      <a:pPr marL="0" algn="ctr" defTabSz="914400" rtl="0" eaLnBrk="1" fontAlgn="b" latinLnBrk="0" hangingPunct="1"/>
-                      <a:r>
-                        <a:rPr b="0" sz="1200" u="none">
-                          <a:solidFill>
-                            <a:schemeClr val="tx1"/>
-                          </a:solidFill>
-                          <a:hlinkClick r:id="rId10"/>
-                        </a:rPr>
-                        <a:t>link</a:t>
-                      </a:r>
-                      <a:endParaRPr lang="en-US" sz="1200" b="0" i="0" u="none" strike="noStrike" kern="1200" noProof="0" dirty="0">
-                        <a:solidFill>
-                          <a:schemeClr val="tx1"/>
-                        </a:solidFill>
-                        <a:effectLst/>
-                        <a:latin typeface="Calibri Regular"/>
-                        <a:ea typeface="+mn-ea"/>
-                        <a:cs typeface="+mn-cs"/>
-                      </a:endParaRPr>
-                    </a:p>
-                  </a:txBody>
-                  <a:tcPr marL="108000" marR="108000" marT="72000" marB="72000" anchor="ctr"/>
-                </a:tc>
-                <a:extLst>
-                  <a:ext uri="{0D108BD9-81ED-4DB2-BD59-A6C34878D82A}">
-                    <a16:rowId xmlns:a16="http://schemas.microsoft.com/office/drawing/2014/main" val="2009910387"/>
-                  </a:ext>
-                </a:extLst>
-              </a:tr>
-              <a:tr h="279736">
-                <a:tc>
-                  <a:txBody>
-                    <a:bodyPr/>
-                    <a:lstStyle/>
-                    <a:p>
-                      <a:pPr algn="l" fontAlgn="b"/>
-                      <a:r>
-                        <a:rPr b="0" sz="1200" u="none">
-                          <a:solidFill>
-                            <a:schemeClr val="tx1"/>
-                          </a:solidFill>
-                        </a:rPr>
-                        <a:t>integrationtest-zuul</a:t>
-                      </a:r>
-                      <a:endParaRPr lang="en-US" sz="1200" b="0" i="0" u="none" strike="noStrike" noProof="0" dirty="0">
-                        <a:solidFill>
-                          <a:schemeClr val="tx1"/>
-                        </a:solidFill>
-                        <a:effectLst/>
-                        <a:latin typeface="Calibri Regular"/>
-                      </a:endParaRPr>
-                    </a:p>
-                  </a:txBody>
-                  <a:tcPr marL="108000" marR="108000" marT="72000" marB="72000" anchor="ctr"/>
-                </a:tc>
-                <a:tc>
-                  <a:txBody>
-                    <a:bodyPr/>
-                    <a:lstStyle/>
-                    <a:p>
-                      <a:pPr marL="0" marR="0" lvl="0" indent="0" algn="ctr" defTabSz="914400" rtl="0" eaLnBrk="1" fontAlgn="b" latinLnBrk="0" hangingPunct="1">
-                        <a:lnSpc>
-                          <a:spcPct val="100000"/>
-                        </a:lnSpc>
-                        <a:spcBef>
-                          <a:spcPts val="0"/>
-                        </a:spcBef>
-                        <a:spcAft>
-                          <a:spcPts val="0"/>
-                        </a:spcAft>
-                        <a:buClrTx/>
-                        <a:buSzTx/>
-                        <a:buFontTx/>
-                        <a:buNone/>
-                        <a:tabLst/>
-                        <a:defRPr/>
-                      </a:pPr>
-                      <a:r>
-                        <a:rPr b="0" i="0" sz="1200" u="none">
-                          <a:solidFill>
-                            <a:schemeClr val="tx1"/>
-                          </a:solidFill>
-                          <a:latin typeface="Calibri Bold"/>
-                        </a:rPr>
-                        <a:t>N/A</a:t>
-                      </a:r>
-                      <a:endParaRPr lang="en-US" sz="1200" b="0" i="0" u="none" strike="noStrike" kern="1200" noProof="0" dirty="0">
-                        <a:solidFill>
-                          <a:schemeClr val="tx1"/>
-                        </a:solidFill>
-                        <a:effectLst/>
-                        <a:latin typeface="Calibri Bold"/>
-                        <a:ea typeface="+mn-ea"/>
-                        <a:cs typeface="+mn-cs"/>
-                      </a:endParaRPr>
-                    </a:p>
-                  </a:txBody>
-                  <a:tcPr marL="108000" marR="108000" marT="72000" marB="72000" anchor="ctr"/>
-                </a:tc>
-                <a:tc>
-                  <a:txBody>
-                    <a:bodyPr/>
-                    <a:lstStyle/>
-                    <a:p>
-                      <a:pPr marL="0" marR="0" lvl="0" indent="0" algn="ctr" defTabSz="914400" rtl="0" eaLnBrk="1" fontAlgn="b" latinLnBrk="0" hangingPunct="1">
-                        <a:lnSpc>
-                          <a:spcPct val="100000"/>
-                        </a:lnSpc>
-                        <a:spcBef>
-                          <a:spcPts val="0"/>
-                        </a:spcBef>
-                        <a:spcAft>
-                          <a:spcPts val="0"/>
-                        </a:spcAft>
-                        <a:buClrTx/>
-                        <a:buSzTx/>
-                        <a:buFontTx/>
-                        <a:buNone/>
-                        <a:tabLst/>
-                        <a:defRPr/>
-                      </a:pPr>
-                      <a:r>
-                        <a:rPr b="0" sz="1200" u="none">
-                          <a:solidFill>
-                            <a:schemeClr val="tx1"/>
-                          </a:solidFill>
-                        </a:rPr>
-                        <a:t>6</a:t>
-                      </a:r>
-                      <a:endParaRPr lang="en-US" sz="1200" b="0" i="0" u="none" strike="noStrike" kern="1200" noProof="0" dirty="0">
-                        <a:solidFill>
-                          <a:schemeClr val="tx1"/>
-                        </a:solidFill>
-                        <a:effectLst/>
-                        <a:latin typeface="Calibri Bold"/>
-                        <a:ea typeface="+mn-ea"/>
-                        <a:cs typeface="+mn-cs"/>
-                      </a:endParaRPr>
-                    </a:p>
-                  </a:txBody>
-                  <a:tcPr marL="108000" marR="108000" marT="72000" marB="72000" anchor="ctr"/>
-                </a:tc>
-                <a:tc>
-                  <a:txBody>
-                    <a:bodyPr/>
-                    <a:lstStyle/>
-                    <a:p>
-                      <a:pPr algn="ctr" fontAlgn="b"/>
-                      <a:r>
-                        <a:rPr b="0" sz="1200" u="none">
-                          <a:solidFill>
-                            <a:schemeClr val="tx1"/>
-                          </a:solidFill>
-                        </a:rPr>
-                        <a:t>2.1★</a:t>
+                        <a:t>3.9★</a:t>
                       </a:r>
                       <a:endParaRPr lang="en-US" sz="1200" b="0" i="0" u="none" strike="noStrike" noProof="0" dirty="0">
                         <a:solidFill>
@@ -34612,6 +34612,194 @@
                             <a:schemeClr val="tx1"/>
                           </a:solidFill>
                         </a:rPr>
+                        <a:t>integrationtest-elasticsearch</a:t>
+                      </a:r>
+                      <a:endParaRPr lang="en-US" sz="1200" b="0" i="0" u="none" strike="noStrike" noProof="0" dirty="0">
+                        <a:solidFill>
+                          <a:schemeClr val="tx1"/>
+                        </a:solidFill>
+                        <a:effectLst/>
+                        <a:latin typeface="Calibri Regular"/>
+                      </a:endParaRPr>
+                    </a:p>
+                  </a:txBody>
+                  <a:tcPr marL="108000" marR="108000" marT="72000" marB="72000" anchor="ctr"/>
+                </a:tc>
+                <a:tc>
+                  <a:txBody>
+                    <a:bodyPr/>
+                    <a:lstStyle/>
+                    <a:p>
+                      <a:pPr marL="0" marR="0" lvl="0" indent="0" algn="ctr" defTabSz="914400" rtl="0" eaLnBrk="1" fontAlgn="b" latinLnBrk="0" hangingPunct="1">
+                        <a:lnSpc>
+                          <a:spcPct val="100000"/>
+                        </a:lnSpc>
+                        <a:spcBef>
+                          <a:spcPts val="0"/>
+                        </a:spcBef>
+                        <a:spcAft>
+                          <a:spcPts val="0"/>
+                        </a:spcAft>
+                        <a:buClrTx/>
+                        <a:buSzTx/>
+                        <a:buFontTx/>
+                        <a:buNone/>
+                        <a:tabLst/>
+                        <a:defRPr/>
+                      </a:pPr>
+                      <a:r>
+                        <a:rPr b="0" i="0" sz="1200" u="none">
+                          <a:solidFill>
+                            <a:schemeClr val="tx1"/>
+                          </a:solidFill>
+                          <a:latin typeface="Calibri Bold"/>
+                        </a:rPr>
+                        <a:t>N/A</a:t>
+                      </a:r>
+                      <a:endParaRPr lang="en-US" sz="1200" b="0" i="0" u="none" strike="noStrike" kern="1200" noProof="0" dirty="0">
+                        <a:solidFill>
+                          <a:schemeClr val="tx1"/>
+                        </a:solidFill>
+                        <a:effectLst/>
+                        <a:latin typeface="Calibri Bold"/>
+                        <a:ea typeface="+mn-ea"/>
+                        <a:cs typeface="+mn-cs"/>
+                      </a:endParaRPr>
+                    </a:p>
+                  </a:txBody>
+                  <a:tcPr marL="108000" marR="108000" marT="72000" marB="72000" anchor="ctr"/>
+                </a:tc>
+                <a:tc>
+                  <a:txBody>
+                    <a:bodyPr/>
+                    <a:lstStyle/>
+                    <a:p>
+                      <a:pPr marL="0" marR="0" lvl="0" indent="0" algn="ctr" defTabSz="914400" rtl="0" eaLnBrk="1" fontAlgn="b" latinLnBrk="0" hangingPunct="1">
+                        <a:lnSpc>
+                          <a:spcPct val="100000"/>
+                        </a:lnSpc>
+                        <a:spcBef>
+                          <a:spcPts val="0"/>
+                        </a:spcBef>
+                        <a:spcAft>
+                          <a:spcPts val="0"/>
+                        </a:spcAft>
+                        <a:buClrTx/>
+                        <a:buSzTx/>
+                        <a:buFontTx/>
+                        <a:buNone/>
+                        <a:tabLst/>
+                        <a:defRPr/>
+                      </a:pPr>
+                      <a:r>
+                        <a:rPr b="0" sz="1200" u="none">
+                          <a:solidFill>
+                            <a:schemeClr val="tx1"/>
+                          </a:solidFill>
+                        </a:rPr>
+                        <a:t>45</a:t>
+                      </a:r>
+                      <a:endParaRPr lang="en-US" sz="1200" b="0" i="0" u="none" strike="noStrike" kern="1200" noProof="0" dirty="0">
+                        <a:solidFill>
+                          <a:schemeClr val="tx1"/>
+                        </a:solidFill>
+                        <a:effectLst/>
+                        <a:latin typeface="Calibri Bold"/>
+                        <a:ea typeface="+mn-ea"/>
+                        <a:cs typeface="+mn-cs"/>
+                      </a:endParaRPr>
+                    </a:p>
+                  </a:txBody>
+                  <a:tcPr marL="108000" marR="108000" marT="72000" marB="72000" anchor="ctr"/>
+                </a:tc>
+                <a:tc>
+                  <a:txBody>
+                    <a:bodyPr/>
+                    <a:lstStyle/>
+                    <a:p>
+                      <a:pPr marL="0" marR="0" indent="0" algn="ctr" defTabSz="457200" rtl="0" eaLnBrk="1" fontAlgn="b" latinLnBrk="0" hangingPunct="1">
+                        <a:lnSpc>
+                          <a:spcPct val="100000"/>
+                        </a:lnSpc>
+                        <a:spcBef>
+                          <a:spcPts val="0"/>
+                        </a:spcBef>
+                        <a:spcAft>
+                          <a:spcPts val="0"/>
+                        </a:spcAft>
+                        <a:buClrTx/>
+                        <a:buSzTx/>
+                        <a:buFontTx/>
+                        <a:buNone/>
+                        <a:tabLst/>
+                        <a:defRPr/>
+                      </a:pPr>
+                      <a:r>
+                        <a:rPr b="0" sz="1200" u="none">
+                          <a:solidFill>
+                            <a:schemeClr val="tx1"/>
+                          </a:solidFill>
+                        </a:rPr>
+                        <a:t>1.1★</a:t>
+                      </a:r>
+                      <a:endParaRPr lang="en-US" sz="1200" b="0" i="0" u="none" strike="noStrike" noProof="0" dirty="0">
+                        <a:solidFill>
+                          <a:schemeClr val="tx1"/>
+                        </a:solidFill>
+                        <a:effectLst/>
+                        <a:latin typeface="Calibri Regular"/>
+                      </a:endParaRPr>
+                    </a:p>
+                  </a:txBody>
+                  <a:tcPr marL="108000" marR="108000" marT="72000" marB="72000" anchor="ctr"/>
+                </a:tc>
+                <a:tc>
+                  <a:txBody>
+                    <a:bodyPr/>
+                    <a:lstStyle/>
+                    <a:p>
+                      <a:pPr marL="0" algn="ctr" defTabSz="914400" rtl="0" eaLnBrk="1" fontAlgn="b" latinLnBrk="0" hangingPunct="1"/>
+                      <a:r>
+                        <a:rPr b="0" sz="1200" u="none">
+                          <a:solidFill>
+                            <a:schemeClr val="tx1"/>
+                          </a:solidFill>
+                          <a:hlinkClick r:id="rId3"/>
+                        </a:rPr>
+                        <a:t>link</a:t>
+                      </a:r>
+                      <a:endParaRPr lang="en-US" sz="1200" b="0" i="0" u="none" strike="noStrike" kern="1200" noProof="0" dirty="0">
+                        <a:solidFill>
+                          <a:schemeClr val="tx1"/>
+                        </a:solidFill>
+                        <a:effectLst/>
+                        <a:latin typeface="Calibri Regular"/>
+                        <a:ea typeface="+mn-ea"/>
+                        <a:cs typeface="+mn-cs"/>
+                      </a:endParaRPr>
+                    </a:p>
+                  </a:txBody>
+                  <a:tcPr marL="108000" marR="108000" marT="72000" marB="72000" anchor="ctr"/>
+                </a:tc>
+                <a:extLst>
+                  <a:ext uri="{0D108BD9-81ED-4DB2-BD59-A6C34878D82A}">
+                    <a16:rowId xmlns:a16="http://schemas.microsoft.com/office/drawing/2014/main" val="10002"/>
+                  </a:ext>
+                </a:extLst>
+              </a:tr>
+              <a:tr h="279736">
+                <a:tc>
+                  <a:txBody>
+                    <a:bodyPr/>
+                    <a:lstStyle/>
+                    <a:p>
+                      <a:pPr algn="l" fontAlgn="b"/>
+                      <a:r>
+                        <a:rPr b="0" sz="1200" u="none">
+                          <a:solidFill>
+                            <a:schemeClr val="tx1"/>
+                          </a:solidFill>
+                        </a:rPr>
                         <a:t>integrationtest-jruby</a:t>
                       </a:r>
                       <a:endParaRPr lang="en-US" sz="1200" b="0" i="0" u="none" strike="noStrike" noProof="0" dirty="0">
@@ -34717,23 +34905,7 @@
                     <a:bodyPr/>
                     <a:lstStyle/>
                     <a:p>
-                      <a:pPr marL="0" marR="0" indent="0" algn="ctr" defTabSz="457200" rtl="0" eaLnBrk="1" fontAlgn="b" latinLnBrk="0" hangingPunct="1">
-                        <a:lnSpc>
-                          <a:spcPct val="100000"/>
-                        </a:lnSpc>
-                        <a:spcBef>
-                          <a:spcPts val="0"/>
-                        </a:spcBef>
-                        <a:spcAft>
-                          <a:spcPts val="0"/>
-                        </a:spcAft>
-                        <a:buClrTx/>
-                        <a:buSzTx/>
-                        <a:buFontTx/>
-                        <a:buNone/>
-                        <a:tabLst/>
-                        <a:defRPr/>
-                      </a:pPr>
+                      <a:pPr algn="ctr" fontAlgn="b"/>
                       <a:r>
                         <a:rPr b="0" sz="1200" u="none">
                           <a:solidFill>
@@ -34764,7 +34936,7 @@
                           <a:solidFill>
                             <a:schemeClr val="tx1"/>
                           </a:solidFill>
-                          <a:hlinkClick r:id="rId3"/>
+                          <a:hlinkClick r:id="rId4"/>
                         </a:rPr>
                         <a:t>link</a:t>
                       </a:r>
@@ -34783,7 +34955,7 @@
                 </a:tc>
                 <a:extLst>
                   <a:ext uri="{0D108BD9-81ED-4DB2-BD59-A6C34878D82A}">
-                    <a16:rowId xmlns:a16="http://schemas.microsoft.com/office/drawing/2014/main" val="10002"/>
+                    <a16:rowId xmlns:a16="http://schemas.microsoft.com/office/drawing/2014/main" val="10003"/>
                   </a:ext>
                 </a:extLst>
               </a:tr>
@@ -34905,7 +35077,23 @@
                     <a:bodyPr/>
                     <a:lstStyle/>
                     <a:p>
-                      <a:pPr algn="ctr" fontAlgn="b"/>
+                      <a:pPr marL="0" marR="0" lvl="0" indent="0" algn="ctr" defTabSz="914400" rtl="0" eaLnBrk="1" fontAlgn="b" latinLnBrk="0" hangingPunct="1">
+                        <a:lnSpc>
+                          <a:spcPct val="100000"/>
+                        </a:lnSpc>
+                        <a:spcBef>
+                          <a:spcPts val="0"/>
+                        </a:spcBef>
+                        <a:spcAft>
+                          <a:spcPts val="0"/>
+                        </a:spcAft>
+                        <a:buClrTx/>
+                        <a:buSzTx/>
+                        <a:buFontTx/>
+                        <a:buNone/>
+                        <a:tabLst/>
+                        <a:defRPr/>
+                      </a:pPr>
                       <a:r>
                         <a:rPr b="0" sz="1200" u="none">
                           <a:solidFill>
@@ -34914,12 +35102,14 @@
                         </a:rPr>
                         <a:t>1.9★</a:t>
                       </a:r>
-                      <a:endParaRPr lang="en-US" sz="1200" b="0" i="0" u="none" strike="noStrike" noProof="0" dirty="0">
+                      <a:endParaRPr lang="en-US" sz="1200" b="0" i="0" u="none" strike="noStrike" kern="1200" noProof="0" dirty="0">
                         <a:solidFill>
                           <a:schemeClr val="tx1"/>
                         </a:solidFill>
                         <a:effectLst/>
-                        <a:latin typeface="Calibri Regular"/>
+                        <a:latin typeface="Calibri Bold"/>
+                        <a:ea typeface="+mn-ea"/>
+                        <a:cs typeface="+mn-cs"/>
                       </a:endParaRPr>
                     </a:p>
                   </a:txBody>
@@ -34936,7 +35126,7 @@
                           <a:solidFill>
                             <a:schemeClr val="tx1"/>
                           </a:solidFill>
-                          <a:hlinkClick r:id="rId4"/>
+                          <a:hlinkClick r:id="rId5"/>
                         </a:rPr>
                         <a:t>link</a:t>
                       </a:r>
@@ -34955,7 +35145,7 @@
                 </a:tc>
                 <a:extLst>
                   <a:ext uri="{0D108BD9-81ED-4DB2-BD59-A6C34878D82A}">
-                    <a16:rowId xmlns:a16="http://schemas.microsoft.com/office/drawing/2014/main" val="10003"/>
+                    <a16:rowId xmlns:a16="http://schemas.microsoft.com/office/drawing/2014/main" val="10004"/>
                   </a:ext>
                 </a:extLst>
               </a:tr>
@@ -35077,23 +35267,7 @@
                     <a:bodyPr/>
                     <a:lstStyle/>
                     <a:p>
-                      <a:pPr marL="0" marR="0" lvl="0" indent="0" algn="ctr" defTabSz="914400" rtl="0" eaLnBrk="1" fontAlgn="b" latinLnBrk="0" hangingPunct="1">
-                        <a:lnSpc>
-                          <a:spcPct val="100000"/>
-                        </a:lnSpc>
-                        <a:spcBef>
-                          <a:spcPts val="0"/>
-                        </a:spcBef>
-                        <a:spcAft>
-                          <a:spcPts val="0"/>
-                        </a:spcAft>
-                        <a:buClrTx/>
-                        <a:buSzTx/>
-                        <a:buFontTx/>
-                        <a:buNone/>
-                        <a:tabLst/>
-                        <a:defRPr/>
-                      </a:pPr>
+                      <a:pPr algn="ctr" fontAlgn="b"/>
                       <a:r>
                         <a:rPr b="0" sz="1200" u="none">
                           <a:solidFill>
@@ -35101,180 +35275,6 @@
                           </a:solidFill>
                         </a:rPr>
                         <a:t>1.4★</a:t>
-                      </a:r>
-                      <a:endParaRPr lang="en-US" sz="1200" b="0" i="0" u="none" strike="noStrike" kern="1200" noProof="0" dirty="0">
-                        <a:solidFill>
-                          <a:schemeClr val="tx1"/>
-                        </a:solidFill>
-                        <a:effectLst/>
-                        <a:latin typeface="Calibri Bold"/>
-                        <a:ea typeface="+mn-ea"/>
-                        <a:cs typeface="+mn-cs"/>
-                      </a:endParaRPr>
-                    </a:p>
-                  </a:txBody>
-                  <a:tcPr marL="108000" marR="108000" marT="72000" marB="72000" anchor="ctr"/>
-                </a:tc>
-                <a:tc>
-                  <a:txBody>
-                    <a:bodyPr/>
-                    <a:lstStyle/>
-                    <a:p>
-                      <a:pPr marL="0" algn="ctr" defTabSz="914400" rtl="0" eaLnBrk="1" fontAlgn="b" latinLnBrk="0" hangingPunct="1"/>
-                      <a:r>
-                        <a:rPr b="0" sz="1200" u="none">
-                          <a:solidFill>
-                            <a:schemeClr val="tx1"/>
-                          </a:solidFill>
-                          <a:hlinkClick r:id="rId5"/>
-                        </a:rPr>
-                        <a:t>link</a:t>
-                      </a:r>
-                      <a:endParaRPr lang="en-US" sz="1200" b="0" i="0" u="none" strike="noStrike" kern="1200" noProof="0" dirty="0">
-                        <a:solidFill>
-                          <a:schemeClr val="tx1"/>
-                        </a:solidFill>
-                        <a:effectLst/>
-                        <a:latin typeface="Calibri Regular"/>
-                        <a:ea typeface="+mn-ea"/>
-                        <a:cs typeface="+mn-cs"/>
-                      </a:endParaRPr>
-                    </a:p>
-                  </a:txBody>
-                  <a:tcPr marL="108000" marR="108000" marT="72000" marB="72000" anchor="ctr"/>
-                </a:tc>
-                <a:extLst>
-                  <a:ext uri="{0D108BD9-81ED-4DB2-BD59-A6C34878D82A}">
-                    <a16:rowId xmlns:a16="http://schemas.microsoft.com/office/drawing/2014/main" val="10004"/>
-                  </a:ext>
-                </a:extLst>
-              </a:tr>
-              <a:tr h="279736">
-                <a:tc>
-                  <a:txBody>
-                    <a:bodyPr/>
-                    <a:lstStyle/>
-                    <a:p>
-                      <a:pPr algn="l" fontAlgn="b"/>
-                      <a:r>
-                        <a:rPr b="0" sz="1200" u="none">
-                          <a:solidFill>
-                            <a:schemeClr val="tx1"/>
-                          </a:solidFill>
-                        </a:rPr>
-                        <a:t>integrationtest-elasticsearch</a:t>
-                      </a:r>
-                      <a:endParaRPr lang="en-US" sz="1200" b="0" i="0" u="none" strike="noStrike" noProof="0" dirty="0">
-                        <a:solidFill>
-                          <a:schemeClr val="tx1"/>
-                        </a:solidFill>
-                        <a:effectLst/>
-                        <a:latin typeface="Calibri Regular"/>
-                      </a:endParaRPr>
-                    </a:p>
-                  </a:txBody>
-                  <a:tcPr marL="108000" marR="108000" marT="72000" marB="72000" anchor="ctr"/>
-                </a:tc>
-                <a:tc>
-                  <a:txBody>
-                    <a:bodyPr/>
-                    <a:lstStyle/>
-                    <a:p>
-                      <a:pPr marL="0" marR="0" lvl="0" indent="0" algn="ctr" defTabSz="914400" rtl="0" eaLnBrk="1" fontAlgn="b" latinLnBrk="0" hangingPunct="1">
-                        <a:lnSpc>
-                          <a:spcPct val="100000"/>
-                        </a:lnSpc>
-                        <a:spcBef>
-                          <a:spcPts val="0"/>
-                        </a:spcBef>
-                        <a:spcAft>
-                          <a:spcPts val="0"/>
-                        </a:spcAft>
-                        <a:buClrTx/>
-                        <a:buSzTx/>
-                        <a:buFontTx/>
-                        <a:buNone/>
-                        <a:tabLst/>
-                        <a:defRPr/>
-                      </a:pPr>
-                      <a:r>
-                        <a:rPr b="0" i="0" sz="1200" u="none">
-                          <a:solidFill>
-                            <a:schemeClr val="tx1"/>
-                          </a:solidFill>
-                          <a:latin typeface="Calibri Bold"/>
-                        </a:rPr>
-                        <a:t>N/A</a:t>
-                      </a:r>
-                      <a:endParaRPr lang="en-US" sz="1200" b="0" i="0" u="none" strike="noStrike" kern="1200" noProof="0" dirty="0">
-                        <a:solidFill>
-                          <a:schemeClr val="tx1"/>
-                        </a:solidFill>
-                        <a:effectLst/>
-                        <a:latin typeface="Calibri Bold"/>
-                        <a:ea typeface="+mn-ea"/>
-                        <a:cs typeface="+mn-cs"/>
-                      </a:endParaRPr>
-                    </a:p>
-                  </a:txBody>
-                  <a:tcPr marL="108000" marR="108000" marT="72000" marB="72000" anchor="ctr"/>
-                </a:tc>
-                <a:tc>
-                  <a:txBody>
-                    <a:bodyPr/>
-                    <a:lstStyle/>
-                    <a:p>
-                      <a:pPr marL="0" marR="0" lvl="0" indent="0" algn="ctr" defTabSz="914400" rtl="0" eaLnBrk="1" fontAlgn="b" latinLnBrk="0" hangingPunct="1">
-                        <a:lnSpc>
-                          <a:spcPct val="100000"/>
-                        </a:lnSpc>
-                        <a:spcBef>
-                          <a:spcPts val="0"/>
-                        </a:spcBef>
-                        <a:spcAft>
-                          <a:spcPts val="0"/>
-                        </a:spcAft>
-                        <a:buClrTx/>
-                        <a:buSzTx/>
-                        <a:buFontTx/>
-                        <a:buNone/>
-                        <a:tabLst/>
-                        <a:defRPr/>
-                      </a:pPr>
-                      <a:r>
-                        <a:rPr b="0" sz="1200" u="none">
-                          <a:solidFill>
-                            <a:schemeClr val="tx1"/>
-                          </a:solidFill>
-                        </a:rPr>
-                        <a:t>8</a:t>
-                      </a:r>
-                      <a:endParaRPr lang="en-US" sz="1200" b="0" i="0" u="none" strike="noStrike" kern="1200" noProof="0" dirty="0">
-                        <a:solidFill>
-                          <a:schemeClr val="tx1"/>
-                        </a:solidFill>
-                        <a:effectLst/>
-                        <a:latin typeface="Calibri Bold"/>
-                        <a:ea typeface="+mn-ea"/>
-                        <a:cs typeface="+mn-cs"/>
-                      </a:endParaRPr>
-                    </a:p>
-                  </a:txBody>
-                  <a:tcPr marL="108000" marR="108000" marT="72000" marB="72000" anchor="ctr"/>
-                </a:tc>
-                <a:tc>
-                  <a:txBody>
-                    <a:bodyPr/>
-                    <a:lstStyle/>
-                    <a:p>
-                      <a:pPr algn="ctr" fontAlgn="b"/>
-                      <a:r>
-                        <a:rPr b="0" sz="1200" u="none">
-                          <a:solidFill>
-                            <a:schemeClr val="tx1"/>
-                          </a:solidFill>
-                        </a:rPr>
-                        <a:t>1.8★</a:t>
                       </a:r>
                       <a:endParaRPr lang="en-US" sz="1200" b="0" i="0" u="none" strike="noStrike" noProof="0" dirty="0">
                         <a:solidFill>
@@ -36672,7 +36672,7 @@
                             <a:schemeClr val="tx1"/>
                           </a:solidFill>
                         </a:rPr>
-                        <a:t>191</a:t>
+                        <a:t>193</a:t>
                       </a:r>
                       <a:endParaRPr lang="en-US" sz="1200" b="0" i="0" u="none" strike="noStrike" kern="1200" noProof="0" dirty="0">
                         <a:solidFill>
@@ -36718,6 +36718,153 @@
                 <a:extLst>
                   <a:ext uri="{0D108BD9-81ED-4DB2-BD59-A6C34878D82A}">
                     <a16:rowId xmlns:a16="http://schemas.microsoft.com/office/drawing/2014/main" val="10001"/>
+                  </a:ext>
+                </a:extLst>
+              </a:tr>
+              <a:tr h="279736">
+                <a:tc>
+                  <a:txBody>
+                    <a:bodyPr/>
+                    <a:lstStyle/>
+                    <a:p>
+                      <a:pPr algn="l" fontAlgn="b"/>
+                      <a:r>
+                        <a:rPr b="0" sz="1200" u="none">
+                          <a:solidFill>
+                            <a:schemeClr val="tx1"/>
+                          </a:solidFill>
+                        </a:rPr>
+                        <a:t>integrationtest-elasticsearch</a:t>
+                      </a:r>
+                      <a:endParaRPr lang="en-US" sz="1200" b="0" i="0" u="none" strike="noStrike" noProof="0" dirty="0">
+                        <a:solidFill>
+                          <a:schemeClr val="tx1"/>
+                        </a:solidFill>
+                        <a:effectLst/>
+                        <a:latin typeface="Calibri Regular"/>
+                      </a:endParaRPr>
+                    </a:p>
+                  </a:txBody>
+                  <a:tcPr marL="108000" marR="108000" marT="72000" marB="72000" anchor="ctr"/>
+                </a:tc>
+                <a:tc>
+                  <a:txBody>
+                    <a:bodyPr/>
+                    <a:lstStyle/>
+                    <a:p>
+                      <a:pPr marL="0" marR="0" lvl="0" indent="0" algn="ctr" defTabSz="914400" rtl="0" eaLnBrk="1" fontAlgn="b" latinLnBrk="0" hangingPunct="1">
+                        <a:lnSpc>
+                          <a:spcPct val="100000"/>
+                        </a:lnSpc>
+                        <a:spcBef>
+                          <a:spcPts val="0"/>
+                        </a:spcBef>
+                        <a:spcAft>
+                          <a:spcPts val="0"/>
+                        </a:spcAft>
+                        <a:buClrTx/>
+                        <a:buSzTx/>
+                        <a:buFontTx/>
+                        <a:buNone/>
+                        <a:tabLst/>
+                        <a:defRPr/>
+                      </a:pPr>
+                      <a:r>
+                        <a:rPr b="0" i="0" sz="1200" u="none">
+                          <a:solidFill>
+                            <a:schemeClr val="tx1"/>
+                          </a:solidFill>
+                          <a:latin typeface="Calibri Bold"/>
+                        </a:rPr>
+                        <a:t>72.7%</a:t>
+                      </a:r>
+                      <a:endParaRPr lang="en-US" sz="1200" b="0" i="0" u="none" strike="noStrike" kern="1200" noProof="0" dirty="0">
+                        <a:solidFill>
+                          <a:schemeClr val="tx1"/>
+                        </a:solidFill>
+                        <a:effectLst/>
+                        <a:latin typeface="Calibri Bold"/>
+                        <a:ea typeface="+mn-ea"/>
+                        <a:cs typeface="+mn-cs"/>
+                      </a:endParaRPr>
+                    </a:p>
+                  </a:txBody>
+                  <a:tcPr marL="108000" marR="108000" marT="72000" marB="72000" anchor="ctr"/>
+                </a:tc>
+                <a:tc>
+                  <a:txBody>
+                    <a:bodyPr/>
+                    <a:lstStyle/>
+                    <a:p>
+                      <a:pPr marL="0" marR="0" lvl="0" indent="0" algn="ctr" defTabSz="914400" rtl="0" eaLnBrk="1" fontAlgn="b" latinLnBrk="0" hangingPunct="1">
+                        <a:lnSpc>
+                          <a:spcPct val="100000"/>
+                        </a:lnSpc>
+                        <a:spcBef>
+                          <a:spcPts val="0"/>
+                        </a:spcBef>
+                        <a:spcAft>
+                          <a:spcPts val="0"/>
+                        </a:spcAft>
+                        <a:buClrTx/>
+                        <a:buSzTx/>
+                        <a:buFontTx/>
+                        <a:buNone/>
+                        <a:tabLst/>
+                        <a:defRPr/>
+                      </a:pPr>
+                      <a:r>
+                        <a:rPr b="0" sz="1200" u="none">
+                          <a:solidFill>
+                            <a:schemeClr val="tx1"/>
+                          </a:solidFill>
+                        </a:rPr>
+                        <a:t>141</a:t>
+                      </a:r>
+                      <a:endParaRPr lang="en-US" sz="1200" b="0" i="0" u="none" strike="noStrike" kern="1200" noProof="0" dirty="0">
+                        <a:solidFill>
+                          <a:schemeClr val="tx1"/>
+                        </a:solidFill>
+                        <a:effectLst/>
+                        <a:latin typeface="Calibri Bold"/>
+                        <a:ea typeface="+mn-ea"/>
+                        <a:cs typeface="+mn-cs"/>
+                      </a:endParaRPr>
+                    </a:p>
+                  </a:txBody>
+                  <a:tcPr marL="108000" marR="108000" marT="72000" marB="72000" anchor="ctr"/>
+                </a:tc>
+                <a:tc>
+                  <a:txBody>
+                    <a:bodyPr/>
+                    <a:lstStyle/>
+                    <a:p>
+                      <a:pPr marL="0" algn="ctr" defTabSz="914400" rtl="0" eaLnBrk="1" fontAlgn="b" latinLnBrk="0" hangingPunct="1"/>
+                      <a:r>
+                        <a:rPr b="0" sz="1200" u="none">
+                          <a:solidFill>
+                            <a:schemeClr val="tx1"/>
+                          </a:solidFill>
+                          <a:hlinkClick r:id="rId3"/>
+                        </a:rPr>
+                        <a:t>link</a:t>
+                      </a:r>
+                      <a:endParaRPr lang="en-US" sz="1200" b="0" i="0" u="none" strike="noStrike" kern="1200" noProof="0" dirty="0">
+                        <a:solidFill>
+                          <a:schemeClr val="tx1"/>
+                        </a:solidFill>
+                        <a:effectLst/>
+                        <a:latin typeface="Calibri Regular"/>
+                        <a:ea typeface="+mn-ea"/>
+                        <a:cs typeface="+mn-cs"/>
+                      </a:endParaRPr>
+                    </a:p>
+                  </a:txBody>
+                  <a:tcPr marL="108000" marR="108000" marT="72000" marB="72000" anchor="ctr"/>
+                </a:tc>
+                <a:extLst>
+                  <a:ext uri="{0D108BD9-81ED-4DB2-BD59-A6C34878D82A}">
+                    <a16:rowId xmlns:a16="http://schemas.microsoft.com/office/drawing/2014/main" val="10002"/>
                   </a:ext>
                 </a:extLst>
               </a:tr>
@@ -36819,7 +36966,7 @@
                             <a:schemeClr val="tx1"/>
                           </a:solidFill>
                         </a:rPr>
-                        <a:t>110</a:t>
+                        <a:t>112</a:t>
                       </a:r>
                       <a:endParaRPr lang="en-US" sz="1200" b="0" i="0" u="none" strike="noStrike" kern="1200" noProof="0" dirty="0">
                         <a:solidFill>
@@ -36845,7 +36992,7 @@
                           <a:solidFill>
                             <a:schemeClr val="tx1"/>
                           </a:solidFill>
-                          <a:hlinkClick r:id="rId3"/>
+                          <a:hlinkClick r:id="rId4"/>
                         </a:rPr>
                         <a:t>link</a:t>
                       </a:r>
@@ -36864,7 +37011,7 @@
                 </a:tc>
                 <a:extLst>
                   <a:ext uri="{0D108BD9-81ED-4DB2-BD59-A6C34878D82A}">
-                    <a16:rowId xmlns:a16="http://schemas.microsoft.com/office/drawing/2014/main" val="10002"/>
+                    <a16:rowId xmlns:a16="http://schemas.microsoft.com/office/drawing/2014/main" val="10003"/>
                   </a:ext>
                 </a:extLst>
               </a:tr>
@@ -36966,7 +37113,7 @@
                             <a:schemeClr val="tx1"/>
                           </a:solidFill>
                         </a:rPr>
-                        <a:t>92</a:t>
+                        <a:t>94</a:t>
                       </a:r>
                       <a:endParaRPr lang="en-US" sz="1200" b="0" i="0" u="none" strike="noStrike" kern="1200" noProof="0" dirty="0">
                         <a:solidFill>
@@ -36992,7 +37139,7 @@
                           <a:solidFill>
                             <a:schemeClr val="tx1"/>
                           </a:solidFill>
-                          <a:hlinkClick r:id="rId4"/>
+                          <a:hlinkClick r:id="rId5"/>
                         </a:rPr>
                         <a:t>link</a:t>
                       </a:r>
@@ -37011,7 +37158,7 @@
                 </a:tc>
                 <a:extLst>
                   <a:ext uri="{0D108BD9-81ED-4DB2-BD59-A6C34878D82A}">
-                    <a16:rowId xmlns:a16="http://schemas.microsoft.com/office/drawing/2014/main" val="10003"/>
+                    <a16:rowId xmlns:a16="http://schemas.microsoft.com/office/drawing/2014/main" val="10004"/>
                   </a:ext>
                 </a:extLst>
               </a:tr>
@@ -37113,7 +37260,7 @@
                             <a:schemeClr val="tx1"/>
                           </a:solidFill>
                         </a:rPr>
-                        <a:t>8</a:t>
+                        <a:t>10</a:t>
                       </a:r>
                       <a:endParaRPr lang="en-US" sz="1200" b="0" i="0" u="none" strike="noStrike" kern="1200" noProof="0" dirty="0">
                         <a:solidFill>
@@ -37139,7 +37286,7 @@
                           <a:solidFill>
                             <a:schemeClr val="tx1"/>
                           </a:solidFill>
-                          <a:hlinkClick r:id="rId5"/>
+                          <a:hlinkClick r:id="rId6"/>
                         </a:rPr>
                         <a:t>link</a:t>
                       </a:r>
@@ -37158,7 +37305,7 @@
                 </a:tc>
                 <a:extLst>
                   <a:ext uri="{0D108BD9-81ED-4DB2-BD59-A6C34878D82A}">
-                    <a16:rowId xmlns:a16="http://schemas.microsoft.com/office/drawing/2014/main" val="10004"/>
+                    <a16:rowId xmlns:a16="http://schemas.microsoft.com/office/drawing/2014/main" val="2001900654"/>
                   </a:ext>
                 </a:extLst>
               </a:tr>
@@ -37260,154 +37407,7 @@
                             <a:schemeClr val="tx1"/>
                           </a:solidFill>
                         </a:rPr>
-                        <a:t>2</a:t>
-                      </a:r>
-                      <a:endParaRPr lang="en-US" sz="1200" b="0" i="0" u="none" strike="noStrike" kern="1200" noProof="0" dirty="0">
-                        <a:solidFill>
-                          <a:schemeClr val="tx1"/>
-                        </a:solidFill>
-                        <a:effectLst/>
-                        <a:latin typeface="Calibri Bold"/>
-                        <a:ea typeface="+mn-ea"/>
-                        <a:cs typeface="+mn-cs"/>
-                      </a:endParaRPr>
-                    </a:p>
-                  </a:txBody>
-                  <a:tcPr marL="108000" marR="108000" marT="72000" marB="72000" anchor="ctr"/>
-                </a:tc>
-                <a:tc>
-                  <a:txBody>
-                    <a:bodyPr/>
-                    <a:lstStyle/>
-                    <a:p>
-                      <a:pPr marL="0" algn="ctr" defTabSz="914400" rtl="0" eaLnBrk="1" fontAlgn="b" latinLnBrk="0" hangingPunct="1"/>
-                      <a:r>
-                        <a:rPr b="0" sz="1200" u="none">
-                          <a:solidFill>
-                            <a:schemeClr val="tx1"/>
-                          </a:solidFill>
-                          <a:hlinkClick r:id="rId6"/>
-                        </a:rPr>
-                        <a:t>link</a:t>
-                      </a:r>
-                      <a:endParaRPr lang="en-US" sz="1200" b="0" i="0" u="none" strike="noStrike" kern="1200" noProof="0" dirty="0">
-                        <a:solidFill>
-                          <a:schemeClr val="tx1"/>
-                        </a:solidFill>
-                        <a:effectLst/>
-                        <a:latin typeface="Calibri Regular"/>
-                        <a:ea typeface="+mn-ea"/>
-                        <a:cs typeface="+mn-cs"/>
-                      </a:endParaRPr>
-                    </a:p>
-                  </a:txBody>
-                  <a:tcPr marL="108000" marR="108000" marT="72000" marB="72000" anchor="ctr"/>
-                </a:tc>
-                <a:extLst>
-                  <a:ext uri="{0D108BD9-81ED-4DB2-BD59-A6C34878D82A}">
-                    <a16:rowId xmlns:a16="http://schemas.microsoft.com/office/drawing/2014/main" val="2001900654"/>
-                  </a:ext>
-                </a:extLst>
-              </a:tr>
-              <a:tr h="279736">
-                <a:tc>
-                  <a:txBody>
-                    <a:bodyPr/>
-                    <a:lstStyle/>
-                    <a:p>
-                      <a:pPr algn="l" fontAlgn="b"/>
-                      <a:r>
-                        <a:rPr b="0" sz="1200" u="none">
-                          <a:solidFill>
-                            <a:schemeClr val="tx1"/>
-                          </a:solidFill>
-                        </a:rPr>
-                        <a:t>integrationtest-elasticsearch</a:t>
-                      </a:r>
-                      <a:endParaRPr lang="en-US" sz="1200" b="0" i="0" u="none" strike="noStrike" noProof="0" dirty="0">
-                        <a:solidFill>
-                          <a:schemeClr val="tx1"/>
-                        </a:solidFill>
-                        <a:effectLst/>
-                        <a:latin typeface="Calibri Regular"/>
-                      </a:endParaRPr>
-                    </a:p>
-                  </a:txBody>
-                  <a:tcPr marL="108000" marR="108000" marT="72000" marB="72000" anchor="ctr"/>
-                </a:tc>
-                <a:tc>
-                  <a:txBody>
-                    <a:bodyPr/>
-                    <a:lstStyle/>
-                    <a:p>
-                      <a:pPr marL="0" marR="0" lvl="0" indent="0" algn="ctr" defTabSz="914400" rtl="0" eaLnBrk="1" fontAlgn="b" latinLnBrk="0" hangingPunct="1">
-                        <a:lnSpc>
-                          <a:spcPct val="100000"/>
-                        </a:lnSpc>
-                        <a:spcBef>
-                          <a:spcPts val="0"/>
-                        </a:spcBef>
-                        <a:spcAft>
-                          <a:spcPts val="0"/>
-                        </a:spcAft>
-                        <a:buClrTx/>
-                        <a:buSzTx/>
-                        <a:buFontTx/>
-                        <a:buNone/>
-                        <a:tabLst/>
-                        <a:defRPr/>
-                      </a:pPr>
-                      <a:r>
-                        <a:rPr b="0" i="0" sz="1200" u="none">
-                          <a:solidFill>
-                            <a:schemeClr val="tx1"/>
-                          </a:solidFill>
-                          <a:latin typeface="Calibri Bold"/>
-                        </a:rPr>
-                        <a:t>72.7%</a:t>
-                      </a:r>
-                      <a:endParaRPr lang="en-US" sz="1200" b="0" i="0" u="none" strike="noStrike" kern="1200" noProof="0" dirty="0">
-                        <a:solidFill>
-                          <a:schemeClr val="tx1"/>
-                        </a:solidFill>
-                        <a:effectLst/>
-                        <a:latin typeface="Calibri Bold"/>
-                        <a:ea typeface="+mn-ea"/>
-                        <a:cs typeface="+mn-cs"/>
-                      </a:endParaRPr>
-                    </a:p>
-                  </a:txBody>
-                  <a:tcPr marL="108000" marR="108000" marT="72000" marB="72000" anchor="ctr"/>
-                </a:tc>
-                <a:tc>
-                  <a:txBody>
-                    <a:bodyPr/>
-                    <a:lstStyle/>
-                    <a:p>
-                      <a:pPr marL="0" marR="0" lvl="0" indent="0" algn="ctr" defTabSz="914400" rtl="0" eaLnBrk="1" fontAlgn="b" latinLnBrk="0" hangingPunct="1">
-                        <a:lnSpc>
-                          <a:spcPct val="100000"/>
-                        </a:lnSpc>
-                        <a:spcBef>
-                          <a:spcPts val="0"/>
-                        </a:spcBef>
-                        <a:spcAft>
-                          <a:spcPts val="0"/>
-                        </a:spcAft>
-                        <a:buClrTx/>
-                        <a:buSzTx/>
-                        <a:buFontTx/>
-                        <a:buNone/>
-                        <a:tabLst/>
-                        <a:defRPr/>
-                      </a:pPr>
-                      <a:r>
-                        <a:rPr b="0" sz="1200" u="none">
-                          <a:solidFill>
-                            <a:schemeClr val="tx1"/>
-                          </a:solidFill>
-                        </a:rPr>
-                        <a:t>1</a:t>
+                        <a:t>4</a:t>
                       </a:r>
                       <a:endParaRPr lang="en-US" sz="1200" b="0" i="0" u="none" strike="noStrike" kern="1200" noProof="0" dirty="0">
                         <a:solidFill>
@@ -37554,7 +37554,7 @@
                             <a:schemeClr val="tx1"/>
                           </a:solidFill>
                         </a:rPr>
-                        <a:t>1</a:t>
+                        <a:t>3</a:t>
                       </a:r>
                       <a:endParaRPr lang="en-US" sz="1200" b="0" i="0" u="none" strike="noStrike" kern="1200" noProof="0" dirty="0">
                         <a:solidFill>
@@ -37701,7 +37701,7 @@
                             <a:schemeClr val="tx1"/>
                           </a:solidFill>
                         </a:rPr>
-                        <a:t>0</a:t>
+                        <a:t>2</a:t>
                       </a:r>
                       <a:endParaRPr lang="en-US" sz="1200" b="0" i="0" u="none" strike="noStrike" kern="1200" noProof="0" dirty="0">
                         <a:solidFill>
@@ -37848,7 +37848,7 @@
                             <a:schemeClr val="tx1"/>
                           </a:solidFill>
                         </a:rPr>
-                        <a:t>0</a:t>
+                        <a:t>2</a:t>
                       </a:r>
                       <a:endParaRPr lang="en-US" sz="1200" b="0" i="0" u="none" strike="noStrike" kern="1200" noProof="0" dirty="0">
                         <a:solidFill>
@@ -37995,7 +37995,7 @@
                             <a:schemeClr val="tx1"/>
                           </a:solidFill>
                         </a:rPr>
-                        <a:t>0</a:t>
+                        <a:t>2</a:t>
                       </a:r>
                       <a:endParaRPr lang="en-US" sz="1200" b="0" i="0" u="none" strike="noStrike" kern="1200" noProof="0" dirty="0">
                         <a:solidFill>

</xml_diff>